<commit_message>
Add agenda, app and onboarding content to Zdanmotion deck
Co-Authored-By: Claude Opus 5.5 <noreply@anthropic.com>
Claude-Session: https://claude.ai/code/session_01QVCR3cV59zPQJ7dR5FS4zs
</commit_message>
<xml_diff>
--- a/zdanmotion-bygg-presentation-v2.pptx
+++ b/zdanmotion-bygg-presentation-v2.pptx
@@ -11,9 +11,10 @@
     <p:sldId id="259" r:id="rId5"/>
     <p:sldId id="260" r:id="rId6"/>
     <p:sldId id="261" r:id="rId7"/>
+    <p:sldId id="262" r:id="rId8"/>
   </p:sldIdLst>
   <p:notesMasterIdLst>
-    <p:notesMasterId r:id="rId8"/>
+    <p:notesMasterId r:id="rId9"/>
   </p:notesMasterIdLst>
   <p:sldSz cx="9144000" cy="5143500"/>
   <p:notesSz cx="5143500" cy="9144000"/>
@@ -112,30 +113,31 @@
   <p:extLst>
     <p:ext uri="{521415D9-36F7-43E2-AB2F-B90AF26B5E84}">
       <p14:sectionLst xmlns:p14="http://schemas.microsoft.com/office/powerpoint/2010/main">
-        <p14:section name="Intro" id="{c4622800-a4f5-a114-0c06-e6f340e33c91}">
+        <p14:section name="Intro" id="{c4891b48-c789-7068-132e-b7c98caa0d9f}">
           <p14:sldIdLst>
             <p14:sldId id="256"/>
           </p14:sldIdLst>
         </p14:section>
-        <p14:section name="Utmaningen" id="{7ab10bd9-b403-75f2-ec72-593498e6d118}">
+        <p14:section name="Agenda" id="{4d166943-0d28-e238-539a-316e2722fb56}">
           <p14:sldIdLst>
             <p14:sldId id="257"/>
           </p14:sldIdLst>
         </p14:section>
-        <p14:section name="Lösningen" id="{c2eded9c-cf73-575b-fe7f-75028c83789c}">
+        <p14:section name="Lösningen" id="{e1ab578a-ec34-8521-b2a1-106ebc5d939b}">
           <p14:sldIdLst>
             <p14:sldId id="258"/>
             <p14:sldId id="259"/>
-          </p14:sldIdLst>
-        </p14:section>
-        <p14:section name="Pris" id="{ecdcdcf0-a9ab-6836-09d6-338ab10acd4a}">
-          <p14:sldIdLst>
             <p14:sldId id="260"/>
           </p14:sldIdLst>
         </p14:section>
-        <p14:section name="Nästa steg" id="{fdbcb4d9-3b61-02c7-a454-f87f3700830a}">
+        <p14:section name="Pris" id="{cbdfc9ec-83c6-ce30-682b-727cae97a035}">
           <p14:sldIdLst>
             <p14:sldId id="261"/>
+          </p14:sldIdLst>
+        </p14:section>
+        <p14:section name="Nästa steg" id="{c4135fda-58f8-57a6-9f48-f8eebff91aa9}">
+          <p14:sldIdLst>
+            <p14:sldId id="262"/>
           </p14:sldIdLst>
         </p14:section>
       </p14:sectionLst>
@@ -630,7 +632,7 @@
           <a:p>
             <a:r>
               <a:rPr lang="en-US" dirty="0"/>
-              <a:t>Fråga: känner du igen dig i någon av de här? Låt kunden prata och använd svaren när du visar lösningen.</a:t>
+              <a:t>Gå igenom agendan: hur systemet fungerar, hur vi kvalificerar och bokar in hembesök i kalendern, appen och sedan investering. Koppla målen till det kunden sa i kartläggningen (fler jobb, kunna planera, slippa jaga). Säg tydligt att ni tar ett beslut i slutet av mötet – och att ett nej är helt okej.</a:t>
             </a:r>
             <a:endParaRPr lang="en-US" dirty="0"/>
           </a:p>
@@ -894,7 +896,7 @@
           <a:p>
             <a:r>
               <a:rPr lang="en-US" dirty="0"/>
-              <a:t>Vi tjänar mest när de tjänar mest. Annonsbudgeten går rakt till Meta och syns i deras eget annonskonto – full insyn. Byt gärna exempelsiffrorna mot kundens egna: hur många besök de klarar per månad och vad ett snittjobb ger.</a:t>
+              <a:t>Visa appen: alla hembesök i en kalender, SMS-notis när något bokas, chatt med leads via SMS och statistik över bokade besök. Fråga: är det du som går på hembesöken? Då är det du som får notiserna.</a:t>
             </a:r>
             <a:endParaRPr lang="en-US" dirty="0"/>
           </a:p>
@@ -982,7 +984,7 @@
           <a:p>
             <a:r>
               <a:rPr lang="en-US" dirty="0"/>
-              <a:t>Avsluta med en direkt fråga och var tyst. Föreslå två konkreta tider för uppstartsmötet.</a:t>
+              <a:t>Vi tjänar mest när de tjänar mest. Annonsbudgeten går rakt till Meta och syns i deras eget annonskonto – full insyn. Byt gärna exempelsiffrorna mot kundens egna: hur många besök de klarar per månad och vad ett snittjobb ger.</a:t>
             </a:r>
             <a:endParaRPr lang="en-US" dirty="0"/>
           </a:p>
@@ -1006,6 +1008,94 @@
             <a:fld id="{F7021451-1387-4CA6-816F-3879F97B5CBC}" type="slidenum">
               <a:rPr lang="en-US"/>
               <a:t>6</a:t>
+            </a:fld>
+            <a:endParaRPr lang="en-US"/>
+          </a:p>
+        </p:txBody>
+      </p:sp>
+    </p:spTree>
+    <p:extLst>
+      <p:ext uri="{BB962C8B-B14F-4D97-AF65-F5344CB8AC3E}">
+        <p14:creationId xmlns:p14="http://schemas.microsoft.com/office/powerpoint/2010/main" val="1024086991"/>
+      </p:ext>
+    </p:extLst>
+  </p:cSld>
+  <p:clrMapOvr>
+    <a:masterClrMapping/>
+  </p:clrMapOvr>
+</p:notes>
+</file>
+
+<file path=ppt/notesSlides/notesSlide7.xml><?xml version="1.0" encoding="utf-8"?>
+<p:notes xmlns:a="http://schemas.openxmlformats.org/drawingml/2006/main" xmlns:r="http://schemas.openxmlformats.org/officeDocument/2006/relationships" xmlns:p="http://schemas.openxmlformats.org/presentationml/2006/main">
+  <p:cSld>
+    <p:spTree>
+      <p:nvGrpSpPr>
+        <p:cNvPr id="1" name=""/>
+        <p:cNvGrpSpPr/>
+        <p:nvPr/>
+      </p:nvGrpSpPr>
+      <p:grpSpPr>
+        <a:xfrm>
+          <a:off x="0" y="0"/>
+          <a:ext cx="0" cy="0"/>
+          <a:chOff x="0" y="0"/>
+          <a:chExt cx="0" cy="0"/>
+        </a:xfrm>
+      </p:grpSpPr>
+      <p:sp>
+        <p:nvSpPr>
+          <p:cNvPr id="2" name="Slide Image Placeholder 1"/>
+          <p:cNvSpPr>
+            <a:spLocks noGrp="1" noRot="1" noChangeAspect="1"/>
+          </p:cNvSpPr>
+          <p:nvPr>
+            <p:ph type="sldImg"/>
+          </p:nvPr>
+        </p:nvSpPr>
+        <p:spPr/>
+      </p:sp>
+      <p:sp>
+        <p:nvSpPr>
+          <p:cNvPr id="3" name="Notes Placeholder 2"/>
+          <p:cNvSpPr>
+            <a:spLocks noGrp="1"/>
+          </p:cNvSpPr>
+          <p:nvPr>
+            <p:ph type="body" idx="1"/>
+          </p:nvPr>
+        </p:nvSpPr>
+        <p:spPr/>
+        <p:txBody>
+          <a:bodyPr/>
+          <a:lstStyle/>
+          <a:p>
+            <a:r>
+              <a:rPr lang="en-US" dirty="0"/>
+              <a:t>Fråga: Vad känner du? Hur vill du gå vidare härifrån? Var tyst och låt kunden svara. Vid ja: skicka avtalet för e-signering direkt under samtalet och be om bilder och filmer i en Google Drive-mapp.</a:t>
+            </a:r>
+            <a:endParaRPr lang="en-US" dirty="0"/>
+          </a:p>
+        </p:txBody>
+      </p:sp>
+      <p:sp>
+        <p:nvSpPr>
+          <p:cNvPr id="4" name="Slide Number Placeholder 3"/>
+          <p:cNvSpPr>
+            <a:spLocks noGrp="1"/>
+          </p:cNvSpPr>
+          <p:nvPr>
+            <p:ph type="sldNum" sz="quarter" idx="10"/>
+          </p:nvPr>
+        </p:nvSpPr>
+        <p:spPr/>
+        <p:txBody>
+          <a:bodyPr/>
+          <a:lstStyle/>
+          <a:p>
+            <a:fld id="{F7021451-1387-4CA6-816F-3879F97B5CBC}" type="slidenum">
+              <a:rPr lang="en-US"/>
+              <a:t>7</a:t>
             </a:fld>
             <a:endParaRPr lang="en-US"/>
           </a:p>
@@ -3307,7 +3397,7 @@
                   <a:schemeClr val="accent1"/>
                 </a:solidFill>
               </a:rPr>
-              <a:t>UTMANINGEN</a:t>
+              <a:t>DAGENS AGENDA</a:t>
             </a:r>
             <a:endParaRPr lang="en-US" sz="1100" dirty="0"/>
           </a:p>
@@ -3345,7 +3435,7 @@
                   <a:schemeClr val="tx1"/>
                 </a:solidFill>
               </a:rPr>
-              <a:t>Bra hantverk fyller inte kalendern</a:t>
+              <a:t>Det här går vi igenom idag</a:t>
             </a:r>
             <a:endParaRPr lang="en-US" sz="3000" dirty="0"/>
           </a:p>
@@ -3409,18 +3499,18 @@
       </p:sp>
       <p:sp>
         <p:nvSpPr>
-          <p:cNvPr id="6" name="Card 1"/>
-          <p:cNvSpPr/>
-          <p:nvPr/>
-        </p:nvSpPr>
-        <p:spPr>
-          <a:xfrm>
-            <a:off x="548640" y="1691640"/>
-            <a:ext cx="2560320" cy="2423160"/>
+          <p:cNvPr id="6" name="Agenda 1"/>
+          <p:cNvSpPr/>
+          <p:nvPr/>
+        </p:nvSpPr>
+        <p:spPr>
+          <a:xfrm>
+            <a:off x="548640" y="1600200"/>
+            <a:ext cx="4846320" cy="594360"/>
           </a:xfrm>
           <a:prstGeom prst="roundRect">
             <a:avLst>
-              <a:gd name="adj" fmla="val 4528"/>
+              <a:gd name="adj" fmla="val 15385"/>
             </a:avLst>
           </a:prstGeom>
           <a:solidFill>
@@ -3443,27 +3533,63 @@
       </p:sp>
       <p:sp>
         <p:nvSpPr>
-          <p:cNvPr id="7" name="Problem 1 circle"/>
-          <p:cNvSpPr/>
-          <p:nvPr/>
-        </p:nvSpPr>
-        <p:spPr>
-          <a:xfrm>
-            <a:off x="822960" y="1965960"/>
-            <a:ext cx="548640" cy="548640"/>
+          <p:cNvPr id="7" name="Text 5"/>
+          <p:cNvSpPr txBox="1"/>
+          <p:nvPr/>
+        </p:nvSpPr>
+        <p:spPr>
+          <a:xfrm>
+            <a:off x="713232" y="1600200"/>
+            <a:ext cx="411480" cy="594360"/>
+          </a:xfrm>
+          <a:prstGeom prst="rect">
+            <a:avLst/>
+          </a:prstGeom>
+          <a:noFill/>
+          <a:ln/>
+        </p:spPr>
+        <p:txBody>
+          <a:bodyPr wrap="square" lIns="0" tIns="0" rIns="0" bIns="0" rtlCol="0" anchor="ctr"/>
+          <a:lstStyle/>
+          <a:p>
+            <a:pPr indent="0" marL="0">
+              <a:buNone/>
+            </a:pPr>
+            <a:r>
+              <a:rPr lang="en-US" sz="1800" b="1" dirty="0">
+                <a:solidFill>
+                  <a:schemeClr val="accent1"/>
+                </a:solidFill>
+              </a:rPr>
+              <a:t>01</a:t>
+            </a:r>
+            <a:endParaRPr lang="en-US" sz="1800" dirty="0"/>
+          </a:p>
+        </p:txBody>
+      </p:sp>
+      <p:sp>
+        <p:nvSpPr>
+          <p:cNvPr id="8" name="Agenda icon 1 circle"/>
+          <p:cNvSpPr/>
+          <p:nvPr/>
+        </p:nvSpPr>
+        <p:spPr>
+          <a:xfrm>
+            <a:off x="1143000" y="1700784"/>
+            <a:ext cx="393192" cy="393192"/>
           </a:xfrm>
           <a:prstGeom prst="ellipse">
             <a:avLst/>
           </a:prstGeom>
           <a:solidFill>
-            <a:schemeClr val="accent1"/>
+            <a:schemeClr val="tx1"/>
           </a:solidFill>
           <a:ln/>
         </p:spPr>
       </p:sp>
       <p:pic>
         <p:nvPicPr>
-          <p:cNvPr id="8" name="Problem 1 icon" descr="preencoded.png">    </p:cNvPr>
+          <p:cNvPr id="9" name="Agenda icon 1 icon" descr="preencoded.png">    </p:cNvPr>
           <p:cNvPicPr>
             <a:picLocks noChangeAspect="1"/>
           </p:cNvPicPr>
@@ -3477,50 +3603,14 @@
         </p:blipFill>
         <p:spPr>
           <a:xfrm>
-            <a:off x="960120" y="2103120"/>
-            <a:ext cx="274320" cy="274320"/>
+            <a:off x="1241298" y="1799082"/>
+            <a:ext cx="196596" cy="196596"/>
           </a:xfrm>
           <a:prstGeom prst="rect">
             <a:avLst/>
           </a:prstGeom>
         </p:spPr>
       </p:pic>
-      <p:sp>
-        <p:nvSpPr>
-          <p:cNvPr id="9" name="Text 6"/>
-          <p:cNvSpPr txBox="1"/>
-          <p:nvPr/>
-        </p:nvSpPr>
-        <p:spPr>
-          <a:xfrm>
-            <a:off x="822960" y="2697480"/>
-            <a:ext cx="2057400" cy="365760"/>
-          </a:xfrm>
-          <a:prstGeom prst="rect">
-            <a:avLst/>
-          </a:prstGeom>
-          <a:noFill/>
-          <a:ln/>
-        </p:spPr>
-        <p:txBody>
-          <a:bodyPr wrap="square" lIns="0" tIns="0" rIns="0" bIns="0" rtlCol="0" anchor="t"/>
-          <a:lstStyle/>
-          <a:p>
-            <a:pPr indent="0" marL="0">
-              <a:buNone/>
-            </a:pPr>
-            <a:r>
-              <a:rPr lang="en-US" sz="1700" b="1" dirty="0">
-                <a:solidFill>
-                  <a:schemeClr val="tx1"/>
-                </a:solidFill>
-              </a:rPr>
-              <a:t>Beroende av tips</a:t>
-            </a:r>
-            <a:endParaRPr lang="en-US" sz="1700" dirty="0"/>
-          </a:p>
-        </p:txBody>
-      </p:sp>
       <p:sp>
         <p:nvSpPr>
           <p:cNvPr id="10" name="Text 7"/>
@@ -3529,48 +3619,62 @@
         </p:nvSpPr>
         <p:spPr>
           <a:xfrm>
-            <a:off x="822960" y="3108960"/>
-            <a:ext cx="2057400" cy="1051560"/>
-          </a:xfrm>
-          <a:prstGeom prst="rect">
-            <a:avLst/>
-          </a:prstGeom>
-          <a:noFill/>
-          <a:ln/>
-        </p:spPr>
-        <p:txBody>
-          <a:bodyPr wrap="square" lIns="0" tIns="0" rIns="0" bIns="0" rtlCol="0" anchor="t"/>
+            <a:off x="1691640" y="1600200"/>
+            <a:ext cx="3611880" cy="594360"/>
+          </a:xfrm>
+          <a:prstGeom prst="rect">
+            <a:avLst/>
+          </a:prstGeom>
+          <a:noFill/>
+          <a:ln/>
+        </p:spPr>
+        <p:txBody>
+          <a:bodyPr wrap="square" lIns="0" tIns="0" rIns="0" bIns="0" rtlCol="0" anchor="ctr"/>
           <a:lstStyle/>
           <a:p>
             <a:pPr indent="0" marL="0">
               <a:buNone/>
             </a:pPr>
             <a:r>
-              <a:rPr lang="en-US" sz="1400" dirty="0">
+              <a:rPr lang="en-US" sz="1500" b="1" dirty="0">
+                <a:solidFill>
+                  <a:schemeClr val="tx1"/>
+                </a:solidFill>
+              </a:rPr>
+              <a:t>Så fungerar systemet</a:t>
+            </a:r>
+            <a:endParaRPr lang="en-US" sz="1500" dirty="0"/>
+          </a:p>
+          <a:p>
+            <a:pPr indent="0" marL="0">
+              <a:buNone/>
+            </a:pPr>
+            <a:r>
+              <a:rPr lang="en-US" sz="1200" dirty="0">
                 <a:solidFill>
                   <a:schemeClr val="accent6"/>
                 </a:solidFill>
               </a:rPr>
-              <a:t>Jobben kommer när någon rekommenderar er – och uteblir när ingen gör det.</a:t>
-            </a:r>
-            <a:endParaRPr lang="en-US" sz="1400" dirty="0"/>
-          </a:p>
-        </p:txBody>
-      </p:sp>
-      <p:sp>
-        <p:nvSpPr>
-          <p:cNvPr id="11" name="Card 2"/>
-          <p:cNvSpPr/>
-          <p:nvPr/>
-        </p:nvSpPr>
-        <p:spPr>
-          <a:xfrm>
-            <a:off x="3291840" y="1691640"/>
-            <a:ext cx="2560320" cy="2423160"/>
+              <a:t>Videoannonser via Meta till husägare i ert område.</a:t>
+            </a:r>
+            <a:endParaRPr lang="en-US" sz="1500" dirty="0"/>
+          </a:p>
+        </p:txBody>
+      </p:sp>
+      <p:sp>
+        <p:nvSpPr>
+          <p:cNvPr id="11" name="Agenda 2"/>
+          <p:cNvSpPr/>
+          <p:nvPr/>
+        </p:nvSpPr>
+        <p:spPr>
+          <a:xfrm>
+            <a:off x="548640" y="2331720"/>
+            <a:ext cx="4846320" cy="594360"/>
           </a:xfrm>
           <a:prstGeom prst="roundRect">
             <a:avLst>
-              <a:gd name="adj" fmla="val 4528"/>
+              <a:gd name="adj" fmla="val 15385"/>
             </a:avLst>
           </a:prstGeom>
           <a:solidFill>
@@ -3593,27 +3697,63 @@
       </p:sp>
       <p:sp>
         <p:nvSpPr>
-          <p:cNvPr id="12" name="Problem 2 circle"/>
-          <p:cNvSpPr/>
-          <p:nvPr/>
-        </p:nvSpPr>
-        <p:spPr>
-          <a:xfrm>
-            <a:off x="3566160" y="1965960"/>
-            <a:ext cx="548640" cy="548640"/>
+          <p:cNvPr id="12" name="Text 9"/>
+          <p:cNvSpPr txBox="1"/>
+          <p:nvPr/>
+        </p:nvSpPr>
+        <p:spPr>
+          <a:xfrm>
+            <a:off x="713232" y="2331720"/>
+            <a:ext cx="411480" cy="594360"/>
+          </a:xfrm>
+          <a:prstGeom prst="rect">
+            <a:avLst/>
+          </a:prstGeom>
+          <a:noFill/>
+          <a:ln/>
+        </p:spPr>
+        <p:txBody>
+          <a:bodyPr wrap="square" lIns="0" tIns="0" rIns="0" bIns="0" rtlCol="0" anchor="ctr"/>
+          <a:lstStyle/>
+          <a:p>
+            <a:pPr indent="0" marL="0">
+              <a:buNone/>
+            </a:pPr>
+            <a:r>
+              <a:rPr lang="en-US" sz="1800" b="1" dirty="0">
+                <a:solidFill>
+                  <a:schemeClr val="accent1"/>
+                </a:solidFill>
+              </a:rPr>
+              <a:t>02</a:t>
+            </a:r>
+            <a:endParaRPr lang="en-US" sz="1800" dirty="0"/>
+          </a:p>
+        </p:txBody>
+      </p:sp>
+      <p:sp>
+        <p:nvSpPr>
+          <p:cNvPr id="13" name="Agenda icon 2 circle"/>
+          <p:cNvSpPr/>
+          <p:nvPr/>
+        </p:nvSpPr>
+        <p:spPr>
+          <a:xfrm>
+            <a:off x="1143000" y="2432304"/>
+            <a:ext cx="393192" cy="393192"/>
           </a:xfrm>
           <a:prstGeom prst="ellipse">
             <a:avLst/>
           </a:prstGeom>
           <a:solidFill>
-            <a:schemeClr val="accent1"/>
+            <a:schemeClr val="tx1"/>
           </a:solidFill>
           <a:ln/>
         </p:spPr>
       </p:sp>
       <p:pic>
         <p:nvPicPr>
-          <p:cNvPr id="13" name="Problem 2 icon" descr="preencoded.png">    </p:cNvPr>
+          <p:cNvPr id="14" name="Agenda icon 2 icon" descr="preencoded.png">    </p:cNvPr>
           <p:cNvPicPr>
             <a:picLocks noChangeAspect="1"/>
           </p:cNvPicPr>
@@ -3627,50 +3767,14 @@
         </p:blipFill>
         <p:spPr>
           <a:xfrm>
-            <a:off x="3703320" y="2103120"/>
-            <a:ext cx="274320" cy="274320"/>
+            <a:off x="1241298" y="2530602"/>
+            <a:ext cx="196596" cy="196596"/>
           </a:xfrm>
           <a:prstGeom prst="rect">
             <a:avLst/>
           </a:prstGeom>
         </p:spPr>
       </p:pic>
-      <p:sp>
-        <p:nvSpPr>
-          <p:cNvPr id="14" name="Text 10"/>
-          <p:cNvSpPr txBox="1"/>
-          <p:nvPr/>
-        </p:nvSpPr>
-        <p:spPr>
-          <a:xfrm>
-            <a:off x="3566160" y="2697480"/>
-            <a:ext cx="2057400" cy="365760"/>
-          </a:xfrm>
-          <a:prstGeom prst="rect">
-            <a:avLst/>
-          </a:prstGeom>
-          <a:noFill/>
-          <a:ln/>
-        </p:spPr>
-        <p:txBody>
-          <a:bodyPr wrap="square" lIns="0" tIns="0" rIns="0" bIns="0" rtlCol="0" anchor="t"/>
-          <a:lstStyle/>
-          <a:p>
-            <a:pPr indent="0" marL="0">
-              <a:buNone/>
-            </a:pPr>
-            <a:r>
-              <a:rPr lang="en-US" sz="1700" b="1" dirty="0">
-                <a:solidFill>
-                  <a:schemeClr val="tx1"/>
-                </a:solidFill>
-              </a:rPr>
-              <a:t>Ojämnt orderflöde</a:t>
-            </a:r>
-            <a:endParaRPr lang="en-US" sz="1700" dirty="0"/>
-          </a:p>
-        </p:txBody>
-      </p:sp>
       <p:sp>
         <p:nvSpPr>
           <p:cNvPr id="15" name="Text 11"/>
@@ -3679,48 +3783,62 @@
         </p:nvSpPr>
         <p:spPr>
           <a:xfrm>
-            <a:off x="3566160" y="3108960"/>
-            <a:ext cx="2057400" cy="1051560"/>
-          </a:xfrm>
-          <a:prstGeom prst="rect">
-            <a:avLst/>
-          </a:prstGeom>
-          <a:noFill/>
-          <a:ln/>
-        </p:spPr>
-        <p:txBody>
-          <a:bodyPr wrap="square" lIns="0" tIns="0" rIns="0" bIns="0" rtlCol="0" anchor="t"/>
+            <a:off x="1691640" y="2331720"/>
+            <a:ext cx="3611880" cy="594360"/>
+          </a:xfrm>
+          <a:prstGeom prst="rect">
+            <a:avLst/>
+          </a:prstGeom>
+          <a:noFill/>
+          <a:ln/>
+        </p:spPr>
+        <p:txBody>
+          <a:bodyPr wrap="square" lIns="0" tIns="0" rIns="0" bIns="0" rtlCol="0" anchor="ctr"/>
           <a:lstStyle/>
           <a:p>
             <a:pPr indent="0" marL="0">
               <a:buNone/>
             </a:pPr>
             <a:r>
-              <a:rPr lang="en-US" sz="1400" dirty="0">
+              <a:rPr lang="en-US" sz="1500" b="1" dirty="0">
+                <a:solidFill>
+                  <a:schemeClr val="tx1"/>
+                </a:solidFill>
+              </a:rPr>
+              <a:t>Kvalificering och bokning</a:t>
+            </a:r>
+            <a:endParaRPr lang="en-US" sz="1500" dirty="0"/>
+          </a:p>
+          <a:p>
+            <a:pPr indent="0" marL="0">
+              <a:buNone/>
+            </a:pPr>
+            <a:r>
+              <a:rPr lang="en-US" sz="1200" dirty="0">
                 <a:solidFill>
                   <a:schemeClr val="accent6"/>
                 </a:solidFill>
               </a:rPr>
-              <a:t>Fullt ena månaden, tomt nästa. Svårt att planera folk och material.</a:t>
-            </a:r>
-            <a:endParaRPr lang="en-US" sz="1400" dirty="0"/>
-          </a:p>
-        </p:txBody>
-      </p:sp>
-      <p:sp>
-        <p:nvSpPr>
-          <p:cNvPr id="16" name="Card 3"/>
-          <p:cNvSpPr/>
-          <p:nvPr/>
-        </p:nvSpPr>
-        <p:spPr>
-          <a:xfrm>
-            <a:off x="6035040" y="1691640"/>
-            <a:ext cx="2560320" cy="2423160"/>
+              <a:t>Hur vi bokar hembesök direkt i din kalender.</a:t>
+            </a:r>
+            <a:endParaRPr lang="en-US" sz="1500" dirty="0"/>
+          </a:p>
+        </p:txBody>
+      </p:sp>
+      <p:sp>
+        <p:nvSpPr>
+          <p:cNvPr id="16" name="Agenda 3"/>
+          <p:cNvSpPr/>
+          <p:nvPr/>
+        </p:nvSpPr>
+        <p:spPr>
+          <a:xfrm>
+            <a:off x="548640" y="3063240"/>
+            <a:ext cx="4846320" cy="594360"/>
           </a:xfrm>
           <a:prstGeom prst="roundRect">
             <a:avLst>
-              <a:gd name="adj" fmla="val 4528"/>
+              <a:gd name="adj" fmla="val 15385"/>
             </a:avLst>
           </a:prstGeom>
           <a:solidFill>
@@ -3743,27 +3861,63 @@
       </p:sp>
       <p:sp>
         <p:nvSpPr>
-          <p:cNvPr id="17" name="Problem 3 circle"/>
-          <p:cNvSpPr/>
-          <p:nvPr/>
-        </p:nvSpPr>
-        <p:spPr>
-          <a:xfrm>
-            <a:off x="6309360" y="1965960"/>
-            <a:ext cx="548640" cy="548640"/>
+          <p:cNvPr id="17" name="Text 13"/>
+          <p:cNvSpPr txBox="1"/>
+          <p:nvPr/>
+        </p:nvSpPr>
+        <p:spPr>
+          <a:xfrm>
+            <a:off x="713232" y="3063240"/>
+            <a:ext cx="411480" cy="594360"/>
+          </a:xfrm>
+          <a:prstGeom prst="rect">
+            <a:avLst/>
+          </a:prstGeom>
+          <a:noFill/>
+          <a:ln/>
+        </p:spPr>
+        <p:txBody>
+          <a:bodyPr wrap="square" lIns="0" tIns="0" rIns="0" bIns="0" rtlCol="0" anchor="ctr"/>
+          <a:lstStyle/>
+          <a:p>
+            <a:pPr indent="0" marL="0">
+              <a:buNone/>
+            </a:pPr>
+            <a:r>
+              <a:rPr lang="en-US" sz="1800" b="1" dirty="0">
+                <a:solidFill>
+                  <a:schemeClr val="accent1"/>
+                </a:solidFill>
+              </a:rPr>
+              <a:t>03</a:t>
+            </a:r>
+            <a:endParaRPr lang="en-US" sz="1800" dirty="0"/>
+          </a:p>
+        </p:txBody>
+      </p:sp>
+      <p:sp>
+        <p:nvSpPr>
+          <p:cNvPr id="18" name="Agenda icon 3 circle"/>
+          <p:cNvSpPr/>
+          <p:nvPr/>
+        </p:nvSpPr>
+        <p:spPr>
+          <a:xfrm>
+            <a:off x="1143000" y="3163824"/>
+            <a:ext cx="393192" cy="393192"/>
           </a:xfrm>
           <a:prstGeom prst="ellipse">
             <a:avLst/>
           </a:prstGeom>
           <a:solidFill>
-            <a:schemeClr val="accent1"/>
+            <a:schemeClr val="tx1"/>
           </a:solidFill>
           <a:ln/>
         </p:spPr>
       </p:sp>
       <p:pic>
         <p:nvPicPr>
-          <p:cNvPr id="18" name="Problem 3 icon" descr="preencoded.png">    </p:cNvPr>
+          <p:cNvPr id="19" name="Agenda icon 3 icon" descr="preencoded.png">    </p:cNvPr>
           <p:cNvPicPr>
             <a:picLocks noChangeAspect="1"/>
           </p:cNvPicPr>
@@ -3777,50 +3931,14 @@
         </p:blipFill>
         <p:spPr>
           <a:xfrm>
-            <a:off x="6446520" y="2103120"/>
-            <a:ext cx="274320" cy="274320"/>
+            <a:off x="1241298" y="3262122"/>
+            <a:ext cx="196596" cy="196596"/>
           </a:xfrm>
           <a:prstGeom prst="rect">
             <a:avLst/>
           </a:prstGeom>
         </p:spPr>
       </p:pic>
-      <p:sp>
-        <p:nvSpPr>
-          <p:cNvPr id="19" name="Text 14"/>
-          <p:cNvSpPr txBox="1"/>
-          <p:nvPr/>
-        </p:nvSpPr>
-        <p:spPr>
-          <a:xfrm>
-            <a:off x="6309360" y="2697480"/>
-            <a:ext cx="2057400" cy="365760"/>
-          </a:xfrm>
-          <a:prstGeom prst="rect">
-            <a:avLst/>
-          </a:prstGeom>
-          <a:noFill/>
-          <a:ln/>
-        </p:spPr>
-        <p:txBody>
-          <a:bodyPr wrap="square" lIns="0" tIns="0" rIns="0" bIns="0" rtlCol="0" anchor="t"/>
-          <a:lstStyle/>
-          <a:p>
-            <a:pPr indent="0" marL="0">
-              <a:buNone/>
-            </a:pPr>
-            <a:r>
-              <a:rPr lang="en-US" sz="1700" b="1" dirty="0">
-                <a:solidFill>
-                  <a:schemeClr val="tx1"/>
-                </a:solidFill>
-              </a:rPr>
-              <a:t>Fel förfrågningar</a:t>
-            </a:r>
-            <a:endParaRPr lang="en-US" sz="1700" dirty="0"/>
-          </a:p>
-        </p:txBody>
-      </p:sp>
       <p:sp>
         <p:nvSpPr>
           <p:cNvPr id="20" name="Text 15"/>
@@ -3829,8 +3947,460 @@
         </p:nvSpPr>
         <p:spPr>
           <a:xfrm>
-            <a:off x="6309360" y="3108960"/>
-            <a:ext cx="2057400" cy="1051560"/>
+            <a:off x="1691640" y="3063240"/>
+            <a:ext cx="3611880" cy="594360"/>
+          </a:xfrm>
+          <a:prstGeom prst="rect">
+            <a:avLst/>
+          </a:prstGeom>
+          <a:noFill/>
+          <a:ln/>
+        </p:spPr>
+        <p:txBody>
+          <a:bodyPr wrap="square" lIns="0" tIns="0" rIns="0" bIns="0" rtlCol="0" anchor="ctr"/>
+          <a:lstStyle/>
+          <a:p>
+            <a:pPr indent="0" marL="0">
+              <a:buNone/>
+            </a:pPr>
+            <a:r>
+              <a:rPr lang="en-US" sz="1500" b="1" dirty="0">
+                <a:solidFill>
+                  <a:schemeClr val="tx1"/>
+                </a:solidFill>
+              </a:rPr>
+              <a:t>Appen</a:t>
+            </a:r>
+            <a:endParaRPr lang="en-US" sz="1500" dirty="0"/>
+          </a:p>
+          <a:p>
+            <a:pPr indent="0" marL="0">
+              <a:buNone/>
+            </a:pPr>
+            <a:r>
+              <a:rPr lang="en-US" sz="1200" dirty="0">
+                <a:solidFill>
+                  <a:schemeClr val="accent6"/>
+                </a:solidFill>
+              </a:rPr>
+              <a:t>Hembesök, notiser och leads på ett ställe.</a:t>
+            </a:r>
+            <a:endParaRPr lang="en-US" sz="1500" dirty="0"/>
+          </a:p>
+        </p:txBody>
+      </p:sp>
+      <p:sp>
+        <p:nvSpPr>
+          <p:cNvPr id="21" name="Agenda 4"/>
+          <p:cNvSpPr/>
+          <p:nvPr/>
+        </p:nvSpPr>
+        <p:spPr>
+          <a:xfrm>
+            <a:off x="548640" y="3794760"/>
+            <a:ext cx="4846320" cy="594360"/>
+          </a:xfrm>
+          <a:prstGeom prst="roundRect">
+            <a:avLst>
+              <a:gd name="adj" fmla="val 15385"/>
+            </a:avLst>
+          </a:prstGeom>
+          <a:solidFill>
+            <a:schemeClr val="bg1"/>
+          </a:solidFill>
+          <a:ln w="12700">
+            <a:solidFill>
+              <a:schemeClr val="accent5"/>
+            </a:solidFill>
+            <a:prstDash val="solid"/>
+          </a:ln>
+          <a:effectLst>
+            <a:outerShdw sx="100000" sy="100000" kx="0" ky="0" algn="bl" rotWithShape="0" blurRad="101600" dist="25400" dir="5400000">
+              <a:srgbClr val="000000">
+                <a:alpha val="12000"/>
+              </a:srgbClr>
+            </a:outerShdw>
+          </a:effectLst>
+        </p:spPr>
+      </p:sp>
+      <p:sp>
+        <p:nvSpPr>
+          <p:cNvPr id="22" name="Text 17"/>
+          <p:cNvSpPr txBox="1"/>
+          <p:nvPr/>
+        </p:nvSpPr>
+        <p:spPr>
+          <a:xfrm>
+            <a:off x="713232" y="3794760"/>
+            <a:ext cx="411480" cy="594360"/>
+          </a:xfrm>
+          <a:prstGeom prst="rect">
+            <a:avLst/>
+          </a:prstGeom>
+          <a:noFill/>
+          <a:ln/>
+        </p:spPr>
+        <p:txBody>
+          <a:bodyPr wrap="square" lIns="0" tIns="0" rIns="0" bIns="0" rtlCol="0" anchor="ctr"/>
+          <a:lstStyle/>
+          <a:p>
+            <a:pPr indent="0" marL="0">
+              <a:buNone/>
+            </a:pPr>
+            <a:r>
+              <a:rPr lang="en-US" sz="1800" b="1" dirty="0">
+                <a:solidFill>
+                  <a:schemeClr val="accent1"/>
+                </a:solidFill>
+              </a:rPr>
+              <a:t>04</a:t>
+            </a:r>
+            <a:endParaRPr lang="en-US" sz="1800" dirty="0"/>
+          </a:p>
+        </p:txBody>
+      </p:sp>
+      <p:sp>
+        <p:nvSpPr>
+          <p:cNvPr id="23" name="Agenda icon 4 circle"/>
+          <p:cNvSpPr/>
+          <p:nvPr/>
+        </p:nvSpPr>
+        <p:spPr>
+          <a:xfrm>
+            <a:off x="1143000" y="3895344"/>
+            <a:ext cx="393192" cy="393192"/>
+          </a:xfrm>
+          <a:prstGeom prst="ellipse">
+            <a:avLst/>
+          </a:prstGeom>
+          <a:solidFill>
+            <a:schemeClr val="tx1"/>
+          </a:solidFill>
+          <a:ln/>
+        </p:spPr>
+      </p:sp>
+      <p:pic>
+        <p:nvPicPr>
+          <p:cNvPr id="24" name="Agenda icon 4 icon" descr="preencoded.png">    </p:cNvPr>
+          <p:cNvPicPr>
+            <a:picLocks noChangeAspect="1"/>
+          </p:cNvPicPr>
+          <p:nvPr/>
+        </p:nvPicPr>
+        <p:blipFill>
+          <a:blip r:embed="rId4"/>
+          <a:stretch>
+            <a:fillRect/>
+          </a:stretch>
+        </p:blipFill>
+        <p:spPr>
+          <a:xfrm>
+            <a:off x="1241298" y="3993642"/>
+            <a:ext cx="196596" cy="196596"/>
+          </a:xfrm>
+          <a:prstGeom prst="rect">
+            <a:avLst/>
+          </a:prstGeom>
+        </p:spPr>
+      </p:pic>
+      <p:sp>
+        <p:nvSpPr>
+          <p:cNvPr id="25" name="Text 19"/>
+          <p:cNvSpPr txBox="1"/>
+          <p:nvPr/>
+        </p:nvSpPr>
+        <p:spPr>
+          <a:xfrm>
+            <a:off x="1691640" y="3794760"/>
+            <a:ext cx="3611880" cy="594360"/>
+          </a:xfrm>
+          <a:prstGeom prst="rect">
+            <a:avLst/>
+          </a:prstGeom>
+          <a:noFill/>
+          <a:ln/>
+        </p:spPr>
+        <p:txBody>
+          <a:bodyPr wrap="square" lIns="0" tIns="0" rIns="0" bIns="0" rtlCol="0" anchor="ctr"/>
+          <a:lstStyle/>
+          <a:p>
+            <a:pPr indent="0" marL="0">
+              <a:buNone/>
+            </a:pPr>
+            <a:r>
+              <a:rPr lang="en-US" sz="1500" b="1" dirty="0">
+                <a:solidFill>
+                  <a:schemeClr val="tx1"/>
+                </a:solidFill>
+              </a:rPr>
+              <a:t>Investering och nästa steg</a:t>
+            </a:r>
+            <a:endParaRPr lang="en-US" sz="1500" dirty="0"/>
+          </a:p>
+          <a:p>
+            <a:pPr indent="0" marL="0">
+              <a:buNone/>
+            </a:pPr>
+            <a:r>
+              <a:rPr lang="en-US" sz="1200" dirty="0">
+                <a:solidFill>
+                  <a:schemeClr val="accent6"/>
+                </a:solidFill>
+              </a:rPr>
+              <a:t>Vi bestämmer tillsammans om vi kör.</a:t>
+            </a:r>
+            <a:endParaRPr lang="en-US" sz="1500" dirty="0"/>
+          </a:p>
+        </p:txBody>
+      </p:sp>
+      <p:sp>
+        <p:nvSpPr>
+          <p:cNvPr id="26" name="Goal card"/>
+          <p:cNvSpPr/>
+          <p:nvPr/>
+        </p:nvSpPr>
+        <p:spPr>
+          <a:xfrm>
+            <a:off x="5760720" y="1600200"/>
+            <a:ext cx="2834640" cy="2788920"/>
+          </a:xfrm>
+          <a:prstGeom prst="roundRect">
+            <a:avLst>
+              <a:gd name="adj" fmla="val 3934"/>
+            </a:avLst>
+          </a:prstGeom>
+          <a:solidFill>
+            <a:schemeClr val="tx1"/>
+          </a:solidFill>
+          <a:ln/>
+        </p:spPr>
+      </p:sp>
+      <p:sp>
+        <p:nvSpPr>
+          <p:cNvPr id="27" name="Text 21"/>
+          <p:cNvSpPr txBox="1"/>
+          <p:nvPr/>
+        </p:nvSpPr>
+        <p:spPr>
+          <a:xfrm>
+            <a:off x="5989320" y="1783080"/>
+            <a:ext cx="2377440" cy="228600"/>
+          </a:xfrm>
+          <a:prstGeom prst="rect">
+            <a:avLst/>
+          </a:prstGeom>
+          <a:noFill/>
+          <a:ln/>
+        </p:spPr>
+        <p:txBody>
+          <a:bodyPr wrap="square" lIns="0" tIns="0" rIns="0" bIns="0" rtlCol="0" anchor="ctr"/>
+          <a:lstStyle/>
+          <a:p>
+            <a:pPr indent="0" marL="0">
+              <a:buNone/>
+            </a:pPr>
+            <a:r>
+              <a:rPr lang="en-US" sz="1000" b="1" spc="300" kern="0" dirty="0">
+                <a:solidFill>
+                  <a:schemeClr val="accent1"/>
+                </a:solidFill>
+              </a:rPr>
+              <a:t>MÅLET</a:t>
+            </a:r>
+            <a:endParaRPr lang="en-US" sz="1000" dirty="0"/>
+          </a:p>
+        </p:txBody>
+      </p:sp>
+      <p:pic>
+        <p:nvPicPr>
+          <p:cNvPr id="28" name="Image 4" descr="preencoded.png">    </p:cNvPr>
+          <p:cNvPicPr>
+            <a:picLocks noChangeAspect="1"/>
+          </p:cNvPicPr>
+          <p:nvPr/>
+        </p:nvPicPr>
+        <p:blipFill>
+          <a:blip r:embed="rId5"/>
+          <a:stretch>
+            <a:fillRect/>
+          </a:stretch>
+        </p:blipFill>
+        <p:spPr>
+          <a:xfrm>
+            <a:off x="5989320" y="2258568"/>
+            <a:ext cx="256032" cy="256032"/>
+          </a:xfrm>
+          <a:prstGeom prst="rect">
+            <a:avLst/>
+          </a:prstGeom>
+        </p:spPr>
+      </p:pic>
+      <p:sp>
+        <p:nvSpPr>
+          <p:cNvPr id="29" name="Text 22"/>
+          <p:cNvSpPr txBox="1"/>
+          <p:nvPr/>
+        </p:nvSpPr>
+        <p:spPr>
+          <a:xfrm>
+            <a:off x="6382512" y="2194560"/>
+            <a:ext cx="2103120" cy="384048"/>
+          </a:xfrm>
+          <a:prstGeom prst="rect">
+            <a:avLst/>
+          </a:prstGeom>
+          <a:noFill/>
+          <a:ln/>
+        </p:spPr>
+        <p:txBody>
+          <a:bodyPr wrap="square" lIns="0" tIns="0" rIns="0" bIns="0" rtlCol="0" anchor="ctr"/>
+          <a:lstStyle/>
+          <a:p>
+            <a:pPr indent="0" marL="0">
+              <a:buNone/>
+            </a:pPr>
+            <a:r>
+              <a:rPr lang="en-US" sz="1400" b="1" dirty="0">
+                <a:solidFill>
+                  <a:schemeClr val="bg1"/>
+                </a:solidFill>
+              </a:rPr>
+              <a:t>Fler hembesök varje månad</a:t>
+            </a:r>
+            <a:endParaRPr lang="en-US" sz="1400" dirty="0"/>
+          </a:p>
+        </p:txBody>
+      </p:sp>
+      <p:pic>
+        <p:nvPicPr>
+          <p:cNvPr id="30" name="Image 5" descr="preencoded.png">    </p:cNvPr>
+          <p:cNvPicPr>
+            <a:picLocks noChangeAspect="1"/>
+          </p:cNvPicPr>
+          <p:nvPr/>
+        </p:nvPicPr>
+        <p:blipFill>
+          <a:blip r:embed="rId6"/>
+          <a:stretch>
+            <a:fillRect/>
+          </a:stretch>
+        </p:blipFill>
+        <p:spPr>
+          <a:xfrm>
+            <a:off x="5989320" y="2807208"/>
+            <a:ext cx="256032" cy="256032"/>
+          </a:xfrm>
+          <a:prstGeom prst="rect">
+            <a:avLst/>
+          </a:prstGeom>
+        </p:spPr>
+      </p:pic>
+      <p:sp>
+        <p:nvSpPr>
+          <p:cNvPr id="31" name="Text 23"/>
+          <p:cNvSpPr txBox="1"/>
+          <p:nvPr/>
+        </p:nvSpPr>
+        <p:spPr>
+          <a:xfrm>
+            <a:off x="6382512" y="2743200"/>
+            <a:ext cx="2103120" cy="384048"/>
+          </a:xfrm>
+          <a:prstGeom prst="rect">
+            <a:avLst/>
+          </a:prstGeom>
+          <a:noFill/>
+          <a:ln/>
+        </p:spPr>
+        <p:txBody>
+          <a:bodyPr wrap="square" lIns="0" tIns="0" rIns="0" bIns="0" rtlCol="0" anchor="ctr"/>
+          <a:lstStyle/>
+          <a:p>
+            <a:pPr indent="0" marL="0">
+              <a:buNone/>
+            </a:pPr>
+            <a:r>
+              <a:rPr lang="en-US" sz="1400" b="1" dirty="0">
+                <a:solidFill>
+                  <a:schemeClr val="bg1"/>
+                </a:solidFill>
+              </a:rPr>
+              <a:t>Trygghet att planera framåt</a:t>
+            </a:r>
+            <a:endParaRPr lang="en-US" sz="1400" dirty="0"/>
+          </a:p>
+        </p:txBody>
+      </p:sp>
+      <p:pic>
+        <p:nvPicPr>
+          <p:cNvPr id="32" name="Image 6" descr="preencoded.png">    </p:cNvPr>
+          <p:cNvPicPr>
+            <a:picLocks noChangeAspect="1"/>
+          </p:cNvPicPr>
+          <p:nvPr/>
+        </p:nvPicPr>
+        <p:blipFill>
+          <a:blip r:embed="rId7"/>
+          <a:stretch>
+            <a:fillRect/>
+          </a:stretch>
+        </p:blipFill>
+        <p:spPr>
+          <a:xfrm>
+            <a:off x="5989320" y="3355848"/>
+            <a:ext cx="256032" cy="256032"/>
+          </a:xfrm>
+          <a:prstGeom prst="rect">
+            <a:avLst/>
+          </a:prstGeom>
+        </p:spPr>
+      </p:pic>
+      <p:sp>
+        <p:nvSpPr>
+          <p:cNvPr id="33" name="Text 24"/>
+          <p:cNvSpPr txBox="1"/>
+          <p:nvPr/>
+        </p:nvSpPr>
+        <p:spPr>
+          <a:xfrm>
+            <a:off x="6382512" y="3291840"/>
+            <a:ext cx="2103120" cy="384048"/>
+          </a:xfrm>
+          <a:prstGeom prst="rect">
+            <a:avLst/>
+          </a:prstGeom>
+          <a:noFill/>
+          <a:ln/>
+        </p:spPr>
+        <p:txBody>
+          <a:bodyPr wrap="square" lIns="0" tIns="0" rIns="0" bIns="0" rtlCol="0" anchor="ctr"/>
+          <a:lstStyle/>
+          <a:p>
+            <a:pPr indent="0" marL="0">
+              <a:buNone/>
+            </a:pPr>
+            <a:r>
+              <a:rPr lang="en-US" sz="1400" b="1" dirty="0">
+                <a:solidFill>
+                  <a:schemeClr val="bg1"/>
+                </a:solidFill>
+              </a:rPr>
+              <a:t>Slippa jaga jobb och leads</a:t>
+            </a:r>
+            <a:endParaRPr lang="en-US" sz="1400" dirty="0"/>
+          </a:p>
+        </p:txBody>
+      </p:sp>
+      <p:sp>
+        <p:nvSpPr>
+          <p:cNvPr id="34" name="Text 25"/>
+          <p:cNvSpPr txBox="1"/>
+          <p:nvPr/>
+        </p:nvSpPr>
+        <p:spPr>
+          <a:xfrm>
+            <a:off x="5989320" y="3840480"/>
+            <a:ext cx="2423160" cy="457200"/>
           </a:xfrm>
           <a:prstGeom prst="rect">
             <a:avLst/>
@@ -3846,14 +4416,14 @@
               <a:buNone/>
             </a:pPr>
             <a:r>
-              <a:rPr lang="en-US" sz="1400" dirty="0">
-                <a:solidFill>
-                  <a:schemeClr val="accent6"/>
-                </a:solidFill>
-              </a:rPr>
-              <a:t>Offerter och hembesök hos kunder som bara jämför priser.</a:t>
-            </a:r>
-            <a:endParaRPr lang="en-US" sz="1400" dirty="0"/>
+              <a:rPr lang="en-US" sz="1100" i="1" dirty="0">
+                <a:solidFill>
+                  <a:schemeClr val="accent4"/>
+                </a:solidFill>
+              </a:rPr>
+              <a:t>Känns det inte rätt är det helt okej – känns det rätt kör vi igång direkt.</a:t>
+            </a:r>
+            <a:endParaRPr lang="en-US" sz="1100" dirty="0"/>
           </a:p>
         </p:txBody>
       </p:sp>
@@ -4626,7 +5196,7 @@
                   <a:schemeClr val="accent4"/>
                 </a:solidFill>
               </a:rPr>
-              <a:t>Film och motion graphics som visar ert hantverk och bygger förtroende.</a:t>
+              <a:t>Motion graphics av era bilder och filmer från färdiga jobb – eller med AI.</a:t>
             </a:r>
             <a:endParaRPr lang="en-US" sz="1400" dirty="0"/>
           </a:p>
@@ -4778,7 +5348,7 @@
                   <a:schemeClr val="accent4"/>
                 </a:solidFill>
               </a:rPr>
-              <a:t>Annonser till husägare i ert område på Facebook och Instagram.</a:t>
+              <a:t>Betald annonsering via Meta till husägare i ert område, 300 kr/dag.</a:t>
             </a:r>
             <a:endParaRPr lang="en-US" sz="1400" dirty="0"/>
           </a:p>
@@ -4930,7 +5500,7 @@
                   <a:schemeClr val="accent4"/>
                 </a:solidFill>
               </a:rPr>
-              <a:t>Frågor om projekt, budget och tidsplan sållar bort prisjägarna.</a:t>
+              <a:t>Formulär och SMS: projekt, budget och tidsplan. Prisjägarna sållas bort.</a:t>
             </a:r>
             <a:endParaRPr lang="en-US" sz="1400" dirty="0"/>
           </a:p>
@@ -5389,7 +5959,7 @@
                   <a:schemeClr val="accent6"/>
                 </a:solidFill>
               </a:rPr>
-              <a:t>Vi ställer rätt frågor, sållar bort prisjägarna och bokar in hembesöket åt dig.</a:t>
+              <a:t>Vårt team kvalificerar via formulär och SMS och bokar in hembesöket åt dig. Kunden får uppföljningsmejl om ert företag så att de känner sig trygga med att välja er.</a:t>
             </a:r>
             <a:endParaRPr lang="en-US" sz="1400" dirty="0"/>
           </a:p>
@@ -6145,7 +6715,7 @@
                   <a:schemeClr val="tx1"/>
                 </a:solidFill>
               </a:rPr>
-              <a:t>Din kalender · vecka 44</a:t>
+              <a:t>Din kalender · 3 hembesök</a:t>
             </a:r>
             <a:endParaRPr lang="en-US" sz="1400" dirty="0"/>
           </a:p>
@@ -6990,7 +7560,7 @@
                   <a:schemeClr val="accent1"/>
                 </a:solidFill>
               </a:rPr>
-              <a:t>PRISMODELL</a:t>
+              <a:t>APPEN</a:t>
             </a:r>
             <a:endParaRPr lang="en-US" sz="1100" dirty="0"/>
           </a:p>
@@ -7028,7 +7598,7 @@
                   <a:schemeClr val="bg1"/>
                 </a:solidFill>
               </a:rPr>
-              <a:t>Ni betalar för resultat</a:t>
+              <a:t>Full överblick – i mobilen och på datorn</a:t>
             </a:r>
             <a:endParaRPr lang="en-US" sz="3000" dirty="0"/>
           </a:p>
@@ -7092,41 +7662,104 @@
       </p:sp>
       <p:sp>
         <p:nvSpPr>
-          <p:cNvPr id="6" name="Price 500 kr"/>
-          <p:cNvSpPr/>
-          <p:nvPr/>
-        </p:nvSpPr>
-        <p:spPr>
-          <a:xfrm>
-            <a:off x="548640" y="1600200"/>
-            <a:ext cx="1536192" cy="2834640"/>
-          </a:xfrm>
-          <a:prstGeom prst="roundRect">
-            <a:avLst>
-              <a:gd name="adj" fmla="val 5952"/>
-            </a:avLst>
+          <p:cNvPr id="6" name="Glow"/>
+          <p:cNvSpPr/>
+          <p:nvPr/>
+        </p:nvSpPr>
+        <p:spPr>
+          <a:xfrm>
+            <a:off x="5669280" y="1417320"/>
+            <a:ext cx="3017520" cy="3017520"/>
+          </a:xfrm>
+          <a:prstGeom prst="ellipse">
+            <a:avLst/>
+          </a:prstGeom>
+          <a:solidFill>
+            <a:schemeClr val="accent1">
+              <a:alpha val="15000"/>
+            </a:schemeClr>
+          </a:solidFill>
+          <a:ln/>
+        </p:spPr>
+      </p:sp>
+      <p:pic>
+        <p:nvPicPr>
+          <p:cNvPr id="7" name="App mockup" descr="preencoded.png">    </p:cNvPr>
+          <p:cNvPicPr>
+            <a:picLocks noChangeAspect="1"/>
+          </p:cNvPicPr>
+          <p:nvPr/>
+        </p:nvPicPr>
+        <p:blipFill>
+          <a:blip r:embed="rId1"/>
+          <a:stretch>
+            <a:fillRect/>
+          </a:stretch>
+        </p:blipFill>
+        <p:spPr>
+          <a:xfrm>
+            <a:off x="6355080" y="1371600"/>
+            <a:ext cx="1645920" cy="3346704"/>
+          </a:xfrm>
+          <a:prstGeom prst="rect">
+            <a:avLst/>
+          </a:prstGeom>
+        </p:spPr>
+      </p:pic>
+      <p:sp>
+        <p:nvSpPr>
+          <p:cNvPr id="8" name="Feature 1 circle"/>
+          <p:cNvSpPr/>
+          <p:nvPr/>
+        </p:nvSpPr>
+        <p:spPr>
+          <a:xfrm>
+            <a:off x="548640" y="1609344"/>
+            <a:ext cx="457200" cy="457200"/>
+          </a:xfrm>
+          <a:prstGeom prst="ellipse">
+            <a:avLst/>
           </a:prstGeom>
           <a:solidFill>
             <a:schemeClr val="tx2"/>
           </a:solidFill>
-          <a:ln w="12700">
-            <a:solidFill>
-              <a:schemeClr val="accent2"/>
-            </a:solidFill>
-            <a:prstDash val="solid"/>
-          </a:ln>
-        </p:spPr>
-      </p:sp>
-      <p:sp>
-        <p:nvSpPr>
-          <p:cNvPr id="7" name="Text 5"/>
+          <a:ln/>
+        </p:spPr>
+      </p:sp>
+      <p:pic>
+        <p:nvPicPr>
+          <p:cNvPr id="9" name="Feature 1 icon" descr="preencoded.png">    </p:cNvPr>
+          <p:cNvPicPr>
+            <a:picLocks noChangeAspect="1"/>
+          </p:cNvPicPr>
+          <p:nvPr/>
+        </p:nvPicPr>
+        <p:blipFill>
+          <a:blip r:embed="rId2"/>
+          <a:stretch>
+            <a:fillRect/>
+          </a:stretch>
+        </p:blipFill>
+        <p:spPr>
+          <a:xfrm>
+            <a:off x="662940" y="1723644"/>
+            <a:ext cx="228600" cy="228600"/>
+          </a:xfrm>
+          <a:prstGeom prst="rect">
+            <a:avLst/>
+          </a:prstGeom>
+        </p:spPr>
+      </p:pic>
+      <p:sp>
+        <p:nvSpPr>
+          <p:cNvPr id="10" name="Text 6"/>
           <p:cNvSpPr txBox="1"/>
           <p:nvPr/>
         </p:nvSpPr>
         <p:spPr>
           <a:xfrm>
-            <a:off x="713232" y="1783080"/>
-            <a:ext cx="1280160" cy="548640"/>
+            <a:off x="1188720" y="1572768"/>
+            <a:ext cx="4480560" cy="548640"/>
           </a:xfrm>
           <a:prstGeom prst="rect">
             <a:avLst/>
@@ -7142,126 +7775,85 @@
               <a:buNone/>
             </a:pPr>
             <a:r>
-              <a:rPr lang="en-US" sz="3000" b="1" dirty="0">
-                <a:solidFill>
-                  <a:schemeClr val="accent1"/>
-                </a:solidFill>
-              </a:rPr>
-              <a:t>500 kr</a:t>
-            </a:r>
-            <a:endParaRPr lang="en-US" sz="3000" dirty="0"/>
-          </a:p>
-        </p:txBody>
-      </p:sp>
-      <p:sp>
-        <p:nvSpPr>
-          <p:cNvPr id="8" name="Text 6"/>
-          <p:cNvSpPr txBox="1"/>
-          <p:nvPr/>
-        </p:nvSpPr>
-        <p:spPr>
-          <a:xfrm>
-            <a:off x="713232" y="2377440"/>
-            <a:ext cx="1280160" cy="502920"/>
-          </a:xfrm>
-          <a:prstGeom prst="rect">
-            <a:avLst/>
-          </a:prstGeom>
-          <a:noFill/>
-          <a:ln/>
-        </p:spPr>
-        <p:txBody>
-          <a:bodyPr wrap="square" lIns="0" tIns="0" rIns="0" bIns="0" rtlCol="0" anchor="t"/>
-          <a:lstStyle/>
+              <a:rPr lang="en-US" sz="1500" b="1" dirty="0">
+                <a:solidFill>
+                  <a:schemeClr val="bg1"/>
+                </a:solidFill>
+              </a:rPr>
+              <a:t>Alla hembesök samlade</a:t>
+            </a:r>
+            <a:endParaRPr lang="en-US" sz="1500" dirty="0"/>
+          </a:p>
           <a:p>
             <a:pPr indent="0" marL="0">
               <a:buNone/>
             </a:pPr>
             <a:r>
-              <a:rPr lang="en-US" sz="1400" b="1" dirty="0">
-                <a:solidFill>
-                  <a:schemeClr val="bg1"/>
-                </a:solidFill>
-              </a:rPr>
-              <a:t>per bokat hembesök</a:t>
-            </a:r>
-            <a:endParaRPr lang="en-US" sz="1400" dirty="0"/>
-          </a:p>
-        </p:txBody>
-      </p:sp>
-      <p:sp>
-        <p:nvSpPr>
-          <p:cNvPr id="9" name="Text 7"/>
-          <p:cNvSpPr txBox="1"/>
-          <p:nvPr/>
-        </p:nvSpPr>
-        <p:spPr>
-          <a:xfrm>
-            <a:off x="713232" y="3017520"/>
-            <a:ext cx="1261872" cy="1280160"/>
-          </a:xfrm>
-          <a:prstGeom prst="rect">
-            <a:avLst/>
-          </a:prstGeom>
-          <a:noFill/>
-          <a:ln/>
-        </p:spPr>
-        <p:txBody>
-          <a:bodyPr wrap="square" lIns="0" tIns="0" rIns="0" bIns="0" rtlCol="0" anchor="t"/>
-          <a:lstStyle/>
-          <a:p>
-            <a:pPr indent="0" marL="0">
-              <a:buNone/>
-            </a:pPr>
-            <a:r>
               <a:rPr lang="en-US" sz="1200" dirty="0">
                 <a:solidFill>
                   <a:schemeClr val="accent4"/>
                 </a:solidFill>
               </a:rPr>
-              <a:t>För varje kvalificerat besök i er kalender.</a:t>
-            </a:r>
-            <a:endParaRPr lang="en-US" sz="1200" dirty="0"/>
-          </a:p>
-        </p:txBody>
-      </p:sp>
-      <p:sp>
-        <p:nvSpPr>
-          <p:cNvPr id="10" name="Price 5 %"/>
-          <p:cNvSpPr/>
-          <p:nvPr/>
-        </p:nvSpPr>
-        <p:spPr>
-          <a:xfrm>
-            <a:off x="2221992" y="1600200"/>
-            <a:ext cx="1536192" cy="2834640"/>
-          </a:xfrm>
-          <a:prstGeom prst="roundRect">
-            <a:avLst>
-              <a:gd name="adj" fmla="val 5952"/>
-            </a:avLst>
+              <a:t>Ett enkelt kalendersystem med adress och info om jobbet.</a:t>
+            </a:r>
+            <a:endParaRPr lang="en-US" sz="1500" dirty="0"/>
+          </a:p>
+        </p:txBody>
+      </p:sp>
+      <p:sp>
+        <p:nvSpPr>
+          <p:cNvPr id="11" name="Feature 2 circle"/>
+          <p:cNvSpPr/>
+          <p:nvPr/>
+        </p:nvSpPr>
+        <p:spPr>
+          <a:xfrm>
+            <a:off x="548640" y="2340864"/>
+            <a:ext cx="457200" cy="457200"/>
+          </a:xfrm>
+          <a:prstGeom prst="ellipse">
+            <a:avLst/>
           </a:prstGeom>
           <a:solidFill>
             <a:schemeClr val="tx2"/>
           </a:solidFill>
-          <a:ln w="12700">
-            <a:solidFill>
-              <a:schemeClr val="accent2"/>
-            </a:solidFill>
-            <a:prstDash val="solid"/>
-          </a:ln>
-        </p:spPr>
-      </p:sp>
-      <p:sp>
-        <p:nvSpPr>
-          <p:cNvPr id="11" name="Text 9"/>
+          <a:ln/>
+        </p:spPr>
+      </p:sp>
+      <p:pic>
+        <p:nvPicPr>
+          <p:cNvPr id="12" name="Feature 2 icon" descr="preencoded.png">    </p:cNvPr>
+          <p:cNvPicPr>
+            <a:picLocks noChangeAspect="1"/>
+          </p:cNvPicPr>
+          <p:nvPr/>
+        </p:nvPicPr>
+        <p:blipFill>
+          <a:blip r:embed="rId3"/>
+          <a:stretch>
+            <a:fillRect/>
+          </a:stretch>
+        </p:blipFill>
+        <p:spPr>
+          <a:xfrm>
+            <a:off x="662940" y="2455164"/>
+            <a:ext cx="228600" cy="228600"/>
+          </a:xfrm>
+          <a:prstGeom prst="rect">
+            <a:avLst/>
+          </a:prstGeom>
+        </p:spPr>
+      </p:pic>
+      <p:sp>
+        <p:nvSpPr>
+          <p:cNvPr id="13" name="Text 8"/>
           <p:cNvSpPr txBox="1"/>
           <p:nvPr/>
         </p:nvSpPr>
         <p:spPr>
           <a:xfrm>
-            <a:off x="2386584" y="1783080"/>
-            <a:ext cx="1280160" cy="548640"/>
+            <a:off x="1188720" y="2304288"/>
+            <a:ext cx="4480560" cy="548640"/>
           </a:xfrm>
           <a:prstGeom prst="rect">
             <a:avLst/>
@@ -7277,126 +7869,85 @@
               <a:buNone/>
             </a:pPr>
             <a:r>
-              <a:rPr lang="en-US" sz="3000" b="1" dirty="0">
-                <a:solidFill>
-                  <a:schemeClr val="accent1"/>
-                </a:solidFill>
-              </a:rPr>
-              <a:t>5 %</a:t>
-            </a:r>
-            <a:endParaRPr lang="en-US" sz="3000" dirty="0"/>
-          </a:p>
-        </p:txBody>
-      </p:sp>
-      <p:sp>
-        <p:nvSpPr>
-          <p:cNvPr id="12" name="Text 10"/>
-          <p:cNvSpPr txBox="1"/>
-          <p:nvPr/>
-        </p:nvSpPr>
-        <p:spPr>
-          <a:xfrm>
-            <a:off x="2386584" y="2377440"/>
-            <a:ext cx="1280160" cy="502920"/>
-          </a:xfrm>
-          <a:prstGeom prst="rect">
-            <a:avLst/>
-          </a:prstGeom>
-          <a:noFill/>
-          <a:ln/>
-        </p:spPr>
-        <p:txBody>
-          <a:bodyPr wrap="square" lIns="0" tIns="0" rIns="0" bIns="0" rtlCol="0" anchor="t"/>
-          <a:lstStyle/>
+              <a:rPr lang="en-US" sz="1500" b="1" dirty="0">
+                <a:solidFill>
+                  <a:schemeClr val="bg1"/>
+                </a:solidFill>
+              </a:rPr>
+              <a:t>SMS-notis vid varje bokning</a:t>
+            </a:r>
+            <a:endParaRPr lang="en-US" sz="1500" dirty="0"/>
+          </a:p>
           <a:p>
             <a:pPr indent="0" marL="0">
               <a:buNone/>
             </a:pPr>
             <a:r>
-              <a:rPr lang="en-US" sz="1400" b="1" dirty="0">
-                <a:solidFill>
-                  <a:schemeClr val="bg1"/>
-                </a:solidFill>
-              </a:rPr>
-              <a:t>av vinsten</a:t>
-            </a:r>
-            <a:endParaRPr lang="en-US" sz="1400" dirty="0"/>
-          </a:p>
-        </p:txBody>
-      </p:sp>
-      <p:sp>
-        <p:nvSpPr>
-          <p:cNvPr id="13" name="Text 11"/>
-          <p:cNvSpPr txBox="1"/>
-          <p:nvPr/>
-        </p:nvSpPr>
-        <p:spPr>
-          <a:xfrm>
-            <a:off x="2386584" y="3017520"/>
-            <a:ext cx="1261872" cy="1280160"/>
-          </a:xfrm>
-          <a:prstGeom prst="rect">
-            <a:avLst/>
-          </a:prstGeom>
-          <a:noFill/>
-          <a:ln/>
-        </p:spPr>
-        <p:txBody>
-          <a:bodyPr wrap="square" lIns="0" tIns="0" rIns="0" bIns="0" rtlCol="0" anchor="t"/>
-          <a:lstStyle/>
-          <a:p>
-            <a:pPr indent="0" marL="0">
-              <a:buNone/>
-            </a:pPr>
-            <a:r>
               <a:rPr lang="en-US" sz="1200" dirty="0">
                 <a:solidFill>
                   <a:schemeClr val="accent4"/>
                 </a:solidFill>
               </a:rPr>
-              <a:t>På de jobb ni vinner från våra besök.</a:t>
-            </a:r>
-            <a:endParaRPr lang="en-US" sz="1200" dirty="0"/>
-          </a:p>
-        </p:txBody>
-      </p:sp>
-      <p:sp>
-        <p:nvSpPr>
-          <p:cNvPr id="14" name="Price 300 kr"/>
-          <p:cNvSpPr/>
-          <p:nvPr/>
-        </p:nvSpPr>
-        <p:spPr>
-          <a:xfrm>
-            <a:off x="3895344" y="1600200"/>
-            <a:ext cx="1536192" cy="2834640"/>
-          </a:xfrm>
-          <a:prstGeom prst="roundRect">
-            <a:avLst>
-              <a:gd name="adj" fmla="val 5952"/>
-            </a:avLst>
+              <a:t>Du får besked direkt när ett hembesök bokas in.</a:t>
+            </a:r>
+            <a:endParaRPr lang="en-US" sz="1500" dirty="0"/>
+          </a:p>
+        </p:txBody>
+      </p:sp>
+      <p:sp>
+        <p:nvSpPr>
+          <p:cNvPr id="14" name="Feature 3 circle"/>
+          <p:cNvSpPr/>
+          <p:nvPr/>
+        </p:nvSpPr>
+        <p:spPr>
+          <a:xfrm>
+            <a:off x="548640" y="3072384"/>
+            <a:ext cx="457200" cy="457200"/>
+          </a:xfrm>
+          <a:prstGeom prst="ellipse">
+            <a:avLst/>
           </a:prstGeom>
           <a:solidFill>
             <a:schemeClr val="tx2"/>
           </a:solidFill>
-          <a:ln w="12700">
-            <a:solidFill>
-              <a:schemeClr val="accent2"/>
-            </a:solidFill>
-            <a:prstDash val="solid"/>
-          </a:ln>
-        </p:spPr>
-      </p:sp>
-      <p:sp>
-        <p:nvSpPr>
-          <p:cNvPr id="15" name="Text 13"/>
+          <a:ln/>
+        </p:spPr>
+      </p:sp>
+      <p:pic>
+        <p:nvPicPr>
+          <p:cNvPr id="15" name="Feature 3 icon" descr="preencoded.png">    </p:cNvPr>
+          <p:cNvPicPr>
+            <a:picLocks noChangeAspect="1"/>
+          </p:cNvPicPr>
+          <p:nvPr/>
+        </p:nvPicPr>
+        <p:blipFill>
+          <a:blip r:embed="rId4"/>
+          <a:stretch>
+            <a:fillRect/>
+          </a:stretch>
+        </p:blipFill>
+        <p:spPr>
+          <a:xfrm>
+            <a:off x="662940" y="3186684"/>
+            <a:ext cx="228600" cy="228600"/>
+          </a:xfrm>
+          <a:prstGeom prst="rect">
+            <a:avLst/>
+          </a:prstGeom>
+        </p:spPr>
+      </p:pic>
+      <p:sp>
+        <p:nvSpPr>
+          <p:cNvPr id="16" name="Text 10"/>
           <p:cNvSpPr txBox="1"/>
           <p:nvPr/>
         </p:nvSpPr>
         <p:spPr>
           <a:xfrm>
-            <a:off x="4059936" y="1783080"/>
-            <a:ext cx="1280160" cy="548640"/>
+            <a:off x="1188720" y="3035808"/>
+            <a:ext cx="4480560" cy="548640"/>
           </a:xfrm>
           <a:prstGeom prst="rect">
             <a:avLst/>
@@ -7412,73 +7963,109 @@
               <a:buNone/>
             </a:pPr>
             <a:r>
-              <a:rPr lang="en-US" sz="3000" b="1" dirty="0">
-                <a:solidFill>
-                  <a:schemeClr val="accent1"/>
-                </a:solidFill>
-              </a:rPr>
-              <a:t>300 kr</a:t>
-            </a:r>
-            <a:endParaRPr lang="en-US" sz="3000" dirty="0"/>
-          </a:p>
-        </p:txBody>
-      </p:sp>
-      <p:sp>
-        <p:nvSpPr>
-          <p:cNvPr id="16" name="Text 14"/>
+              <a:rPr lang="en-US" sz="1500" b="1" dirty="0">
+                <a:solidFill>
+                  <a:schemeClr val="bg1"/>
+                </a:solidFill>
+              </a:rPr>
+              <a:t>Chatta med leads via SMS</a:t>
+            </a:r>
+            <a:endParaRPr lang="en-US" sz="1500" dirty="0"/>
+          </a:p>
+          <a:p>
+            <a:pPr indent="0" marL="0">
+              <a:buNone/>
+            </a:pPr>
+            <a:r>
+              <a:rPr lang="en-US" sz="1200" dirty="0">
+                <a:solidFill>
+                  <a:schemeClr val="accent4"/>
+                </a:solidFill>
+              </a:rPr>
+              <a:t>All kontakt med kunderna på ett ställe.</a:t>
+            </a:r>
+            <a:endParaRPr lang="en-US" sz="1500" dirty="0"/>
+          </a:p>
+        </p:txBody>
+      </p:sp>
+      <p:sp>
+        <p:nvSpPr>
+          <p:cNvPr id="17" name="Feature 4 circle"/>
+          <p:cNvSpPr/>
+          <p:nvPr/>
+        </p:nvSpPr>
+        <p:spPr>
+          <a:xfrm>
+            <a:off x="548640" y="3803904"/>
+            <a:ext cx="457200" cy="457200"/>
+          </a:xfrm>
+          <a:prstGeom prst="ellipse">
+            <a:avLst/>
+          </a:prstGeom>
+          <a:solidFill>
+            <a:schemeClr val="tx2"/>
+          </a:solidFill>
+          <a:ln/>
+        </p:spPr>
+      </p:sp>
+      <p:pic>
+        <p:nvPicPr>
+          <p:cNvPr id="18" name="Feature 4 icon" descr="preencoded.png">    </p:cNvPr>
+          <p:cNvPicPr>
+            <a:picLocks noChangeAspect="1"/>
+          </p:cNvPicPr>
+          <p:nvPr/>
+        </p:nvPicPr>
+        <p:blipFill>
+          <a:blip r:embed="rId5"/>
+          <a:stretch>
+            <a:fillRect/>
+          </a:stretch>
+        </p:blipFill>
+        <p:spPr>
+          <a:xfrm>
+            <a:off x="662940" y="3918204"/>
+            <a:ext cx="228600" cy="228600"/>
+          </a:xfrm>
+          <a:prstGeom prst="rect">
+            <a:avLst/>
+          </a:prstGeom>
+        </p:spPr>
+      </p:pic>
+      <p:sp>
+        <p:nvSpPr>
+          <p:cNvPr id="19" name="Text 12"/>
           <p:cNvSpPr txBox="1"/>
           <p:nvPr/>
         </p:nvSpPr>
         <p:spPr>
           <a:xfrm>
-            <a:off x="4059936" y="2377440"/>
-            <a:ext cx="1280160" cy="502920"/>
-          </a:xfrm>
-          <a:prstGeom prst="rect">
-            <a:avLst/>
-          </a:prstGeom>
-          <a:noFill/>
-          <a:ln/>
-        </p:spPr>
-        <p:txBody>
-          <a:bodyPr wrap="square" lIns="0" tIns="0" rIns="0" bIns="0" rtlCol="0" anchor="t"/>
+            <a:off x="1188720" y="3767328"/>
+            <a:ext cx="4480560" cy="548640"/>
+          </a:xfrm>
+          <a:prstGeom prst="rect">
+            <a:avLst/>
+          </a:prstGeom>
+          <a:noFill/>
+          <a:ln/>
+        </p:spPr>
+        <p:txBody>
+          <a:bodyPr wrap="square" lIns="0" tIns="0" rIns="0" bIns="0" rtlCol="0" anchor="ctr"/>
           <a:lstStyle/>
           <a:p>
             <a:pPr indent="0" marL="0">
               <a:buNone/>
             </a:pPr>
             <a:r>
-              <a:rPr lang="en-US" sz="1400" b="1" dirty="0">
+              <a:rPr lang="en-US" sz="1500" b="1" dirty="0">
                 <a:solidFill>
                   <a:schemeClr val="bg1"/>
                 </a:solidFill>
               </a:rPr>
-              <a:t>per dag i annonser</a:t>
-            </a:r>
-            <a:endParaRPr lang="en-US" sz="1400" dirty="0"/>
-          </a:p>
-        </p:txBody>
-      </p:sp>
-      <p:sp>
-        <p:nvSpPr>
-          <p:cNvPr id="17" name="Text 15"/>
-          <p:cNvSpPr txBox="1"/>
-          <p:nvPr/>
-        </p:nvSpPr>
-        <p:spPr>
-          <a:xfrm>
-            <a:off x="4059936" y="3017520"/>
-            <a:ext cx="1261872" cy="1280160"/>
-          </a:xfrm>
-          <a:prstGeom prst="rect">
-            <a:avLst/>
-          </a:prstGeom>
-          <a:noFill/>
-          <a:ln/>
-        </p:spPr>
-        <p:txBody>
-          <a:bodyPr wrap="square" lIns="0" tIns="0" rIns="0" bIns="0" rtlCol="0" anchor="t"/>
-          <a:lstStyle/>
+              <a:t>Överblick och statistik</a:t>
+            </a:r>
+            <a:endParaRPr lang="en-US" sz="1500" dirty="0"/>
+          </a:p>
           <a:p>
             <a:pPr indent="0" marL="0">
               <a:buNone/>
@@ -7489,464 +8076,9 @@
                   <a:schemeClr val="accent4"/>
                 </a:solidFill>
               </a:rPr>
-              <a:t>Går direkt till Meta. Ca 9 000 kr/mån.</a:t>
-            </a:r>
-            <a:endParaRPr lang="en-US" sz="1200" dirty="0"/>
-          </a:p>
-        </p:txBody>
-      </p:sp>
-      <p:sp>
-        <p:nvSpPr>
-          <p:cNvPr id="18" name="Example box"/>
-          <p:cNvSpPr/>
-          <p:nvPr/>
-        </p:nvSpPr>
-        <p:spPr>
-          <a:xfrm>
-            <a:off x="5669280" y="1600200"/>
-            <a:ext cx="2926080" cy="2834640"/>
-          </a:xfrm>
-          <a:prstGeom prst="roundRect">
-            <a:avLst>
-              <a:gd name="adj" fmla="val 3226"/>
-            </a:avLst>
-          </a:prstGeom>
-          <a:solidFill>
-            <a:schemeClr val="accent1"/>
-          </a:solidFill>
-          <a:ln/>
-        </p:spPr>
-      </p:sp>
-      <p:sp>
-        <p:nvSpPr>
-          <p:cNvPr id="19" name="Text 17"/>
-          <p:cNvSpPr txBox="1"/>
-          <p:nvPr/>
-        </p:nvSpPr>
-        <p:spPr>
-          <a:xfrm>
-            <a:off x="5870448" y="1755648"/>
-            <a:ext cx="2560320" cy="228600"/>
-          </a:xfrm>
-          <a:prstGeom prst="rect">
-            <a:avLst/>
-          </a:prstGeom>
-          <a:noFill/>
-          <a:ln/>
-        </p:spPr>
-        <p:txBody>
-          <a:bodyPr wrap="square" lIns="0" tIns="0" rIns="0" bIns="0" rtlCol="0" anchor="ctr"/>
-          <a:lstStyle/>
-          <a:p>
-            <a:pPr indent="0" marL="0">
-              <a:buNone/>
-            </a:pPr>
-            <a:r>
-              <a:rPr lang="en-US" sz="900" b="1" spc="200" kern="0" dirty="0">
-                <a:solidFill>
-                  <a:schemeClr val="tx1"/>
-                </a:solidFill>
-              </a:rPr>
-              <a:t>RÄKNEEXEMPEL · 1 MÅNAD</a:t>
-            </a:r>
-            <a:endParaRPr lang="en-US" sz="900" dirty="0"/>
-          </a:p>
-        </p:txBody>
-      </p:sp>
-      <p:sp>
-        <p:nvSpPr>
-          <p:cNvPr id="20" name="Text 18"/>
-          <p:cNvSpPr txBox="1"/>
-          <p:nvPr/>
-        </p:nvSpPr>
-        <p:spPr>
-          <a:xfrm>
-            <a:off x="5870448" y="2075688"/>
-            <a:ext cx="1737360" cy="274320"/>
-          </a:xfrm>
-          <a:prstGeom prst="rect">
-            <a:avLst/>
-          </a:prstGeom>
-          <a:noFill/>
-          <a:ln/>
-        </p:spPr>
-        <p:txBody>
-          <a:bodyPr wrap="square" lIns="0" tIns="0" rIns="0" bIns="0" rtlCol="0" anchor="ctr"/>
-          <a:lstStyle/>
-          <a:p>
-            <a:pPr indent="0" marL="0">
-              <a:buNone/>
-            </a:pPr>
-            <a:r>
-              <a:rPr lang="en-US" sz="1200" dirty="0">
-                <a:solidFill>
-                  <a:schemeClr val="tx1"/>
-                </a:solidFill>
-              </a:rPr>
-              <a:t>Annonser 30 × 300 kr</a:t>
-            </a:r>
-            <a:endParaRPr lang="en-US" sz="1200" dirty="0"/>
-          </a:p>
-        </p:txBody>
-      </p:sp>
-      <p:sp>
-        <p:nvSpPr>
-          <p:cNvPr id="21" name="Text 19"/>
-          <p:cNvSpPr txBox="1"/>
-          <p:nvPr/>
-        </p:nvSpPr>
-        <p:spPr>
-          <a:xfrm>
-            <a:off x="7498080" y="2075688"/>
-            <a:ext cx="914400" cy="274320"/>
-          </a:xfrm>
-          <a:prstGeom prst="rect">
-            <a:avLst/>
-          </a:prstGeom>
-          <a:noFill/>
-          <a:ln/>
-        </p:spPr>
-        <p:txBody>
-          <a:bodyPr wrap="square" lIns="0" tIns="0" rIns="0" bIns="0" rtlCol="0" anchor="ctr"/>
-          <a:lstStyle/>
-          <a:p>
-            <a:pPr algn="r" indent="0" marL="0">
-              <a:buNone/>
-            </a:pPr>
-            <a:r>
-              <a:rPr lang="en-US" sz="1200" b="1" dirty="0">
-                <a:solidFill>
-                  <a:schemeClr val="tx1"/>
-                </a:solidFill>
-              </a:rPr>
-              <a:t>9 000 kr</a:t>
-            </a:r>
-            <a:endParaRPr lang="en-US" sz="1200" dirty="0"/>
-          </a:p>
-        </p:txBody>
-      </p:sp>
-      <p:sp>
-        <p:nvSpPr>
-          <p:cNvPr id="22" name="Text 20"/>
-          <p:cNvSpPr txBox="1"/>
-          <p:nvPr/>
-        </p:nvSpPr>
-        <p:spPr>
-          <a:xfrm>
-            <a:off x="5870448" y="2404872"/>
-            <a:ext cx="1737360" cy="274320"/>
-          </a:xfrm>
-          <a:prstGeom prst="rect">
-            <a:avLst/>
-          </a:prstGeom>
-          <a:noFill/>
-          <a:ln/>
-        </p:spPr>
-        <p:txBody>
-          <a:bodyPr wrap="square" lIns="0" tIns="0" rIns="0" bIns="0" rtlCol="0" anchor="ctr"/>
-          <a:lstStyle/>
-          <a:p>
-            <a:pPr indent="0" marL="0">
-              <a:buNone/>
-            </a:pPr>
-            <a:r>
-              <a:rPr lang="en-US" sz="1200" dirty="0">
-                <a:solidFill>
-                  <a:schemeClr val="tx1"/>
-                </a:solidFill>
-              </a:rPr>
-              <a:t>10 hembesök × 500 kr</a:t>
-            </a:r>
-            <a:endParaRPr lang="en-US" sz="1200" dirty="0"/>
-          </a:p>
-        </p:txBody>
-      </p:sp>
-      <p:sp>
-        <p:nvSpPr>
-          <p:cNvPr id="23" name="Text 21"/>
-          <p:cNvSpPr txBox="1"/>
-          <p:nvPr/>
-        </p:nvSpPr>
-        <p:spPr>
-          <a:xfrm>
-            <a:off x="7498080" y="2404872"/>
-            <a:ext cx="914400" cy="274320"/>
-          </a:xfrm>
-          <a:prstGeom prst="rect">
-            <a:avLst/>
-          </a:prstGeom>
-          <a:noFill/>
-          <a:ln/>
-        </p:spPr>
-        <p:txBody>
-          <a:bodyPr wrap="square" lIns="0" tIns="0" rIns="0" bIns="0" rtlCol="0" anchor="ctr"/>
-          <a:lstStyle/>
-          <a:p>
-            <a:pPr algn="r" indent="0" marL="0">
-              <a:buNone/>
-            </a:pPr>
-            <a:r>
-              <a:rPr lang="en-US" sz="1200" b="1" dirty="0">
-                <a:solidFill>
-                  <a:schemeClr val="tx1"/>
-                </a:solidFill>
-              </a:rPr>
-              <a:t>5 000 kr</a:t>
-            </a:r>
-            <a:endParaRPr lang="en-US" sz="1200" dirty="0"/>
-          </a:p>
-        </p:txBody>
-      </p:sp>
-      <p:sp>
-        <p:nvSpPr>
-          <p:cNvPr id="24" name="Text 22"/>
-          <p:cNvSpPr txBox="1"/>
-          <p:nvPr/>
-        </p:nvSpPr>
-        <p:spPr>
-          <a:xfrm>
-            <a:off x="5870448" y="2734056"/>
-            <a:ext cx="1737360" cy="274320"/>
-          </a:xfrm>
-          <a:prstGeom prst="rect">
-            <a:avLst/>
-          </a:prstGeom>
-          <a:noFill/>
-          <a:ln/>
-        </p:spPr>
-        <p:txBody>
-          <a:bodyPr wrap="square" lIns="0" tIns="0" rIns="0" bIns="0" rtlCol="0" anchor="ctr"/>
-          <a:lstStyle/>
-          <a:p>
-            <a:pPr indent="0" marL="0">
-              <a:buNone/>
-            </a:pPr>
-            <a:r>
-              <a:rPr lang="en-US" sz="1200" dirty="0">
-                <a:solidFill>
-                  <a:schemeClr val="tx1"/>
-                </a:solidFill>
-              </a:rPr>
-              <a:t>5 % av 150 000 kr</a:t>
-            </a:r>
-            <a:endParaRPr lang="en-US" sz="1200" dirty="0"/>
-          </a:p>
-        </p:txBody>
-      </p:sp>
-      <p:sp>
-        <p:nvSpPr>
-          <p:cNvPr id="25" name="Text 23"/>
-          <p:cNvSpPr txBox="1"/>
-          <p:nvPr/>
-        </p:nvSpPr>
-        <p:spPr>
-          <a:xfrm>
-            <a:off x="7498080" y="2734056"/>
-            <a:ext cx="914400" cy="274320"/>
-          </a:xfrm>
-          <a:prstGeom prst="rect">
-            <a:avLst/>
-          </a:prstGeom>
-          <a:noFill/>
-          <a:ln/>
-        </p:spPr>
-        <p:txBody>
-          <a:bodyPr wrap="square" lIns="0" tIns="0" rIns="0" bIns="0" rtlCol="0" anchor="ctr"/>
-          <a:lstStyle/>
-          <a:p>
-            <a:pPr algn="r" indent="0" marL="0">
-              <a:buNone/>
-            </a:pPr>
-            <a:r>
-              <a:rPr lang="en-US" sz="1200" b="1" dirty="0">
-                <a:solidFill>
-                  <a:schemeClr val="tx1"/>
-                </a:solidFill>
-              </a:rPr>
-              <a:t>7 500 kr</a:t>
-            </a:r>
-            <a:endParaRPr lang="en-US" sz="1200" dirty="0"/>
-          </a:p>
-        </p:txBody>
-      </p:sp>
-      <p:sp>
-        <p:nvSpPr>
-          <p:cNvPr id="26" name="Shape 24"/>
-          <p:cNvSpPr/>
-          <p:nvPr/>
-        </p:nvSpPr>
-        <p:spPr>
-          <a:xfrm>
-            <a:off x="5870448" y="3099816"/>
-            <a:ext cx="2542032" cy="0"/>
-          </a:xfrm>
-          <a:prstGeom prst="line">
-            <a:avLst/>
-          </a:prstGeom>
-          <a:noFill/>
-          <a:ln w="12700">
-            <a:solidFill>
-              <a:schemeClr val="tx1"/>
-            </a:solidFill>
-            <a:prstDash val="solid"/>
-          </a:ln>
-        </p:spPr>
-      </p:sp>
-      <p:sp>
-        <p:nvSpPr>
-          <p:cNvPr id="27" name="Text 25"/>
-          <p:cNvSpPr txBox="1"/>
-          <p:nvPr/>
-        </p:nvSpPr>
-        <p:spPr>
-          <a:xfrm>
-            <a:off x="5870448" y="3154680"/>
-            <a:ext cx="1371600" cy="292608"/>
-          </a:xfrm>
-          <a:prstGeom prst="rect">
-            <a:avLst/>
-          </a:prstGeom>
-          <a:noFill/>
-          <a:ln/>
-        </p:spPr>
-        <p:txBody>
-          <a:bodyPr wrap="square" lIns="0" tIns="0" rIns="0" bIns="0" rtlCol="0" anchor="ctr"/>
-          <a:lstStyle/>
-          <a:p>
-            <a:pPr indent="0" marL="0">
-              <a:buNone/>
-            </a:pPr>
-            <a:r>
-              <a:rPr lang="en-US" sz="1300" b="1" dirty="0">
-                <a:solidFill>
-                  <a:schemeClr val="tx1"/>
-                </a:solidFill>
-              </a:rPr>
-              <a:t>Totalt</a:t>
-            </a:r>
-            <a:endParaRPr lang="en-US" sz="1300" dirty="0"/>
-          </a:p>
-        </p:txBody>
-      </p:sp>
-      <p:sp>
-        <p:nvSpPr>
-          <p:cNvPr id="28" name="Text 26"/>
-          <p:cNvSpPr txBox="1"/>
-          <p:nvPr/>
-        </p:nvSpPr>
-        <p:spPr>
-          <a:xfrm>
-            <a:off x="7223760" y="3154680"/>
-            <a:ext cx="1188720" cy="292608"/>
-          </a:xfrm>
-          <a:prstGeom prst="rect">
-            <a:avLst/>
-          </a:prstGeom>
-          <a:noFill/>
-          <a:ln/>
-        </p:spPr>
-        <p:txBody>
-          <a:bodyPr wrap="square" lIns="0" tIns="0" rIns="0" bIns="0" rtlCol="0" anchor="ctr"/>
-          <a:lstStyle/>
-          <a:p>
-            <a:pPr algn="r" indent="0" marL="0">
-              <a:buNone/>
-            </a:pPr>
-            <a:r>
-              <a:rPr lang="en-US" sz="1300" b="1" dirty="0">
-                <a:solidFill>
-                  <a:schemeClr val="tx1"/>
-                </a:solidFill>
-              </a:rPr>
-              <a:t>21 500 kr</a:t>
-            </a:r>
-            <a:endParaRPr lang="en-US" sz="1300" dirty="0"/>
-          </a:p>
-        </p:txBody>
-      </p:sp>
-      <p:sp>
-        <p:nvSpPr>
-          <p:cNvPr id="29" name="Text 27"/>
-          <p:cNvSpPr txBox="1"/>
-          <p:nvPr/>
-        </p:nvSpPr>
-        <p:spPr>
-          <a:xfrm>
-            <a:off x="5870448" y="3566160"/>
-            <a:ext cx="2560320" cy="731520"/>
-          </a:xfrm>
-          <a:prstGeom prst="rect">
-            <a:avLst/>
-          </a:prstGeom>
-          <a:noFill/>
-          <a:ln/>
-        </p:spPr>
-        <p:txBody>
-          <a:bodyPr wrap="square" lIns="0" tIns="0" rIns="0" bIns="0" rtlCol="0" anchor="t"/>
-          <a:lstStyle/>
-          <a:p>
-            <a:pPr indent="0" marL="0">
-              <a:buNone/>
-            </a:pPr>
-            <a:r>
-              <a:rPr lang="en-US" sz="2800" b="1" dirty="0">
-                <a:solidFill>
-                  <a:schemeClr val="bg1"/>
-                </a:solidFill>
-              </a:rPr>
-              <a:t>95 %</a:t>
-            </a:r>
-            <a:endParaRPr lang="en-US" sz="2800" dirty="0"/>
-          </a:p>
-          <a:p>
-            <a:pPr indent="0" marL="0">
-              <a:buNone/>
-            </a:pPr>
-            <a:r>
-              <a:rPr lang="en-US" sz="1200" b="1" dirty="0">
-                <a:solidFill>
-                  <a:schemeClr val="tx1"/>
-                </a:solidFill>
-              </a:rPr>
-              <a:t>av vinsten behåller ni</a:t>
-            </a:r>
-            <a:endParaRPr lang="en-US" sz="2800" dirty="0"/>
-          </a:p>
-        </p:txBody>
-      </p:sp>
-      <p:sp>
-        <p:nvSpPr>
-          <p:cNvPr id="30" name="Text 28"/>
-          <p:cNvSpPr txBox="1"/>
-          <p:nvPr/>
-        </p:nvSpPr>
-        <p:spPr>
-          <a:xfrm>
-            <a:off x="2743200" y="4681728"/>
-            <a:ext cx="4846320" cy="228600"/>
-          </a:xfrm>
-          <a:prstGeom prst="rect">
-            <a:avLst/>
-          </a:prstGeom>
-          <a:noFill/>
-          <a:ln/>
-        </p:spPr>
-        <p:txBody>
-          <a:bodyPr wrap="square" lIns="0" tIns="0" rIns="0" bIns="0" rtlCol="0" anchor="ctr"/>
-          <a:lstStyle/>
-          <a:p>
-            <a:pPr algn="ctr" indent="0" marL="0">
-              <a:buNone/>
-            </a:pPr>
-            <a:r>
-              <a:rPr lang="en-US" sz="900" dirty="0">
-                <a:solidFill>
-                  <a:schemeClr val="accent3"/>
-                </a:solidFill>
-              </a:rPr>
-              <a:t>Exempelsiffror – faktiskt utfall varierar per företag och område</a:t>
-            </a:r>
-            <a:endParaRPr lang="en-US" sz="900" dirty="0"/>
+              <a:t>Se hur många hembesök som bokas varje månad.</a:t>
+            </a:r>
+            <a:endParaRPr lang="en-US" sz="1500" dirty="0"/>
           </a:p>
         </p:txBody>
       </p:sp>
@@ -8025,6 +8157,1071 @@
       </p:grpSpPr>
       <p:sp>
         <p:nvSpPr>
+          <p:cNvPr id="2" name="Text 9"/>
+          <p:cNvSpPr/>
+          <p:nvPr>
+            <p:ph idx="109" type="body" hasCustomPrompt="1"/>
+          </p:nvPr>
+        </p:nvSpPr>
+        <p:spPr>
+          <a:xfrm>
+            <a:off x="548640" y="384048"/>
+            <a:ext cx="5943600" cy="274320"/>
+          </a:xfrm>
+          <a:prstGeom prst="rect">
+            <a:avLst/>
+          </a:prstGeom>
+          <a:noFill/>
+          <a:ln/>
+        </p:spPr>
+        <p:txBody>
+          <a:bodyPr wrap="square" lIns="0" tIns="0" rIns="0" bIns="0" rtlCol="0"/>
+          <a:lstStyle/>
+          <a:p>
+            <a:pPr indent="0" marL="0">
+              <a:buNone/>
+            </a:pPr>
+            <a:r>
+              <a:rPr lang="en-US" sz="1100" b="1" spc="300" kern="0" dirty="0">
+                <a:solidFill>
+                  <a:schemeClr val="accent1"/>
+                </a:solidFill>
+              </a:rPr>
+              <a:t>PRISMODELL</a:t>
+            </a:r>
+            <a:endParaRPr lang="en-US" sz="1100" dirty="0"/>
+          </a:p>
+        </p:txBody>
+      </p:sp>
+      <p:sp>
+        <p:nvSpPr>
+          <p:cNvPr id="3" name="Text 9"/>
+          <p:cNvSpPr/>
+          <p:nvPr>
+            <p:ph idx="110" type="title" hasCustomPrompt="1"/>
+          </p:nvPr>
+        </p:nvSpPr>
+        <p:spPr>
+          <a:xfrm>
+            <a:off x="548640" y="658368"/>
+            <a:ext cx="8046720" cy="685800"/>
+          </a:xfrm>
+          <a:prstGeom prst="rect">
+            <a:avLst/>
+          </a:prstGeom>
+          <a:noFill/>
+          <a:ln/>
+        </p:spPr>
+        <p:txBody>
+          <a:bodyPr wrap="square" lIns="0" tIns="0" rIns="0" bIns="0" rtlCol="0" anchor="ctr"/>
+          <a:lstStyle/>
+          <a:p>
+            <a:pPr algn="l" indent="0" marL="0">
+              <a:buNone/>
+            </a:pPr>
+            <a:r>
+              <a:rPr lang="en-US" sz="3000" b="1" dirty="0">
+                <a:solidFill>
+                  <a:schemeClr val="bg1"/>
+                </a:solidFill>
+              </a:rPr>
+              <a:t>Ni betalar för resultat</a:t>
+            </a:r>
+            <a:endParaRPr lang="en-US" sz="3000" dirty="0"/>
+          </a:p>
+        </p:txBody>
+      </p:sp>
+      <p:sp>
+        <p:nvSpPr>
+          <p:cNvPr id="4" name="REC dot"/>
+          <p:cNvSpPr/>
+          <p:nvPr/>
+        </p:nvSpPr>
+        <p:spPr>
+          <a:xfrm>
+            <a:off x="7360920" y="429768"/>
+            <a:ext cx="118872" cy="118872"/>
+          </a:xfrm>
+          <a:prstGeom prst="ellipse">
+            <a:avLst/>
+          </a:prstGeom>
+          <a:solidFill>
+            <a:schemeClr val="accent1"/>
+          </a:solidFill>
+          <a:ln/>
+        </p:spPr>
+      </p:sp>
+      <p:sp>
+        <p:nvSpPr>
+          <p:cNvPr id="5" name="Timecode"/>
+          <p:cNvSpPr txBox="1"/>
+          <p:nvPr/>
+        </p:nvSpPr>
+        <p:spPr>
+          <a:xfrm>
+            <a:off x="7543800" y="365760"/>
+            <a:ext cx="1051560" cy="246888"/>
+          </a:xfrm>
+          <a:prstGeom prst="rect">
+            <a:avLst/>
+          </a:prstGeom>
+          <a:noFill/>
+          <a:ln/>
+        </p:spPr>
+        <p:txBody>
+          <a:bodyPr wrap="square" lIns="0" tIns="0" rIns="0" bIns="0" rtlCol="0" anchor="ctr"/>
+          <a:lstStyle/>
+          <a:p>
+            <a:pPr algn="r" indent="0" marL="0">
+              <a:buNone/>
+            </a:pPr>
+            <a:r>
+              <a:rPr lang="en-US" sz="900" b="1" dirty="0">
+                <a:solidFill>
+                  <a:schemeClr val="accent3"/>
+                </a:solidFill>
+              </a:rPr>
+              <a:t>REC  00:00:06:00</a:t>
+            </a:r>
+            <a:endParaRPr lang="en-US" sz="900" dirty="0"/>
+          </a:p>
+        </p:txBody>
+      </p:sp>
+      <p:sp>
+        <p:nvSpPr>
+          <p:cNvPr id="6" name="Price 500 kr"/>
+          <p:cNvSpPr/>
+          <p:nvPr/>
+        </p:nvSpPr>
+        <p:spPr>
+          <a:xfrm>
+            <a:off x="548640" y="1600200"/>
+            <a:ext cx="1536192" cy="2834640"/>
+          </a:xfrm>
+          <a:prstGeom prst="roundRect">
+            <a:avLst>
+              <a:gd name="adj" fmla="val 5952"/>
+            </a:avLst>
+          </a:prstGeom>
+          <a:solidFill>
+            <a:schemeClr val="tx2"/>
+          </a:solidFill>
+          <a:ln w="12700">
+            <a:solidFill>
+              <a:schemeClr val="accent2"/>
+            </a:solidFill>
+            <a:prstDash val="solid"/>
+          </a:ln>
+        </p:spPr>
+      </p:sp>
+      <p:sp>
+        <p:nvSpPr>
+          <p:cNvPr id="7" name="Text 5"/>
+          <p:cNvSpPr txBox="1"/>
+          <p:nvPr/>
+        </p:nvSpPr>
+        <p:spPr>
+          <a:xfrm>
+            <a:off x="713232" y="1783080"/>
+            <a:ext cx="1280160" cy="548640"/>
+          </a:xfrm>
+          <a:prstGeom prst="rect">
+            <a:avLst/>
+          </a:prstGeom>
+          <a:noFill/>
+          <a:ln/>
+        </p:spPr>
+        <p:txBody>
+          <a:bodyPr wrap="square" lIns="0" tIns="0" rIns="0" bIns="0" rtlCol="0" anchor="ctr"/>
+          <a:lstStyle/>
+          <a:p>
+            <a:pPr indent="0" marL="0">
+              <a:buNone/>
+            </a:pPr>
+            <a:r>
+              <a:rPr lang="en-US" sz="3000" b="1" dirty="0">
+                <a:solidFill>
+                  <a:schemeClr val="accent1"/>
+                </a:solidFill>
+              </a:rPr>
+              <a:t>500 kr</a:t>
+            </a:r>
+            <a:endParaRPr lang="en-US" sz="3000" dirty="0"/>
+          </a:p>
+        </p:txBody>
+      </p:sp>
+      <p:sp>
+        <p:nvSpPr>
+          <p:cNvPr id="8" name="Text 6"/>
+          <p:cNvSpPr txBox="1"/>
+          <p:nvPr/>
+        </p:nvSpPr>
+        <p:spPr>
+          <a:xfrm>
+            <a:off x="713232" y="2377440"/>
+            <a:ext cx="1280160" cy="502920"/>
+          </a:xfrm>
+          <a:prstGeom prst="rect">
+            <a:avLst/>
+          </a:prstGeom>
+          <a:noFill/>
+          <a:ln/>
+        </p:spPr>
+        <p:txBody>
+          <a:bodyPr wrap="square" lIns="0" tIns="0" rIns="0" bIns="0" rtlCol="0" anchor="t"/>
+          <a:lstStyle/>
+          <a:p>
+            <a:pPr indent="0" marL="0">
+              <a:buNone/>
+            </a:pPr>
+            <a:r>
+              <a:rPr lang="en-US" sz="1400" b="1" dirty="0">
+                <a:solidFill>
+                  <a:schemeClr val="bg1"/>
+                </a:solidFill>
+              </a:rPr>
+              <a:t>per bokat hembesök</a:t>
+            </a:r>
+            <a:endParaRPr lang="en-US" sz="1400" dirty="0"/>
+          </a:p>
+        </p:txBody>
+      </p:sp>
+      <p:sp>
+        <p:nvSpPr>
+          <p:cNvPr id="9" name="Text 7"/>
+          <p:cNvSpPr txBox="1"/>
+          <p:nvPr/>
+        </p:nvSpPr>
+        <p:spPr>
+          <a:xfrm>
+            <a:off x="713232" y="3017520"/>
+            <a:ext cx="1261872" cy="1280160"/>
+          </a:xfrm>
+          <a:prstGeom prst="rect">
+            <a:avLst/>
+          </a:prstGeom>
+          <a:noFill/>
+          <a:ln/>
+        </p:spPr>
+        <p:txBody>
+          <a:bodyPr wrap="square" lIns="0" tIns="0" rIns="0" bIns="0" rtlCol="0" anchor="t"/>
+          <a:lstStyle/>
+          <a:p>
+            <a:pPr indent="0" marL="0">
+              <a:buNone/>
+            </a:pPr>
+            <a:r>
+              <a:rPr lang="en-US" sz="1200" dirty="0">
+                <a:solidFill>
+                  <a:schemeClr val="accent4"/>
+                </a:solidFill>
+              </a:rPr>
+              <a:t>För varje kvalificerat besök i er kalender.</a:t>
+            </a:r>
+            <a:endParaRPr lang="en-US" sz="1200" dirty="0"/>
+          </a:p>
+        </p:txBody>
+      </p:sp>
+      <p:sp>
+        <p:nvSpPr>
+          <p:cNvPr id="10" name="Price 5 %"/>
+          <p:cNvSpPr/>
+          <p:nvPr/>
+        </p:nvSpPr>
+        <p:spPr>
+          <a:xfrm>
+            <a:off x="2221992" y="1600200"/>
+            <a:ext cx="1536192" cy="2834640"/>
+          </a:xfrm>
+          <a:prstGeom prst="roundRect">
+            <a:avLst>
+              <a:gd name="adj" fmla="val 5952"/>
+            </a:avLst>
+          </a:prstGeom>
+          <a:solidFill>
+            <a:schemeClr val="tx2"/>
+          </a:solidFill>
+          <a:ln w="12700">
+            <a:solidFill>
+              <a:schemeClr val="accent2"/>
+            </a:solidFill>
+            <a:prstDash val="solid"/>
+          </a:ln>
+        </p:spPr>
+      </p:sp>
+      <p:sp>
+        <p:nvSpPr>
+          <p:cNvPr id="11" name="Text 9"/>
+          <p:cNvSpPr txBox="1"/>
+          <p:nvPr/>
+        </p:nvSpPr>
+        <p:spPr>
+          <a:xfrm>
+            <a:off x="2386584" y="1783080"/>
+            <a:ext cx="1280160" cy="548640"/>
+          </a:xfrm>
+          <a:prstGeom prst="rect">
+            <a:avLst/>
+          </a:prstGeom>
+          <a:noFill/>
+          <a:ln/>
+        </p:spPr>
+        <p:txBody>
+          <a:bodyPr wrap="square" lIns="0" tIns="0" rIns="0" bIns="0" rtlCol="0" anchor="ctr"/>
+          <a:lstStyle/>
+          <a:p>
+            <a:pPr indent="0" marL="0">
+              <a:buNone/>
+            </a:pPr>
+            <a:r>
+              <a:rPr lang="en-US" sz="3000" b="1" dirty="0">
+                <a:solidFill>
+                  <a:schemeClr val="accent1"/>
+                </a:solidFill>
+              </a:rPr>
+              <a:t>5 %</a:t>
+            </a:r>
+            <a:endParaRPr lang="en-US" sz="3000" dirty="0"/>
+          </a:p>
+        </p:txBody>
+      </p:sp>
+      <p:sp>
+        <p:nvSpPr>
+          <p:cNvPr id="12" name="Text 10"/>
+          <p:cNvSpPr txBox="1"/>
+          <p:nvPr/>
+        </p:nvSpPr>
+        <p:spPr>
+          <a:xfrm>
+            <a:off x="2386584" y="2377440"/>
+            <a:ext cx="1280160" cy="502920"/>
+          </a:xfrm>
+          <a:prstGeom prst="rect">
+            <a:avLst/>
+          </a:prstGeom>
+          <a:noFill/>
+          <a:ln/>
+        </p:spPr>
+        <p:txBody>
+          <a:bodyPr wrap="square" lIns="0" tIns="0" rIns="0" bIns="0" rtlCol="0" anchor="t"/>
+          <a:lstStyle/>
+          <a:p>
+            <a:pPr indent="0" marL="0">
+              <a:buNone/>
+            </a:pPr>
+            <a:r>
+              <a:rPr lang="en-US" sz="1400" b="1" dirty="0">
+                <a:solidFill>
+                  <a:schemeClr val="bg1"/>
+                </a:solidFill>
+              </a:rPr>
+              <a:t>av vinsten</a:t>
+            </a:r>
+            <a:endParaRPr lang="en-US" sz="1400" dirty="0"/>
+          </a:p>
+        </p:txBody>
+      </p:sp>
+      <p:sp>
+        <p:nvSpPr>
+          <p:cNvPr id="13" name="Text 11"/>
+          <p:cNvSpPr txBox="1"/>
+          <p:nvPr/>
+        </p:nvSpPr>
+        <p:spPr>
+          <a:xfrm>
+            <a:off x="2386584" y="3017520"/>
+            <a:ext cx="1261872" cy="1280160"/>
+          </a:xfrm>
+          <a:prstGeom prst="rect">
+            <a:avLst/>
+          </a:prstGeom>
+          <a:noFill/>
+          <a:ln/>
+        </p:spPr>
+        <p:txBody>
+          <a:bodyPr wrap="square" lIns="0" tIns="0" rIns="0" bIns="0" rtlCol="0" anchor="t"/>
+          <a:lstStyle/>
+          <a:p>
+            <a:pPr indent="0" marL="0">
+              <a:buNone/>
+            </a:pPr>
+            <a:r>
+              <a:rPr lang="en-US" sz="1200" dirty="0">
+                <a:solidFill>
+                  <a:schemeClr val="accent4"/>
+                </a:solidFill>
+              </a:rPr>
+              <a:t>På de jobb ni vinner från våra besök.</a:t>
+            </a:r>
+            <a:endParaRPr lang="en-US" sz="1200" dirty="0"/>
+          </a:p>
+        </p:txBody>
+      </p:sp>
+      <p:sp>
+        <p:nvSpPr>
+          <p:cNvPr id="14" name="Price 300 kr"/>
+          <p:cNvSpPr/>
+          <p:nvPr/>
+        </p:nvSpPr>
+        <p:spPr>
+          <a:xfrm>
+            <a:off x="3895344" y="1600200"/>
+            <a:ext cx="1536192" cy="2834640"/>
+          </a:xfrm>
+          <a:prstGeom prst="roundRect">
+            <a:avLst>
+              <a:gd name="adj" fmla="val 5952"/>
+            </a:avLst>
+          </a:prstGeom>
+          <a:solidFill>
+            <a:schemeClr val="tx2"/>
+          </a:solidFill>
+          <a:ln w="12700">
+            <a:solidFill>
+              <a:schemeClr val="accent2"/>
+            </a:solidFill>
+            <a:prstDash val="solid"/>
+          </a:ln>
+        </p:spPr>
+      </p:sp>
+      <p:sp>
+        <p:nvSpPr>
+          <p:cNvPr id="15" name="Text 13"/>
+          <p:cNvSpPr txBox="1"/>
+          <p:nvPr/>
+        </p:nvSpPr>
+        <p:spPr>
+          <a:xfrm>
+            <a:off x="4059936" y="1783080"/>
+            <a:ext cx="1280160" cy="548640"/>
+          </a:xfrm>
+          <a:prstGeom prst="rect">
+            <a:avLst/>
+          </a:prstGeom>
+          <a:noFill/>
+          <a:ln/>
+        </p:spPr>
+        <p:txBody>
+          <a:bodyPr wrap="square" lIns="0" tIns="0" rIns="0" bIns="0" rtlCol="0" anchor="ctr"/>
+          <a:lstStyle/>
+          <a:p>
+            <a:pPr indent="0" marL="0">
+              <a:buNone/>
+            </a:pPr>
+            <a:r>
+              <a:rPr lang="en-US" sz="3000" b="1" dirty="0">
+                <a:solidFill>
+                  <a:schemeClr val="accent1"/>
+                </a:solidFill>
+              </a:rPr>
+              <a:t>300 kr</a:t>
+            </a:r>
+            <a:endParaRPr lang="en-US" sz="3000" dirty="0"/>
+          </a:p>
+        </p:txBody>
+      </p:sp>
+      <p:sp>
+        <p:nvSpPr>
+          <p:cNvPr id="16" name="Text 14"/>
+          <p:cNvSpPr txBox="1"/>
+          <p:nvPr/>
+        </p:nvSpPr>
+        <p:spPr>
+          <a:xfrm>
+            <a:off x="4059936" y="2377440"/>
+            <a:ext cx="1280160" cy="502920"/>
+          </a:xfrm>
+          <a:prstGeom prst="rect">
+            <a:avLst/>
+          </a:prstGeom>
+          <a:noFill/>
+          <a:ln/>
+        </p:spPr>
+        <p:txBody>
+          <a:bodyPr wrap="square" lIns="0" tIns="0" rIns="0" bIns="0" rtlCol="0" anchor="t"/>
+          <a:lstStyle/>
+          <a:p>
+            <a:pPr indent="0" marL="0">
+              <a:buNone/>
+            </a:pPr>
+            <a:r>
+              <a:rPr lang="en-US" sz="1400" b="1" dirty="0">
+                <a:solidFill>
+                  <a:schemeClr val="bg1"/>
+                </a:solidFill>
+              </a:rPr>
+              <a:t>per dag i annonser</a:t>
+            </a:r>
+            <a:endParaRPr lang="en-US" sz="1400" dirty="0"/>
+          </a:p>
+        </p:txBody>
+      </p:sp>
+      <p:sp>
+        <p:nvSpPr>
+          <p:cNvPr id="17" name="Text 15"/>
+          <p:cNvSpPr txBox="1"/>
+          <p:nvPr/>
+        </p:nvSpPr>
+        <p:spPr>
+          <a:xfrm>
+            <a:off x="4059936" y="3017520"/>
+            <a:ext cx="1261872" cy="1280160"/>
+          </a:xfrm>
+          <a:prstGeom prst="rect">
+            <a:avLst/>
+          </a:prstGeom>
+          <a:noFill/>
+          <a:ln/>
+        </p:spPr>
+        <p:txBody>
+          <a:bodyPr wrap="square" lIns="0" tIns="0" rIns="0" bIns="0" rtlCol="0" anchor="t"/>
+          <a:lstStyle/>
+          <a:p>
+            <a:pPr indent="0" marL="0">
+              <a:buNone/>
+            </a:pPr>
+            <a:r>
+              <a:rPr lang="en-US" sz="1200" dirty="0">
+                <a:solidFill>
+                  <a:schemeClr val="accent4"/>
+                </a:solidFill>
+              </a:rPr>
+              <a:t>Går direkt till Meta. Ca 9 000 kr/mån.</a:t>
+            </a:r>
+            <a:endParaRPr lang="en-US" sz="1200" dirty="0"/>
+          </a:p>
+        </p:txBody>
+      </p:sp>
+      <p:sp>
+        <p:nvSpPr>
+          <p:cNvPr id="18" name="Example box"/>
+          <p:cNvSpPr/>
+          <p:nvPr/>
+        </p:nvSpPr>
+        <p:spPr>
+          <a:xfrm>
+            <a:off x="5669280" y="1600200"/>
+            <a:ext cx="2926080" cy="2834640"/>
+          </a:xfrm>
+          <a:prstGeom prst="roundRect">
+            <a:avLst>
+              <a:gd name="adj" fmla="val 3226"/>
+            </a:avLst>
+          </a:prstGeom>
+          <a:solidFill>
+            <a:schemeClr val="accent1"/>
+          </a:solidFill>
+          <a:ln/>
+        </p:spPr>
+      </p:sp>
+      <p:sp>
+        <p:nvSpPr>
+          <p:cNvPr id="19" name="Text 17"/>
+          <p:cNvSpPr txBox="1"/>
+          <p:nvPr/>
+        </p:nvSpPr>
+        <p:spPr>
+          <a:xfrm>
+            <a:off x="5870448" y="1755648"/>
+            <a:ext cx="2560320" cy="228600"/>
+          </a:xfrm>
+          <a:prstGeom prst="rect">
+            <a:avLst/>
+          </a:prstGeom>
+          <a:noFill/>
+          <a:ln/>
+        </p:spPr>
+        <p:txBody>
+          <a:bodyPr wrap="square" lIns="0" tIns="0" rIns="0" bIns="0" rtlCol="0" anchor="ctr"/>
+          <a:lstStyle/>
+          <a:p>
+            <a:pPr indent="0" marL="0">
+              <a:buNone/>
+            </a:pPr>
+            <a:r>
+              <a:rPr lang="en-US" sz="900" b="1" spc="200" kern="0" dirty="0">
+                <a:solidFill>
+                  <a:schemeClr val="tx1"/>
+                </a:solidFill>
+              </a:rPr>
+              <a:t>RÄKNEEXEMPEL · 1 MÅNAD</a:t>
+            </a:r>
+            <a:endParaRPr lang="en-US" sz="900" dirty="0"/>
+          </a:p>
+        </p:txBody>
+      </p:sp>
+      <p:sp>
+        <p:nvSpPr>
+          <p:cNvPr id="20" name="Text 18"/>
+          <p:cNvSpPr txBox="1"/>
+          <p:nvPr/>
+        </p:nvSpPr>
+        <p:spPr>
+          <a:xfrm>
+            <a:off x="5870448" y="2075688"/>
+            <a:ext cx="1737360" cy="274320"/>
+          </a:xfrm>
+          <a:prstGeom prst="rect">
+            <a:avLst/>
+          </a:prstGeom>
+          <a:noFill/>
+          <a:ln/>
+        </p:spPr>
+        <p:txBody>
+          <a:bodyPr wrap="square" lIns="0" tIns="0" rIns="0" bIns="0" rtlCol="0" anchor="ctr"/>
+          <a:lstStyle/>
+          <a:p>
+            <a:pPr indent="0" marL="0">
+              <a:buNone/>
+            </a:pPr>
+            <a:r>
+              <a:rPr lang="en-US" sz="1200" dirty="0">
+                <a:solidFill>
+                  <a:schemeClr val="tx1"/>
+                </a:solidFill>
+              </a:rPr>
+              <a:t>Annonser 30 × 300 kr</a:t>
+            </a:r>
+            <a:endParaRPr lang="en-US" sz="1200" dirty="0"/>
+          </a:p>
+        </p:txBody>
+      </p:sp>
+      <p:sp>
+        <p:nvSpPr>
+          <p:cNvPr id="21" name="Text 19"/>
+          <p:cNvSpPr txBox="1"/>
+          <p:nvPr/>
+        </p:nvSpPr>
+        <p:spPr>
+          <a:xfrm>
+            <a:off x="7498080" y="2075688"/>
+            <a:ext cx="914400" cy="274320"/>
+          </a:xfrm>
+          <a:prstGeom prst="rect">
+            <a:avLst/>
+          </a:prstGeom>
+          <a:noFill/>
+          <a:ln/>
+        </p:spPr>
+        <p:txBody>
+          <a:bodyPr wrap="square" lIns="0" tIns="0" rIns="0" bIns="0" rtlCol="0" anchor="ctr"/>
+          <a:lstStyle/>
+          <a:p>
+            <a:pPr algn="r" indent="0" marL="0">
+              <a:buNone/>
+            </a:pPr>
+            <a:r>
+              <a:rPr lang="en-US" sz="1200" b="1" dirty="0">
+                <a:solidFill>
+                  <a:schemeClr val="tx1"/>
+                </a:solidFill>
+              </a:rPr>
+              <a:t>9 000 kr</a:t>
+            </a:r>
+            <a:endParaRPr lang="en-US" sz="1200" dirty="0"/>
+          </a:p>
+        </p:txBody>
+      </p:sp>
+      <p:sp>
+        <p:nvSpPr>
+          <p:cNvPr id="22" name="Text 20"/>
+          <p:cNvSpPr txBox="1"/>
+          <p:nvPr/>
+        </p:nvSpPr>
+        <p:spPr>
+          <a:xfrm>
+            <a:off x="5870448" y="2404872"/>
+            <a:ext cx="1737360" cy="274320"/>
+          </a:xfrm>
+          <a:prstGeom prst="rect">
+            <a:avLst/>
+          </a:prstGeom>
+          <a:noFill/>
+          <a:ln/>
+        </p:spPr>
+        <p:txBody>
+          <a:bodyPr wrap="square" lIns="0" tIns="0" rIns="0" bIns="0" rtlCol="0" anchor="ctr"/>
+          <a:lstStyle/>
+          <a:p>
+            <a:pPr indent="0" marL="0">
+              <a:buNone/>
+            </a:pPr>
+            <a:r>
+              <a:rPr lang="en-US" sz="1200" dirty="0">
+                <a:solidFill>
+                  <a:schemeClr val="tx1"/>
+                </a:solidFill>
+              </a:rPr>
+              <a:t>10 hembesök × 500 kr</a:t>
+            </a:r>
+            <a:endParaRPr lang="en-US" sz="1200" dirty="0"/>
+          </a:p>
+        </p:txBody>
+      </p:sp>
+      <p:sp>
+        <p:nvSpPr>
+          <p:cNvPr id="23" name="Text 21"/>
+          <p:cNvSpPr txBox="1"/>
+          <p:nvPr/>
+        </p:nvSpPr>
+        <p:spPr>
+          <a:xfrm>
+            <a:off x="7498080" y="2404872"/>
+            <a:ext cx="914400" cy="274320"/>
+          </a:xfrm>
+          <a:prstGeom prst="rect">
+            <a:avLst/>
+          </a:prstGeom>
+          <a:noFill/>
+          <a:ln/>
+        </p:spPr>
+        <p:txBody>
+          <a:bodyPr wrap="square" lIns="0" tIns="0" rIns="0" bIns="0" rtlCol="0" anchor="ctr"/>
+          <a:lstStyle/>
+          <a:p>
+            <a:pPr algn="r" indent="0" marL="0">
+              <a:buNone/>
+            </a:pPr>
+            <a:r>
+              <a:rPr lang="en-US" sz="1200" b="1" dirty="0">
+                <a:solidFill>
+                  <a:schemeClr val="tx1"/>
+                </a:solidFill>
+              </a:rPr>
+              <a:t>5 000 kr</a:t>
+            </a:r>
+            <a:endParaRPr lang="en-US" sz="1200" dirty="0"/>
+          </a:p>
+        </p:txBody>
+      </p:sp>
+      <p:sp>
+        <p:nvSpPr>
+          <p:cNvPr id="24" name="Text 22"/>
+          <p:cNvSpPr txBox="1"/>
+          <p:nvPr/>
+        </p:nvSpPr>
+        <p:spPr>
+          <a:xfrm>
+            <a:off x="5870448" y="2734056"/>
+            <a:ext cx="1737360" cy="274320"/>
+          </a:xfrm>
+          <a:prstGeom prst="rect">
+            <a:avLst/>
+          </a:prstGeom>
+          <a:noFill/>
+          <a:ln/>
+        </p:spPr>
+        <p:txBody>
+          <a:bodyPr wrap="square" lIns="0" tIns="0" rIns="0" bIns="0" rtlCol="0" anchor="ctr"/>
+          <a:lstStyle/>
+          <a:p>
+            <a:pPr indent="0" marL="0">
+              <a:buNone/>
+            </a:pPr>
+            <a:r>
+              <a:rPr lang="en-US" sz="1200" dirty="0">
+                <a:solidFill>
+                  <a:schemeClr val="tx1"/>
+                </a:solidFill>
+              </a:rPr>
+              <a:t>5 % av 150 000 kr</a:t>
+            </a:r>
+            <a:endParaRPr lang="en-US" sz="1200" dirty="0"/>
+          </a:p>
+        </p:txBody>
+      </p:sp>
+      <p:sp>
+        <p:nvSpPr>
+          <p:cNvPr id="25" name="Text 23"/>
+          <p:cNvSpPr txBox="1"/>
+          <p:nvPr/>
+        </p:nvSpPr>
+        <p:spPr>
+          <a:xfrm>
+            <a:off x="7498080" y="2734056"/>
+            <a:ext cx="914400" cy="274320"/>
+          </a:xfrm>
+          <a:prstGeom prst="rect">
+            <a:avLst/>
+          </a:prstGeom>
+          <a:noFill/>
+          <a:ln/>
+        </p:spPr>
+        <p:txBody>
+          <a:bodyPr wrap="square" lIns="0" tIns="0" rIns="0" bIns="0" rtlCol="0" anchor="ctr"/>
+          <a:lstStyle/>
+          <a:p>
+            <a:pPr algn="r" indent="0" marL="0">
+              <a:buNone/>
+            </a:pPr>
+            <a:r>
+              <a:rPr lang="en-US" sz="1200" b="1" dirty="0">
+                <a:solidFill>
+                  <a:schemeClr val="tx1"/>
+                </a:solidFill>
+              </a:rPr>
+              <a:t>7 500 kr</a:t>
+            </a:r>
+            <a:endParaRPr lang="en-US" sz="1200" dirty="0"/>
+          </a:p>
+        </p:txBody>
+      </p:sp>
+      <p:sp>
+        <p:nvSpPr>
+          <p:cNvPr id="26" name="Shape 24"/>
+          <p:cNvSpPr/>
+          <p:nvPr/>
+        </p:nvSpPr>
+        <p:spPr>
+          <a:xfrm>
+            <a:off x="5870448" y="3099816"/>
+            <a:ext cx="2542032" cy="0"/>
+          </a:xfrm>
+          <a:prstGeom prst="line">
+            <a:avLst/>
+          </a:prstGeom>
+          <a:noFill/>
+          <a:ln w="12700">
+            <a:solidFill>
+              <a:schemeClr val="tx1"/>
+            </a:solidFill>
+            <a:prstDash val="solid"/>
+          </a:ln>
+        </p:spPr>
+      </p:sp>
+      <p:sp>
+        <p:nvSpPr>
+          <p:cNvPr id="27" name="Text 25"/>
+          <p:cNvSpPr txBox="1"/>
+          <p:nvPr/>
+        </p:nvSpPr>
+        <p:spPr>
+          <a:xfrm>
+            <a:off x="5870448" y="3154680"/>
+            <a:ext cx="1371600" cy="292608"/>
+          </a:xfrm>
+          <a:prstGeom prst="rect">
+            <a:avLst/>
+          </a:prstGeom>
+          <a:noFill/>
+          <a:ln/>
+        </p:spPr>
+        <p:txBody>
+          <a:bodyPr wrap="square" lIns="0" tIns="0" rIns="0" bIns="0" rtlCol="0" anchor="ctr"/>
+          <a:lstStyle/>
+          <a:p>
+            <a:pPr indent="0" marL="0">
+              <a:buNone/>
+            </a:pPr>
+            <a:r>
+              <a:rPr lang="en-US" sz="1300" b="1" dirty="0">
+                <a:solidFill>
+                  <a:schemeClr val="tx1"/>
+                </a:solidFill>
+              </a:rPr>
+              <a:t>Totalt</a:t>
+            </a:r>
+            <a:endParaRPr lang="en-US" sz="1300" dirty="0"/>
+          </a:p>
+        </p:txBody>
+      </p:sp>
+      <p:sp>
+        <p:nvSpPr>
+          <p:cNvPr id="28" name="Text 26"/>
+          <p:cNvSpPr txBox="1"/>
+          <p:nvPr/>
+        </p:nvSpPr>
+        <p:spPr>
+          <a:xfrm>
+            <a:off x="7223760" y="3154680"/>
+            <a:ext cx="1188720" cy="292608"/>
+          </a:xfrm>
+          <a:prstGeom prst="rect">
+            <a:avLst/>
+          </a:prstGeom>
+          <a:noFill/>
+          <a:ln/>
+        </p:spPr>
+        <p:txBody>
+          <a:bodyPr wrap="square" lIns="0" tIns="0" rIns="0" bIns="0" rtlCol="0" anchor="ctr"/>
+          <a:lstStyle/>
+          <a:p>
+            <a:pPr algn="r" indent="0" marL="0">
+              <a:buNone/>
+            </a:pPr>
+            <a:r>
+              <a:rPr lang="en-US" sz="1300" b="1" dirty="0">
+                <a:solidFill>
+                  <a:schemeClr val="tx1"/>
+                </a:solidFill>
+              </a:rPr>
+              <a:t>21 500 kr</a:t>
+            </a:r>
+            <a:endParaRPr lang="en-US" sz="1300" dirty="0"/>
+          </a:p>
+        </p:txBody>
+      </p:sp>
+      <p:sp>
+        <p:nvSpPr>
+          <p:cNvPr id="29" name="Text 27"/>
+          <p:cNvSpPr txBox="1"/>
+          <p:nvPr/>
+        </p:nvSpPr>
+        <p:spPr>
+          <a:xfrm>
+            <a:off x="5870448" y="3566160"/>
+            <a:ext cx="2560320" cy="731520"/>
+          </a:xfrm>
+          <a:prstGeom prst="rect">
+            <a:avLst/>
+          </a:prstGeom>
+          <a:noFill/>
+          <a:ln/>
+        </p:spPr>
+        <p:txBody>
+          <a:bodyPr wrap="square" lIns="0" tIns="0" rIns="0" bIns="0" rtlCol="0" anchor="t"/>
+          <a:lstStyle/>
+          <a:p>
+            <a:pPr indent="0" marL="0">
+              <a:buNone/>
+            </a:pPr>
+            <a:r>
+              <a:rPr lang="en-US" sz="2800" b="1" dirty="0">
+                <a:solidFill>
+                  <a:schemeClr val="bg1"/>
+                </a:solidFill>
+              </a:rPr>
+              <a:t>95 %</a:t>
+            </a:r>
+            <a:endParaRPr lang="en-US" sz="2800" dirty="0"/>
+          </a:p>
+          <a:p>
+            <a:pPr indent="0" marL="0">
+              <a:buNone/>
+            </a:pPr>
+            <a:r>
+              <a:rPr lang="en-US" sz="1200" b="1" dirty="0">
+                <a:solidFill>
+                  <a:schemeClr val="tx1"/>
+                </a:solidFill>
+              </a:rPr>
+              <a:t>av vinsten behåller ni</a:t>
+            </a:r>
+            <a:endParaRPr lang="en-US" sz="2800" dirty="0"/>
+          </a:p>
+        </p:txBody>
+      </p:sp>
+      <p:sp>
+        <p:nvSpPr>
+          <p:cNvPr id="30" name="Text 28"/>
+          <p:cNvSpPr txBox="1"/>
+          <p:nvPr/>
+        </p:nvSpPr>
+        <p:spPr>
+          <a:xfrm>
+            <a:off x="2743200" y="4681728"/>
+            <a:ext cx="4846320" cy="228600"/>
+          </a:xfrm>
+          <a:prstGeom prst="rect">
+            <a:avLst/>
+          </a:prstGeom>
+          <a:noFill/>
+          <a:ln/>
+        </p:spPr>
+        <p:txBody>
+          <a:bodyPr wrap="square" lIns="0" tIns="0" rIns="0" bIns="0" rtlCol="0" anchor="ctr"/>
+          <a:lstStyle/>
+          <a:p>
+            <a:pPr algn="ctr" indent="0" marL="0">
+              <a:buNone/>
+            </a:pPr>
+            <a:r>
+              <a:rPr lang="en-US" sz="900" dirty="0">
+                <a:solidFill>
+                  <a:schemeClr val="accent3"/>
+                </a:solidFill>
+              </a:rPr>
+              <a:t>Exempelsiffror – faktiskt utfall varierar per företag och område</a:t>
+            </a:r>
+            <a:endParaRPr lang="en-US" sz="900" dirty="0"/>
+          </a:p>
+        </p:txBody>
+      </p:sp>
+      <p:sp>
+        <p:nvSpPr>
+          <p:cNvPr id="25" name="Slide Number Placeholder 0"/>
+          <p:cNvSpPr>
+            <a:spLocks noGrp="1"/>
+          </p:cNvSpPr>
+          <p:nvPr>
+            <p:ph type="sldNum" sz="quarter" idx="4294967295"/>
+          </p:nvPr>
+        </p:nvSpPr>
+        <p:spPr>
+          <a:xfrm>
+            <a:off x="7680960" y="4681728"/>
+            <a:ext cx="914400" cy="228600"/>
+          </a:xfrm>
+          <a:prstGeom prst="rect">
+            <a:avLst/>
+          </a:prstGeom>
+          <a:extLst>
+            <a:ext uri="{C572A759-6A51-4108-AA02-DFA0A04FC94B}">
+              <ma14:wrappingTextBoxFlag xmlns:ma14="http://schemas.microsoft.com/office/mac/drawingml/2011/main" val="0"/>
+            </a:ext>
+          </a:extLst>
+        </p:spPr>
+        <p:txBody>
+          <a:bodyPr/>
+          <a:lstStyle>
+            <a:lvl1pPr>
+              <a:defRPr sz="1000">
+                <a:solidFill>
+                  <a:schemeClr val="accent3"/>
+                </a:solidFill>
+              </a:defRPr>
+            </a:lvl1pPr>
+          </a:lstStyle>
+          <a:p>
+            <a:pPr algn="r"/>
+            <a:fld id="{F7021451-1387-4CA6-816F-3879F97B5CBC}" type="slidenum">
+              <a:rPr b="0" lang="en-US"/>
+              <a:t>6</a:t>
+            </a:fld>
+            <a:endParaRPr lang="en-US"/>
+          </a:p>
+        </p:txBody>
+      </p:sp>
+    </p:spTree>
+  </p:cSld>
+  <p:clrMapOvr>
+    <a:masterClrMapping/>
+  </p:clrMapOvr>
+  <p:transition spd="med">
+    <p:fade/>
+  </p:transition>
+</p:sld>
+</file>
+
+<file path=ppt/slides/slide7.xml><?xml version="1.0" encoding="utf-8"?>
+<p:sld xmlns:a="http://schemas.openxmlformats.org/drawingml/2006/main" xmlns:r="http://schemas.openxmlformats.org/officeDocument/2006/relationships" xmlns:p="http://schemas.openxmlformats.org/presentationml/2006/main">
+  <p:cSld name="Slide 7">
+    <p:spTree>
+      <p:nvGrpSpPr>
+        <p:cNvPr id="1" name=""/>
+        <p:cNvGrpSpPr/>
+        <p:nvPr/>
+      </p:nvGrpSpPr>
+      <p:grpSpPr>
+        <a:xfrm>
+          <a:off x="0" y="0"/>
+          <a:ext cx="0" cy="0"/>
+          <a:chOff x="0" y="0"/>
+          <a:chExt cx="0" cy="0"/>
+        </a:xfrm>
+      </p:grpSpPr>
+      <p:sp>
+        <p:nvSpPr>
           <p:cNvPr id="2" name="REC dot"/>
           <p:cNvSpPr/>
           <p:nvPr/>
@@ -8073,7 +9270,7 @@
                   <a:schemeClr val="tx1"/>
                 </a:solidFill>
               </a:rPr>
-              <a:t>REC  00:00:06:00</a:t>
+              <a:t>REC  00:00:07:00</a:t>
             </a:r>
             <a:endParaRPr lang="en-US" sz="900" dirty="0"/>
           </a:p>
@@ -8296,7 +9493,7 @@
                   <a:schemeClr val="tx1"/>
                 </a:solidFill>
               </a:rPr>
-              <a:t>Uppstartsmöte</a:t>
+              <a:t>Signera avtalet</a:t>
             </a:r>
             <a:endParaRPr lang="en-US" sz="1600" dirty="0"/>
           </a:p>
@@ -8332,7 +9529,7 @@
                   <a:schemeClr val="tx2"/>
                 </a:solidFill>
               </a:rPr>
-              <a:t>Tjänster, område och drömkund.</a:t>
+              <a:t>Digitalt via länk – direkt under mötet.</a:t>
             </a:r>
             <a:endParaRPr lang="en-US" sz="1400" dirty="0"/>
           </a:p>
@@ -8424,7 +9621,7 @@
                   <a:schemeClr val="tx1"/>
                 </a:solidFill>
               </a:rPr>
-              <a:t>Produktion</a:t>
+              <a:t>Skicka material</a:t>
             </a:r>
             <a:endParaRPr lang="en-US" sz="1600" dirty="0"/>
           </a:p>
@@ -8460,7 +9657,7 @@
                   <a:schemeClr val="tx2"/>
                 </a:solidFill>
               </a:rPr>
-              <a:t>Videoannonser och kvalificeringsformulär.</a:t>
+              <a:t>Bilder och filmer från era jobb i en Google Drive-mapp.</a:t>
             </a:r>
             <a:endParaRPr lang="en-US" sz="1400" dirty="0"/>
           </a:p>
@@ -8552,7 +9749,7 @@
                   <a:schemeClr val="tx1"/>
                 </a:solidFill>
               </a:rPr>
-              <a:t>Annonser live</a:t>
+              <a:t>Produktion</a:t>
             </a:r>
             <a:endParaRPr lang="en-US" sz="1600" dirty="0"/>
           </a:p>
@@ -8588,7 +9785,7 @@
                   <a:schemeClr val="tx2"/>
                 </a:solidFill>
               </a:rPr>
-              <a:t>Kampanjen startar med 300 kr per dag.</a:t>
+              <a:t>Vi gör annonser och formulär. Kampanjen går live.</a:t>
             </a:r>
             <a:endParaRPr lang="en-US" sz="1400" dirty="0"/>
           </a:p>
@@ -8716,7 +9913,7 @@
                   <a:schemeClr val="tx2"/>
                 </a:solidFill>
               </a:rPr>
-              <a:t>Första kunderna bokas in i er kalender.</a:t>
+              <a:t>De första kunderna bokas in i er kalender.</a:t>
             </a:r>
             <a:endParaRPr lang="en-US" sz="1400" dirty="0"/>
           </a:p>

</xml_diff>

<commit_message>
Replace motion graphics on cover with Annonser, reword agenda step 4
Co-Authored-By: Claude Opus 5.5 <noreply@anthropic.com>
Claude-Session: https://claude.ai/code/session_01QVCR3cV59zPQJ7dR5FS4zs
</commit_message>
<xml_diff>
--- a/zdanmotion-bygg-presentation-v2.pptx
+++ b/zdanmotion-bygg-presentation-v2.pptx
@@ -113,29 +113,29 @@
   <p:extLst>
     <p:ext uri="{521415D9-36F7-43E2-AB2F-B90AF26B5E84}">
       <p14:sectionLst xmlns:p14="http://schemas.microsoft.com/office/powerpoint/2010/main">
-        <p14:section name="Intro" id="{c4891b48-c789-7068-132e-b7c98caa0d9f}">
+        <p14:section name="Intro" id="{cd1d2073-ac51-2345-7c51-3cd638137c15}">
           <p14:sldIdLst>
             <p14:sldId id="256"/>
           </p14:sldIdLst>
         </p14:section>
-        <p14:section name="Agenda" id="{4d166943-0d28-e238-539a-316e2722fb56}">
+        <p14:section name="Agenda" id="{39e6d388-2ecc-cd66-2dc5-d35c1d636ac3}">
           <p14:sldIdLst>
             <p14:sldId id="257"/>
           </p14:sldIdLst>
         </p14:section>
-        <p14:section name="Lösningen" id="{e1ab578a-ec34-8521-b2a1-106ebc5d939b}">
+        <p14:section name="Lösningen" id="{eb894d00-d450-1dae-eb70-700d0bc021aa}">
           <p14:sldIdLst>
             <p14:sldId id="258"/>
             <p14:sldId id="259"/>
             <p14:sldId id="260"/>
           </p14:sldIdLst>
         </p14:section>
-        <p14:section name="Pris" id="{cbdfc9ec-83c6-ce30-682b-727cae97a035}">
+        <p14:section name="Pris" id="{10b5dbf4-2ac0-db97-e547-552eff0b71a7}">
           <p14:sldIdLst>
             <p14:sldId id="261"/>
           </p14:sldIdLst>
         </p14:section>
-        <p14:section name="Nästa steg" id="{c4135fda-58f8-57a6-9f48-f8eebff91aa9}">
+        <p14:section name="Nästa steg" id="{f871c011-018e-d1a7-ad69-255f55311749}">
           <p14:sldIdLst>
             <p14:sldId id="262"/>
           </p14:sldIdLst>
@@ -2806,7 +2806,7 @@
                   <a:schemeClr val="accent4"/>
                 </a:solidFill>
               </a:rPr>
-              <a:t>Videoannonser med motion graphics för byggföretag. Vi kvalificerar leads och bokar hembesöken direkt i din kalender.</a:t>
+              <a:t>Videoannonser för byggföretag. Vi kvalificerar leads och bokar hembesöken direkt i din kalender.</a:t>
             </a:r>
             <a:endParaRPr lang="en-US" sz="1500" dirty="0"/>
           </a:p>
@@ -2814,14 +2814,14 @@
       </p:sp>
       <p:sp>
         <p:nvSpPr>
-          <p:cNvPr id="5" name="Chip Motion graphics"/>
+          <p:cNvPr id="5" name="Chip Annonser"/>
           <p:cNvSpPr/>
           <p:nvPr/>
         </p:nvSpPr>
         <p:spPr>
           <a:xfrm>
             <a:off x="548640" y="3520440"/>
-            <a:ext cx="1623060" cy="347472"/>
+            <a:ext cx="1078992" cy="347472"/>
           </a:xfrm>
           <a:prstGeom prst="roundRect">
             <a:avLst>
@@ -2872,7 +2872,7 @@
         <p:spPr>
           <a:xfrm>
             <a:off x="886968" y="3520440"/>
-            <a:ext cx="1239012" cy="347472"/>
+            <a:ext cx="694944" cy="347472"/>
           </a:xfrm>
           <a:prstGeom prst="rect">
             <a:avLst/>
@@ -2893,7 +2893,7 @@
                   <a:schemeClr val="bg1"/>
                 </a:solidFill>
               </a:rPr>
-              <a:t>Motion graphics</a:t>
+              <a:t>Annonser</a:t>
             </a:r>
             <a:endParaRPr lang="en-US" sz="1100" dirty="0"/>
           </a:p>
@@ -2907,7 +2907,7 @@
         </p:nvSpPr>
         <p:spPr>
           <a:xfrm>
-            <a:off x="2308860" y="3520440"/>
+            <a:off x="1764792" y="3520440"/>
             <a:ext cx="1623060" cy="347472"/>
           </a:xfrm>
           <a:prstGeom prst="roundRect">
@@ -2942,7 +2942,7 @@
         </p:blipFill>
         <p:spPr>
           <a:xfrm>
-            <a:off x="2427732" y="3611880"/>
+            <a:off x="1883664" y="3611880"/>
             <a:ext cx="164592" cy="164592"/>
           </a:xfrm>
           <a:prstGeom prst="rect">
@@ -2958,7 +2958,7 @@
         </p:nvSpPr>
         <p:spPr>
           <a:xfrm>
-            <a:off x="2647188" y="3520440"/>
+            <a:off x="2103120" y="3520440"/>
             <a:ext cx="1239012" cy="347472"/>
           </a:xfrm>
           <a:prstGeom prst="rect">
@@ -2994,7 +2994,7 @@
         </p:nvSpPr>
         <p:spPr>
           <a:xfrm>
-            <a:off x="4069080" y="3520440"/>
+            <a:off x="3525012" y="3520440"/>
             <a:ext cx="1623060" cy="347472"/>
           </a:xfrm>
           <a:prstGeom prst="roundRect">
@@ -3029,7 +3029,7 @@
         </p:blipFill>
         <p:spPr>
           <a:xfrm>
-            <a:off x="4187952" y="3611880"/>
+            <a:off x="3643884" y="3611880"/>
             <a:ext cx="164592" cy="164592"/>
           </a:xfrm>
           <a:prstGeom prst="rect">
@@ -3045,7 +3045,7 @@
         </p:nvSpPr>
         <p:spPr>
           <a:xfrm>
-            <a:off x="4407408" y="3520440"/>
+            <a:off x="3863340" y="3520440"/>
             <a:ext cx="1239012" cy="347472"/>
           </a:xfrm>
           <a:prstGeom prst="rect">
@@ -4133,7 +4133,7 @@
                   <a:schemeClr val="tx1"/>
                 </a:solidFill>
               </a:rPr>
-              <a:t>Investering och nästa steg</a:t>
+              <a:t>Investering och beslut</a:t>
             </a:r>
             <a:endParaRPr lang="en-US" sz="1500" dirty="0"/>
           </a:p>
@@ -4147,7 +4147,7 @@
                   <a:schemeClr val="accent6"/>
                 </a:solidFill>
               </a:rPr>
-              <a:t>Vi bestämmer tillsammans om vi kör.</a:t>
+              <a:t>Målet: ett tydligt ja eller nej – ska vi jobba ihop?</a:t>
             </a:r>
             <a:endParaRPr lang="en-US" sz="1500" dirty="0"/>
           </a:p>

</xml_diff>

<commit_message>
Remove price example and motion graphics wording, redesign closing slide
Co-Authored-By: Claude Opus 5.5 <noreply@anthropic.com>
Claude-Session: https://claude.ai/code/session_01QVCR3cV59zPQJ7dR5FS4zs
</commit_message>
<xml_diff>
--- a/zdanmotion-bygg-presentation-v2.pptx
+++ b/zdanmotion-bygg-presentation-v2.pptx
@@ -113,29 +113,29 @@
   <p:extLst>
     <p:ext uri="{521415D9-36F7-43E2-AB2F-B90AF26B5E84}">
       <p14:sectionLst xmlns:p14="http://schemas.microsoft.com/office/powerpoint/2010/main">
-        <p14:section name="Intro" id="{cd1d2073-ac51-2345-7c51-3cd638137c15}">
+        <p14:section name="Intro" id="{8a542d01-cf61-6a3e-0e8a-ca0dd1bb1bd1}">
           <p14:sldIdLst>
             <p14:sldId id="256"/>
           </p14:sldIdLst>
         </p14:section>
-        <p14:section name="Agenda" id="{39e6d388-2ecc-cd66-2dc5-d35c1d636ac3}">
+        <p14:section name="Agenda" id="{2f0cd821-9dd1-ce8d-39f3-0f3834c6bf2f}">
           <p14:sldIdLst>
             <p14:sldId id="257"/>
           </p14:sldIdLst>
         </p14:section>
-        <p14:section name="Lösningen" id="{eb894d00-d450-1dae-eb70-700d0bc021aa}">
+        <p14:section name="Lösningen" id="{3134b6b4-f296-244b-8e88-22128762c653}">
           <p14:sldIdLst>
             <p14:sldId id="258"/>
             <p14:sldId id="259"/>
             <p14:sldId id="260"/>
           </p14:sldIdLst>
         </p14:section>
-        <p14:section name="Pris" id="{10b5dbf4-2ac0-db97-e547-552eff0b71a7}">
+        <p14:section name="Pris" id="{96ed1a88-501c-5a06-bf6c-77f27d76a03b}">
           <p14:sldIdLst>
             <p14:sldId id="261"/>
           </p14:sldIdLst>
         </p14:section>
-        <p14:section name="Nästa steg" id="{f871c011-018e-d1a7-ad69-255f55311749}">
+        <p14:section name="Nästa steg" id="{5f0cfbf8-71ff-4666-acda-3104e4d54bea}">
           <p14:sldIdLst>
             <p14:sldId id="262"/>
           </p14:sldIdLst>
@@ -984,7 +984,7 @@
           <a:p>
             <a:r>
               <a:rPr lang="en-US" dirty="0"/>
-              <a:t>Vi tjänar mest när de tjänar mest. Annonsbudgeten går rakt till Meta och syns i deras eget annonskonto – full insyn. Byt gärna exempelsiffrorna mot kundens egna: hur många besök de klarar per månad och vad ett snittjobb ger.</a:t>
+              <a:t>Vi tjänar mest när de tjänar mest. Annonsbudgeten går rakt till Meta och syns i deras eget annonskonto – full insyn.</a:t>
             </a:r>
             <a:endParaRPr lang="en-US" dirty="0"/>
           </a:p>
@@ -1072,7 +1072,7 @@
           <a:p>
             <a:r>
               <a:rPr lang="en-US" dirty="0"/>
-              <a:t>Fråga: Vad känner du? Hur vill du gå vidare härifrån? Var tyst och låt kunden svara. Vid ja: skicka avtalet för e-signering direkt under samtalet och be om bilder och filmer i en Google Drive-mapp.</a:t>
+              <a:t>Sammanfatta kort vad de får, ställ sedan frågan: Vad känner du? Hur vill du gå vidare härifrån? Var tyst och låt kunden svara. Vid ja: skicka avtalet för e-signering direkt under samtalet och be om bilder och filmer i en Google Drive-mapp. Vid nej: helt okej – tacka för tiden.</a:t>
             </a:r>
             <a:endParaRPr lang="en-US" dirty="0"/>
           </a:p>
@@ -5196,7 +5196,7 @@
                   <a:schemeClr val="accent4"/>
                 </a:solidFill>
               </a:rPr>
-              <a:t>Motion graphics av era bilder och filmer från färdiga jobb – eller med AI.</a:t>
+              <a:t>Videoannonser av era bilder och filmer från färdiga jobb – eller med AI.</a:t>
             </a:r>
             <a:endParaRPr lang="en-US" sz="1400" dirty="0"/>
           </a:p>
@@ -8296,11 +8296,11 @@
         <p:spPr>
           <a:xfrm>
             <a:off x="548640" y="1600200"/>
-            <a:ext cx="1536192" cy="2834640"/>
+            <a:ext cx="2560320" cy="2788920"/>
           </a:xfrm>
           <a:prstGeom prst="roundRect">
             <a:avLst>
-              <a:gd name="adj" fmla="val 5952"/>
+              <a:gd name="adj" fmla="val 3571"/>
             </a:avLst>
           </a:prstGeom>
           <a:solidFill>
@@ -8316,14 +8316,58 @@
       </p:sp>
       <p:sp>
         <p:nvSpPr>
-          <p:cNvPr id="7" name="Text 5"/>
+          <p:cNvPr id="7" name="Price icon 1 circle"/>
+          <p:cNvSpPr/>
+          <p:nvPr/>
+        </p:nvSpPr>
+        <p:spPr>
+          <a:xfrm>
+            <a:off x="804672" y="1828800"/>
+            <a:ext cx="502920" cy="502920"/>
+          </a:xfrm>
+          <a:prstGeom prst="ellipse">
+            <a:avLst/>
+          </a:prstGeom>
+          <a:solidFill>
+            <a:schemeClr val="accent2"/>
+          </a:solidFill>
+          <a:ln/>
+        </p:spPr>
+      </p:sp>
+      <p:pic>
+        <p:nvPicPr>
+          <p:cNvPr id="8" name="Price icon 1 icon" descr="preencoded.png">    </p:cNvPr>
+          <p:cNvPicPr>
+            <a:picLocks noChangeAspect="1"/>
+          </p:cNvPicPr>
+          <p:nvPr/>
+        </p:nvPicPr>
+        <p:blipFill>
+          <a:blip r:embed="rId1"/>
+          <a:stretch>
+            <a:fillRect/>
+          </a:stretch>
+        </p:blipFill>
+        <p:spPr>
+          <a:xfrm>
+            <a:off x="930402" y="1954530"/>
+            <a:ext cx="251460" cy="251460"/>
+          </a:xfrm>
+          <a:prstGeom prst="rect">
+            <a:avLst/>
+          </a:prstGeom>
+        </p:spPr>
+      </p:pic>
+      <p:sp>
+        <p:nvSpPr>
+          <p:cNvPr id="9" name="Text 6"/>
           <p:cNvSpPr txBox="1"/>
           <p:nvPr/>
         </p:nvSpPr>
         <p:spPr>
           <a:xfrm>
-            <a:off x="713232" y="1783080"/>
-            <a:ext cx="1280160" cy="548640"/>
+            <a:off x="804672" y="2468880"/>
+            <a:ext cx="2103120" cy="594360"/>
           </a:xfrm>
           <a:prstGeom prst="rect">
             <a:avLst/>
@@ -8339,27 +8383,27 @@
               <a:buNone/>
             </a:pPr>
             <a:r>
-              <a:rPr lang="en-US" sz="3000" b="1" dirty="0">
+              <a:rPr lang="en-US" sz="3600" b="1" dirty="0">
                 <a:solidFill>
                   <a:schemeClr val="accent1"/>
                 </a:solidFill>
               </a:rPr>
               <a:t>500 kr</a:t>
             </a:r>
-            <a:endParaRPr lang="en-US" sz="3000" dirty="0"/>
-          </a:p>
-        </p:txBody>
-      </p:sp>
-      <p:sp>
-        <p:nvSpPr>
-          <p:cNvPr id="8" name="Text 6"/>
+            <a:endParaRPr lang="en-US" sz="3600" dirty="0"/>
+          </a:p>
+        </p:txBody>
+      </p:sp>
+      <p:sp>
+        <p:nvSpPr>
+          <p:cNvPr id="10" name="Text 7"/>
           <p:cNvSpPr txBox="1"/>
           <p:nvPr/>
         </p:nvSpPr>
         <p:spPr>
           <a:xfrm>
-            <a:off x="713232" y="2377440"/>
-            <a:ext cx="1280160" cy="502920"/>
+            <a:off x="804672" y="3090672"/>
+            <a:ext cx="2103120" cy="320040"/>
           </a:xfrm>
           <a:prstGeom prst="rect">
             <a:avLst/>
@@ -8375,67 +8419,67 @@
               <a:buNone/>
             </a:pPr>
             <a:r>
-              <a:rPr lang="en-US" sz="1400" b="1" dirty="0">
+              <a:rPr lang="en-US" sz="1600" b="1" dirty="0">
                 <a:solidFill>
                   <a:schemeClr val="bg1"/>
                 </a:solidFill>
               </a:rPr>
               <a:t>per bokat hembesök</a:t>
             </a:r>
+            <a:endParaRPr lang="en-US" sz="1600" dirty="0"/>
+          </a:p>
+        </p:txBody>
+      </p:sp>
+      <p:sp>
+        <p:nvSpPr>
+          <p:cNvPr id="11" name="Text 8"/>
+          <p:cNvSpPr txBox="1"/>
+          <p:nvPr/>
+        </p:nvSpPr>
+        <p:spPr>
+          <a:xfrm>
+            <a:off x="804672" y="3474720"/>
+            <a:ext cx="2103120" cy="777240"/>
+          </a:xfrm>
+          <a:prstGeom prst="rect">
+            <a:avLst/>
+          </a:prstGeom>
+          <a:noFill/>
+          <a:ln/>
+        </p:spPr>
+        <p:txBody>
+          <a:bodyPr wrap="square" lIns="0" tIns="0" rIns="0" bIns="0" rtlCol="0" anchor="t"/>
+          <a:lstStyle/>
+          <a:p>
+            <a:pPr indent="0" marL="0">
+              <a:buNone/>
+            </a:pPr>
+            <a:r>
+              <a:rPr lang="en-US" sz="1400" dirty="0">
+                <a:solidFill>
+                  <a:schemeClr val="accent4"/>
+                </a:solidFill>
+              </a:rPr>
+              <a:t>För varje kvalificerat hembesök vi bokar in i er kalender.</a:t>
+            </a:r>
             <a:endParaRPr lang="en-US" sz="1400" dirty="0"/>
           </a:p>
         </p:txBody>
       </p:sp>
       <p:sp>
         <p:nvSpPr>
-          <p:cNvPr id="9" name="Text 7"/>
-          <p:cNvSpPr txBox="1"/>
-          <p:nvPr/>
-        </p:nvSpPr>
-        <p:spPr>
-          <a:xfrm>
-            <a:off x="713232" y="3017520"/>
-            <a:ext cx="1261872" cy="1280160"/>
-          </a:xfrm>
-          <a:prstGeom prst="rect">
-            <a:avLst/>
-          </a:prstGeom>
-          <a:noFill/>
-          <a:ln/>
-        </p:spPr>
-        <p:txBody>
-          <a:bodyPr wrap="square" lIns="0" tIns="0" rIns="0" bIns="0" rtlCol="0" anchor="t"/>
-          <a:lstStyle/>
-          <a:p>
-            <a:pPr indent="0" marL="0">
-              <a:buNone/>
-            </a:pPr>
-            <a:r>
-              <a:rPr lang="en-US" sz="1200" dirty="0">
-                <a:solidFill>
-                  <a:schemeClr val="accent4"/>
-                </a:solidFill>
-              </a:rPr>
-              <a:t>För varje kvalificerat besök i er kalender.</a:t>
-            </a:r>
-            <a:endParaRPr lang="en-US" sz="1200" dirty="0"/>
-          </a:p>
-        </p:txBody>
-      </p:sp>
-      <p:sp>
-        <p:nvSpPr>
-          <p:cNvPr id="10" name="Price 5 %"/>
-          <p:cNvSpPr/>
-          <p:nvPr/>
-        </p:nvSpPr>
-        <p:spPr>
-          <a:xfrm>
-            <a:off x="2221992" y="1600200"/>
-            <a:ext cx="1536192" cy="2834640"/>
+          <p:cNvPr id="12" name="Price 5 %"/>
+          <p:cNvSpPr/>
+          <p:nvPr/>
+        </p:nvSpPr>
+        <p:spPr>
+          <a:xfrm>
+            <a:off x="3291840" y="1600200"/>
+            <a:ext cx="2560320" cy="2788920"/>
           </a:xfrm>
           <a:prstGeom prst="roundRect">
             <a:avLst>
-              <a:gd name="adj" fmla="val 5952"/>
+              <a:gd name="adj" fmla="val 3571"/>
             </a:avLst>
           </a:prstGeom>
           <a:solidFill>
@@ -8451,14 +8495,58 @@
       </p:sp>
       <p:sp>
         <p:nvSpPr>
-          <p:cNvPr id="11" name="Text 9"/>
+          <p:cNvPr id="13" name="Price icon 2 circle"/>
+          <p:cNvSpPr/>
+          <p:nvPr/>
+        </p:nvSpPr>
+        <p:spPr>
+          <a:xfrm>
+            <a:off x="3547872" y="1828800"/>
+            <a:ext cx="502920" cy="502920"/>
+          </a:xfrm>
+          <a:prstGeom prst="ellipse">
+            <a:avLst/>
+          </a:prstGeom>
+          <a:solidFill>
+            <a:schemeClr val="accent2"/>
+          </a:solidFill>
+          <a:ln/>
+        </p:spPr>
+      </p:sp>
+      <p:pic>
+        <p:nvPicPr>
+          <p:cNvPr id="14" name="Price icon 2 icon" descr="preencoded.png">    </p:cNvPr>
+          <p:cNvPicPr>
+            <a:picLocks noChangeAspect="1"/>
+          </p:cNvPicPr>
+          <p:nvPr/>
+        </p:nvPicPr>
+        <p:blipFill>
+          <a:blip r:embed="rId2"/>
+          <a:stretch>
+            <a:fillRect/>
+          </a:stretch>
+        </p:blipFill>
+        <p:spPr>
+          <a:xfrm>
+            <a:off x="3673602" y="1954530"/>
+            <a:ext cx="251460" cy="251460"/>
+          </a:xfrm>
+          <a:prstGeom prst="rect">
+            <a:avLst/>
+          </a:prstGeom>
+        </p:spPr>
+      </p:pic>
+      <p:sp>
+        <p:nvSpPr>
+          <p:cNvPr id="15" name="Text 11"/>
           <p:cNvSpPr txBox="1"/>
           <p:nvPr/>
         </p:nvSpPr>
         <p:spPr>
           <a:xfrm>
-            <a:off x="2386584" y="1783080"/>
-            <a:ext cx="1280160" cy="548640"/>
+            <a:off x="3547872" y="2468880"/>
+            <a:ext cx="2103120" cy="594360"/>
           </a:xfrm>
           <a:prstGeom prst="rect">
             <a:avLst/>
@@ -8474,27 +8562,27 @@
               <a:buNone/>
             </a:pPr>
             <a:r>
-              <a:rPr lang="en-US" sz="3000" b="1" dirty="0">
+              <a:rPr lang="en-US" sz="3600" b="1" dirty="0">
                 <a:solidFill>
                   <a:schemeClr val="accent1"/>
                 </a:solidFill>
               </a:rPr>
               <a:t>5 %</a:t>
             </a:r>
-            <a:endParaRPr lang="en-US" sz="3000" dirty="0"/>
-          </a:p>
-        </p:txBody>
-      </p:sp>
-      <p:sp>
-        <p:nvSpPr>
-          <p:cNvPr id="12" name="Text 10"/>
+            <a:endParaRPr lang="en-US" sz="3600" dirty="0"/>
+          </a:p>
+        </p:txBody>
+      </p:sp>
+      <p:sp>
+        <p:nvSpPr>
+          <p:cNvPr id="16" name="Text 12"/>
           <p:cNvSpPr txBox="1"/>
           <p:nvPr/>
         </p:nvSpPr>
         <p:spPr>
           <a:xfrm>
-            <a:off x="2386584" y="2377440"/>
-            <a:ext cx="1280160" cy="502920"/>
+            <a:off x="3547872" y="3090672"/>
+            <a:ext cx="2103120" cy="320040"/>
           </a:xfrm>
           <a:prstGeom prst="rect">
             <a:avLst/>
@@ -8510,67 +8598,67 @@
               <a:buNone/>
             </a:pPr>
             <a:r>
-              <a:rPr lang="en-US" sz="1400" b="1" dirty="0">
+              <a:rPr lang="en-US" sz="1600" b="1" dirty="0">
                 <a:solidFill>
                   <a:schemeClr val="bg1"/>
                 </a:solidFill>
               </a:rPr>
               <a:t>av vinsten</a:t>
             </a:r>
+            <a:endParaRPr lang="en-US" sz="1600" dirty="0"/>
+          </a:p>
+        </p:txBody>
+      </p:sp>
+      <p:sp>
+        <p:nvSpPr>
+          <p:cNvPr id="17" name="Text 13"/>
+          <p:cNvSpPr txBox="1"/>
+          <p:nvPr/>
+        </p:nvSpPr>
+        <p:spPr>
+          <a:xfrm>
+            <a:off x="3547872" y="3474720"/>
+            <a:ext cx="2103120" cy="777240"/>
+          </a:xfrm>
+          <a:prstGeom prst="rect">
+            <a:avLst/>
+          </a:prstGeom>
+          <a:noFill/>
+          <a:ln/>
+        </p:spPr>
+        <p:txBody>
+          <a:bodyPr wrap="square" lIns="0" tIns="0" rIns="0" bIns="0" rtlCol="0" anchor="t"/>
+          <a:lstStyle/>
+          <a:p>
+            <a:pPr indent="0" marL="0">
+              <a:buNone/>
+            </a:pPr>
+            <a:r>
+              <a:rPr lang="en-US" sz="1400" dirty="0">
+                <a:solidFill>
+                  <a:schemeClr val="accent4"/>
+                </a:solidFill>
+              </a:rPr>
+              <a:t>På de jobb ni vinner från våra hembesök.</a:t>
+            </a:r>
             <a:endParaRPr lang="en-US" sz="1400" dirty="0"/>
           </a:p>
         </p:txBody>
       </p:sp>
       <p:sp>
         <p:nvSpPr>
-          <p:cNvPr id="13" name="Text 11"/>
-          <p:cNvSpPr txBox="1"/>
-          <p:nvPr/>
-        </p:nvSpPr>
-        <p:spPr>
-          <a:xfrm>
-            <a:off x="2386584" y="3017520"/>
-            <a:ext cx="1261872" cy="1280160"/>
-          </a:xfrm>
-          <a:prstGeom prst="rect">
-            <a:avLst/>
-          </a:prstGeom>
-          <a:noFill/>
-          <a:ln/>
-        </p:spPr>
-        <p:txBody>
-          <a:bodyPr wrap="square" lIns="0" tIns="0" rIns="0" bIns="0" rtlCol="0" anchor="t"/>
-          <a:lstStyle/>
-          <a:p>
-            <a:pPr indent="0" marL="0">
-              <a:buNone/>
-            </a:pPr>
-            <a:r>
-              <a:rPr lang="en-US" sz="1200" dirty="0">
-                <a:solidFill>
-                  <a:schemeClr val="accent4"/>
-                </a:solidFill>
-              </a:rPr>
-              <a:t>På de jobb ni vinner från våra besök.</a:t>
-            </a:r>
-            <a:endParaRPr lang="en-US" sz="1200" dirty="0"/>
-          </a:p>
-        </p:txBody>
-      </p:sp>
-      <p:sp>
-        <p:nvSpPr>
-          <p:cNvPr id="14" name="Price 300 kr"/>
-          <p:cNvSpPr/>
-          <p:nvPr/>
-        </p:nvSpPr>
-        <p:spPr>
-          <a:xfrm>
-            <a:off x="3895344" y="1600200"/>
-            <a:ext cx="1536192" cy="2834640"/>
+          <p:cNvPr id="18" name="Price 300 kr"/>
+          <p:cNvSpPr/>
+          <p:nvPr/>
+        </p:nvSpPr>
+        <p:spPr>
+          <a:xfrm>
+            <a:off x="6035040" y="1600200"/>
+            <a:ext cx="2560320" cy="2788920"/>
           </a:xfrm>
           <a:prstGeom prst="roundRect">
             <a:avLst>
-              <a:gd name="adj" fmla="val 5952"/>
+              <a:gd name="adj" fmla="val 3571"/>
             </a:avLst>
           </a:prstGeom>
           <a:solidFill>
@@ -8586,14 +8674,58 @@
       </p:sp>
       <p:sp>
         <p:nvSpPr>
-          <p:cNvPr id="15" name="Text 13"/>
+          <p:cNvPr id="19" name="Price icon 3 circle"/>
+          <p:cNvSpPr/>
+          <p:nvPr/>
+        </p:nvSpPr>
+        <p:spPr>
+          <a:xfrm>
+            <a:off x="6291072" y="1828800"/>
+            <a:ext cx="502920" cy="502920"/>
+          </a:xfrm>
+          <a:prstGeom prst="ellipse">
+            <a:avLst/>
+          </a:prstGeom>
+          <a:solidFill>
+            <a:schemeClr val="accent2"/>
+          </a:solidFill>
+          <a:ln/>
+        </p:spPr>
+      </p:sp>
+      <p:pic>
+        <p:nvPicPr>
+          <p:cNvPr id="20" name="Price icon 3 icon" descr="preencoded.png">    </p:cNvPr>
+          <p:cNvPicPr>
+            <a:picLocks noChangeAspect="1"/>
+          </p:cNvPicPr>
+          <p:nvPr/>
+        </p:nvPicPr>
+        <p:blipFill>
+          <a:blip r:embed="rId3"/>
+          <a:stretch>
+            <a:fillRect/>
+          </a:stretch>
+        </p:blipFill>
+        <p:spPr>
+          <a:xfrm>
+            <a:off x="6416802" y="1954530"/>
+            <a:ext cx="251460" cy="251460"/>
+          </a:xfrm>
+          <a:prstGeom prst="rect">
+            <a:avLst/>
+          </a:prstGeom>
+        </p:spPr>
+      </p:pic>
+      <p:sp>
+        <p:nvSpPr>
+          <p:cNvPr id="21" name="Text 16"/>
           <p:cNvSpPr txBox="1"/>
           <p:nvPr/>
         </p:nvSpPr>
         <p:spPr>
           <a:xfrm>
-            <a:off x="4059936" y="1783080"/>
-            <a:ext cx="1280160" cy="548640"/>
+            <a:off x="6291072" y="2468880"/>
+            <a:ext cx="2103120" cy="594360"/>
           </a:xfrm>
           <a:prstGeom prst="rect">
             <a:avLst/>
@@ -8609,27 +8741,27 @@
               <a:buNone/>
             </a:pPr>
             <a:r>
-              <a:rPr lang="en-US" sz="3000" b="1" dirty="0">
+              <a:rPr lang="en-US" sz="3600" b="1" dirty="0">
                 <a:solidFill>
                   <a:schemeClr val="accent1"/>
                 </a:solidFill>
               </a:rPr>
               <a:t>300 kr</a:t>
             </a:r>
-            <a:endParaRPr lang="en-US" sz="3000" dirty="0"/>
-          </a:p>
-        </p:txBody>
-      </p:sp>
-      <p:sp>
-        <p:nvSpPr>
-          <p:cNvPr id="16" name="Text 14"/>
+            <a:endParaRPr lang="en-US" sz="3600" dirty="0"/>
+          </a:p>
+        </p:txBody>
+      </p:sp>
+      <p:sp>
+        <p:nvSpPr>
+          <p:cNvPr id="22" name="Text 17"/>
           <p:cNvSpPr txBox="1"/>
           <p:nvPr/>
         </p:nvSpPr>
         <p:spPr>
           <a:xfrm>
-            <a:off x="4059936" y="2377440"/>
-            <a:ext cx="1280160" cy="502920"/>
+            <a:off x="6291072" y="3090672"/>
+            <a:ext cx="2103120" cy="320040"/>
           </a:xfrm>
           <a:prstGeom prst="rect">
             <a:avLst/>
@@ -8645,505 +8777,50 @@
               <a:buNone/>
             </a:pPr>
             <a:r>
-              <a:rPr lang="en-US" sz="1400" b="1" dirty="0">
+              <a:rPr lang="en-US" sz="1600" b="1" dirty="0">
                 <a:solidFill>
                   <a:schemeClr val="bg1"/>
                 </a:solidFill>
               </a:rPr>
               <a:t>per dag i annonser</a:t>
             </a:r>
+            <a:endParaRPr lang="en-US" sz="1600" dirty="0"/>
+          </a:p>
+        </p:txBody>
+      </p:sp>
+      <p:sp>
+        <p:nvSpPr>
+          <p:cNvPr id="23" name="Text 18"/>
+          <p:cNvSpPr txBox="1"/>
+          <p:nvPr/>
+        </p:nvSpPr>
+        <p:spPr>
+          <a:xfrm>
+            <a:off x="6291072" y="3474720"/>
+            <a:ext cx="2103120" cy="777240"/>
+          </a:xfrm>
+          <a:prstGeom prst="rect">
+            <a:avLst/>
+          </a:prstGeom>
+          <a:noFill/>
+          <a:ln/>
+        </p:spPr>
+        <p:txBody>
+          <a:bodyPr wrap="square" lIns="0" tIns="0" rIns="0" bIns="0" rtlCol="0" anchor="t"/>
+          <a:lstStyle/>
+          <a:p>
+            <a:pPr indent="0" marL="0">
+              <a:buNone/>
+            </a:pPr>
+            <a:r>
+              <a:rPr lang="en-US" sz="1400" dirty="0">
+                <a:solidFill>
+                  <a:schemeClr val="accent4"/>
+                </a:solidFill>
+              </a:rPr>
+              <a:t>Går direkt till Meta och syns i ert eget annonskonto.</a:t>
+            </a:r>
             <a:endParaRPr lang="en-US" sz="1400" dirty="0"/>
-          </a:p>
-        </p:txBody>
-      </p:sp>
-      <p:sp>
-        <p:nvSpPr>
-          <p:cNvPr id="17" name="Text 15"/>
-          <p:cNvSpPr txBox="1"/>
-          <p:nvPr/>
-        </p:nvSpPr>
-        <p:spPr>
-          <a:xfrm>
-            <a:off x="4059936" y="3017520"/>
-            <a:ext cx="1261872" cy="1280160"/>
-          </a:xfrm>
-          <a:prstGeom prst="rect">
-            <a:avLst/>
-          </a:prstGeom>
-          <a:noFill/>
-          <a:ln/>
-        </p:spPr>
-        <p:txBody>
-          <a:bodyPr wrap="square" lIns="0" tIns="0" rIns="0" bIns="0" rtlCol="0" anchor="t"/>
-          <a:lstStyle/>
-          <a:p>
-            <a:pPr indent="0" marL="0">
-              <a:buNone/>
-            </a:pPr>
-            <a:r>
-              <a:rPr lang="en-US" sz="1200" dirty="0">
-                <a:solidFill>
-                  <a:schemeClr val="accent4"/>
-                </a:solidFill>
-              </a:rPr>
-              <a:t>Går direkt till Meta. Ca 9 000 kr/mån.</a:t>
-            </a:r>
-            <a:endParaRPr lang="en-US" sz="1200" dirty="0"/>
-          </a:p>
-        </p:txBody>
-      </p:sp>
-      <p:sp>
-        <p:nvSpPr>
-          <p:cNvPr id="18" name="Example box"/>
-          <p:cNvSpPr/>
-          <p:nvPr/>
-        </p:nvSpPr>
-        <p:spPr>
-          <a:xfrm>
-            <a:off x="5669280" y="1600200"/>
-            <a:ext cx="2926080" cy="2834640"/>
-          </a:xfrm>
-          <a:prstGeom prst="roundRect">
-            <a:avLst>
-              <a:gd name="adj" fmla="val 3226"/>
-            </a:avLst>
-          </a:prstGeom>
-          <a:solidFill>
-            <a:schemeClr val="accent1"/>
-          </a:solidFill>
-          <a:ln/>
-        </p:spPr>
-      </p:sp>
-      <p:sp>
-        <p:nvSpPr>
-          <p:cNvPr id="19" name="Text 17"/>
-          <p:cNvSpPr txBox="1"/>
-          <p:nvPr/>
-        </p:nvSpPr>
-        <p:spPr>
-          <a:xfrm>
-            <a:off x="5870448" y="1755648"/>
-            <a:ext cx="2560320" cy="228600"/>
-          </a:xfrm>
-          <a:prstGeom prst="rect">
-            <a:avLst/>
-          </a:prstGeom>
-          <a:noFill/>
-          <a:ln/>
-        </p:spPr>
-        <p:txBody>
-          <a:bodyPr wrap="square" lIns="0" tIns="0" rIns="0" bIns="0" rtlCol="0" anchor="ctr"/>
-          <a:lstStyle/>
-          <a:p>
-            <a:pPr indent="0" marL="0">
-              <a:buNone/>
-            </a:pPr>
-            <a:r>
-              <a:rPr lang="en-US" sz="900" b="1" spc="200" kern="0" dirty="0">
-                <a:solidFill>
-                  <a:schemeClr val="tx1"/>
-                </a:solidFill>
-              </a:rPr>
-              <a:t>RÄKNEEXEMPEL · 1 MÅNAD</a:t>
-            </a:r>
-            <a:endParaRPr lang="en-US" sz="900" dirty="0"/>
-          </a:p>
-        </p:txBody>
-      </p:sp>
-      <p:sp>
-        <p:nvSpPr>
-          <p:cNvPr id="20" name="Text 18"/>
-          <p:cNvSpPr txBox="1"/>
-          <p:nvPr/>
-        </p:nvSpPr>
-        <p:spPr>
-          <a:xfrm>
-            <a:off x="5870448" y="2075688"/>
-            <a:ext cx="1737360" cy="274320"/>
-          </a:xfrm>
-          <a:prstGeom prst="rect">
-            <a:avLst/>
-          </a:prstGeom>
-          <a:noFill/>
-          <a:ln/>
-        </p:spPr>
-        <p:txBody>
-          <a:bodyPr wrap="square" lIns="0" tIns="0" rIns="0" bIns="0" rtlCol="0" anchor="ctr"/>
-          <a:lstStyle/>
-          <a:p>
-            <a:pPr indent="0" marL="0">
-              <a:buNone/>
-            </a:pPr>
-            <a:r>
-              <a:rPr lang="en-US" sz="1200" dirty="0">
-                <a:solidFill>
-                  <a:schemeClr val="tx1"/>
-                </a:solidFill>
-              </a:rPr>
-              <a:t>Annonser 30 × 300 kr</a:t>
-            </a:r>
-            <a:endParaRPr lang="en-US" sz="1200" dirty="0"/>
-          </a:p>
-        </p:txBody>
-      </p:sp>
-      <p:sp>
-        <p:nvSpPr>
-          <p:cNvPr id="21" name="Text 19"/>
-          <p:cNvSpPr txBox="1"/>
-          <p:nvPr/>
-        </p:nvSpPr>
-        <p:spPr>
-          <a:xfrm>
-            <a:off x="7498080" y="2075688"/>
-            <a:ext cx="914400" cy="274320"/>
-          </a:xfrm>
-          <a:prstGeom prst="rect">
-            <a:avLst/>
-          </a:prstGeom>
-          <a:noFill/>
-          <a:ln/>
-        </p:spPr>
-        <p:txBody>
-          <a:bodyPr wrap="square" lIns="0" tIns="0" rIns="0" bIns="0" rtlCol="0" anchor="ctr"/>
-          <a:lstStyle/>
-          <a:p>
-            <a:pPr algn="r" indent="0" marL="0">
-              <a:buNone/>
-            </a:pPr>
-            <a:r>
-              <a:rPr lang="en-US" sz="1200" b="1" dirty="0">
-                <a:solidFill>
-                  <a:schemeClr val="tx1"/>
-                </a:solidFill>
-              </a:rPr>
-              <a:t>9 000 kr</a:t>
-            </a:r>
-            <a:endParaRPr lang="en-US" sz="1200" dirty="0"/>
-          </a:p>
-        </p:txBody>
-      </p:sp>
-      <p:sp>
-        <p:nvSpPr>
-          <p:cNvPr id="22" name="Text 20"/>
-          <p:cNvSpPr txBox="1"/>
-          <p:nvPr/>
-        </p:nvSpPr>
-        <p:spPr>
-          <a:xfrm>
-            <a:off x="5870448" y="2404872"/>
-            <a:ext cx="1737360" cy="274320"/>
-          </a:xfrm>
-          <a:prstGeom prst="rect">
-            <a:avLst/>
-          </a:prstGeom>
-          <a:noFill/>
-          <a:ln/>
-        </p:spPr>
-        <p:txBody>
-          <a:bodyPr wrap="square" lIns="0" tIns="0" rIns="0" bIns="0" rtlCol="0" anchor="ctr"/>
-          <a:lstStyle/>
-          <a:p>
-            <a:pPr indent="0" marL="0">
-              <a:buNone/>
-            </a:pPr>
-            <a:r>
-              <a:rPr lang="en-US" sz="1200" dirty="0">
-                <a:solidFill>
-                  <a:schemeClr val="tx1"/>
-                </a:solidFill>
-              </a:rPr>
-              <a:t>10 hembesök × 500 kr</a:t>
-            </a:r>
-            <a:endParaRPr lang="en-US" sz="1200" dirty="0"/>
-          </a:p>
-        </p:txBody>
-      </p:sp>
-      <p:sp>
-        <p:nvSpPr>
-          <p:cNvPr id="23" name="Text 21"/>
-          <p:cNvSpPr txBox="1"/>
-          <p:nvPr/>
-        </p:nvSpPr>
-        <p:spPr>
-          <a:xfrm>
-            <a:off x="7498080" y="2404872"/>
-            <a:ext cx="914400" cy="274320"/>
-          </a:xfrm>
-          <a:prstGeom prst="rect">
-            <a:avLst/>
-          </a:prstGeom>
-          <a:noFill/>
-          <a:ln/>
-        </p:spPr>
-        <p:txBody>
-          <a:bodyPr wrap="square" lIns="0" tIns="0" rIns="0" bIns="0" rtlCol="0" anchor="ctr"/>
-          <a:lstStyle/>
-          <a:p>
-            <a:pPr algn="r" indent="0" marL="0">
-              <a:buNone/>
-            </a:pPr>
-            <a:r>
-              <a:rPr lang="en-US" sz="1200" b="1" dirty="0">
-                <a:solidFill>
-                  <a:schemeClr val="tx1"/>
-                </a:solidFill>
-              </a:rPr>
-              <a:t>5 000 kr</a:t>
-            </a:r>
-            <a:endParaRPr lang="en-US" sz="1200" dirty="0"/>
-          </a:p>
-        </p:txBody>
-      </p:sp>
-      <p:sp>
-        <p:nvSpPr>
-          <p:cNvPr id="24" name="Text 22"/>
-          <p:cNvSpPr txBox="1"/>
-          <p:nvPr/>
-        </p:nvSpPr>
-        <p:spPr>
-          <a:xfrm>
-            <a:off x="5870448" y="2734056"/>
-            <a:ext cx="1737360" cy="274320"/>
-          </a:xfrm>
-          <a:prstGeom prst="rect">
-            <a:avLst/>
-          </a:prstGeom>
-          <a:noFill/>
-          <a:ln/>
-        </p:spPr>
-        <p:txBody>
-          <a:bodyPr wrap="square" lIns="0" tIns="0" rIns="0" bIns="0" rtlCol="0" anchor="ctr"/>
-          <a:lstStyle/>
-          <a:p>
-            <a:pPr indent="0" marL="0">
-              <a:buNone/>
-            </a:pPr>
-            <a:r>
-              <a:rPr lang="en-US" sz="1200" dirty="0">
-                <a:solidFill>
-                  <a:schemeClr val="tx1"/>
-                </a:solidFill>
-              </a:rPr>
-              <a:t>5 % av 150 000 kr</a:t>
-            </a:r>
-            <a:endParaRPr lang="en-US" sz="1200" dirty="0"/>
-          </a:p>
-        </p:txBody>
-      </p:sp>
-      <p:sp>
-        <p:nvSpPr>
-          <p:cNvPr id="25" name="Text 23"/>
-          <p:cNvSpPr txBox="1"/>
-          <p:nvPr/>
-        </p:nvSpPr>
-        <p:spPr>
-          <a:xfrm>
-            <a:off x="7498080" y="2734056"/>
-            <a:ext cx="914400" cy="274320"/>
-          </a:xfrm>
-          <a:prstGeom prst="rect">
-            <a:avLst/>
-          </a:prstGeom>
-          <a:noFill/>
-          <a:ln/>
-        </p:spPr>
-        <p:txBody>
-          <a:bodyPr wrap="square" lIns="0" tIns="0" rIns="0" bIns="0" rtlCol="0" anchor="ctr"/>
-          <a:lstStyle/>
-          <a:p>
-            <a:pPr algn="r" indent="0" marL="0">
-              <a:buNone/>
-            </a:pPr>
-            <a:r>
-              <a:rPr lang="en-US" sz="1200" b="1" dirty="0">
-                <a:solidFill>
-                  <a:schemeClr val="tx1"/>
-                </a:solidFill>
-              </a:rPr>
-              <a:t>7 500 kr</a:t>
-            </a:r>
-            <a:endParaRPr lang="en-US" sz="1200" dirty="0"/>
-          </a:p>
-        </p:txBody>
-      </p:sp>
-      <p:sp>
-        <p:nvSpPr>
-          <p:cNvPr id="26" name="Shape 24"/>
-          <p:cNvSpPr/>
-          <p:nvPr/>
-        </p:nvSpPr>
-        <p:spPr>
-          <a:xfrm>
-            <a:off x="5870448" y="3099816"/>
-            <a:ext cx="2542032" cy="0"/>
-          </a:xfrm>
-          <a:prstGeom prst="line">
-            <a:avLst/>
-          </a:prstGeom>
-          <a:noFill/>
-          <a:ln w="12700">
-            <a:solidFill>
-              <a:schemeClr val="tx1"/>
-            </a:solidFill>
-            <a:prstDash val="solid"/>
-          </a:ln>
-        </p:spPr>
-      </p:sp>
-      <p:sp>
-        <p:nvSpPr>
-          <p:cNvPr id="27" name="Text 25"/>
-          <p:cNvSpPr txBox="1"/>
-          <p:nvPr/>
-        </p:nvSpPr>
-        <p:spPr>
-          <a:xfrm>
-            <a:off x="5870448" y="3154680"/>
-            <a:ext cx="1371600" cy="292608"/>
-          </a:xfrm>
-          <a:prstGeom prst="rect">
-            <a:avLst/>
-          </a:prstGeom>
-          <a:noFill/>
-          <a:ln/>
-        </p:spPr>
-        <p:txBody>
-          <a:bodyPr wrap="square" lIns="0" tIns="0" rIns="0" bIns="0" rtlCol="0" anchor="ctr"/>
-          <a:lstStyle/>
-          <a:p>
-            <a:pPr indent="0" marL="0">
-              <a:buNone/>
-            </a:pPr>
-            <a:r>
-              <a:rPr lang="en-US" sz="1300" b="1" dirty="0">
-                <a:solidFill>
-                  <a:schemeClr val="tx1"/>
-                </a:solidFill>
-              </a:rPr>
-              <a:t>Totalt</a:t>
-            </a:r>
-            <a:endParaRPr lang="en-US" sz="1300" dirty="0"/>
-          </a:p>
-        </p:txBody>
-      </p:sp>
-      <p:sp>
-        <p:nvSpPr>
-          <p:cNvPr id="28" name="Text 26"/>
-          <p:cNvSpPr txBox="1"/>
-          <p:nvPr/>
-        </p:nvSpPr>
-        <p:spPr>
-          <a:xfrm>
-            <a:off x="7223760" y="3154680"/>
-            <a:ext cx="1188720" cy="292608"/>
-          </a:xfrm>
-          <a:prstGeom prst="rect">
-            <a:avLst/>
-          </a:prstGeom>
-          <a:noFill/>
-          <a:ln/>
-        </p:spPr>
-        <p:txBody>
-          <a:bodyPr wrap="square" lIns="0" tIns="0" rIns="0" bIns="0" rtlCol="0" anchor="ctr"/>
-          <a:lstStyle/>
-          <a:p>
-            <a:pPr algn="r" indent="0" marL="0">
-              <a:buNone/>
-            </a:pPr>
-            <a:r>
-              <a:rPr lang="en-US" sz="1300" b="1" dirty="0">
-                <a:solidFill>
-                  <a:schemeClr val="tx1"/>
-                </a:solidFill>
-              </a:rPr>
-              <a:t>21 500 kr</a:t>
-            </a:r>
-            <a:endParaRPr lang="en-US" sz="1300" dirty="0"/>
-          </a:p>
-        </p:txBody>
-      </p:sp>
-      <p:sp>
-        <p:nvSpPr>
-          <p:cNvPr id="29" name="Text 27"/>
-          <p:cNvSpPr txBox="1"/>
-          <p:nvPr/>
-        </p:nvSpPr>
-        <p:spPr>
-          <a:xfrm>
-            <a:off x="5870448" y="3566160"/>
-            <a:ext cx="2560320" cy="731520"/>
-          </a:xfrm>
-          <a:prstGeom prst="rect">
-            <a:avLst/>
-          </a:prstGeom>
-          <a:noFill/>
-          <a:ln/>
-        </p:spPr>
-        <p:txBody>
-          <a:bodyPr wrap="square" lIns="0" tIns="0" rIns="0" bIns="0" rtlCol="0" anchor="t"/>
-          <a:lstStyle/>
-          <a:p>
-            <a:pPr indent="0" marL="0">
-              <a:buNone/>
-            </a:pPr>
-            <a:r>
-              <a:rPr lang="en-US" sz="2800" b="1" dirty="0">
-                <a:solidFill>
-                  <a:schemeClr val="bg1"/>
-                </a:solidFill>
-              </a:rPr>
-              <a:t>95 %</a:t>
-            </a:r>
-            <a:endParaRPr lang="en-US" sz="2800" dirty="0"/>
-          </a:p>
-          <a:p>
-            <a:pPr indent="0" marL="0">
-              <a:buNone/>
-            </a:pPr>
-            <a:r>
-              <a:rPr lang="en-US" sz="1200" b="1" dirty="0">
-                <a:solidFill>
-                  <a:schemeClr val="tx1"/>
-                </a:solidFill>
-              </a:rPr>
-              <a:t>av vinsten behåller ni</a:t>
-            </a:r>
-            <a:endParaRPr lang="en-US" sz="2800" dirty="0"/>
-          </a:p>
-        </p:txBody>
-      </p:sp>
-      <p:sp>
-        <p:nvSpPr>
-          <p:cNvPr id="30" name="Text 28"/>
-          <p:cNvSpPr txBox="1"/>
-          <p:nvPr/>
-        </p:nvSpPr>
-        <p:spPr>
-          <a:xfrm>
-            <a:off x="2743200" y="4681728"/>
-            <a:ext cx="4846320" cy="228600"/>
-          </a:xfrm>
-          <a:prstGeom prst="rect">
-            <a:avLst/>
-          </a:prstGeom>
-          <a:noFill/>
-          <a:ln/>
-        </p:spPr>
-        <p:txBody>
-          <a:bodyPr wrap="square" lIns="0" tIns="0" rIns="0" bIns="0" rtlCol="0" anchor="ctr"/>
-          <a:lstStyle/>
-          <a:p>
-            <a:pPr algn="ctr" indent="0" marL="0">
-              <a:buNone/>
-            </a:pPr>
-            <a:r>
-              <a:rPr lang="en-US" sz="900" dirty="0">
-                <a:solidFill>
-                  <a:schemeClr val="accent3"/>
-                </a:solidFill>
-              </a:rPr>
-              <a:t>Exempelsiffror – faktiskt utfall varierar per företag och område</a:t>
-            </a:r>
-            <a:endParaRPr lang="en-US" sz="900" dirty="0"/>
           </a:p>
         </p:txBody>
       </p:sp>
@@ -9235,7 +8912,7 @@
             <a:avLst/>
           </a:prstGeom>
           <a:solidFill>
-            <a:schemeClr val="tx1"/>
+            <a:schemeClr val="accent1"/>
           </a:solidFill>
           <a:ln/>
         </p:spPr>
@@ -9267,7 +8944,7 @@
             <a:r>
               <a:rPr lang="en-US" sz="900" b="1" dirty="0">
                 <a:solidFill>
-                  <a:schemeClr val="tx1"/>
+                  <a:schemeClr val="accent3"/>
                 </a:solidFill>
               </a:rPr>
               <a:t>REC  00:00:07:00</a:t>
@@ -9301,12 +8978,333 @@
               <a:buNone/>
             </a:pPr>
             <a:r>
-              <a:rPr lang="en-US" sz="1200" b="1" spc="400" kern="0" dirty="0">
+              <a:rPr lang="en-US" sz="1100" b="1" spc="300" kern="0" dirty="0">
+                <a:solidFill>
+                  <a:schemeClr val="accent1"/>
+                </a:solidFill>
+              </a:rPr>
+              <a:t>NÄSTA STEG</a:t>
+            </a:r>
+            <a:endParaRPr lang="en-US" sz="1100" dirty="0"/>
+          </a:p>
+        </p:txBody>
+      </p:sp>
+      <p:sp>
+        <p:nvSpPr>
+          <p:cNvPr id="5" name="Closing title"/>
+          <p:cNvSpPr txBox="1"/>
+          <p:nvPr/>
+        </p:nvSpPr>
+        <p:spPr>
+          <a:xfrm>
+            <a:off x="548640" y="822960"/>
+            <a:ext cx="4754880" cy="1280160"/>
+          </a:xfrm>
+          <a:prstGeom prst="rect">
+            <a:avLst/>
+          </a:prstGeom>
+          <a:noFill/>
+          <a:ln/>
+        </p:spPr>
+        <p:txBody>
+          <a:bodyPr wrap="square" lIns="0" tIns="0" rIns="0" bIns="0" rtlCol="0" anchor="t"/>
+          <a:lstStyle/>
+          <a:p>
+            <a:pPr indent="0" marL="0">
+              <a:buNone/>
+            </a:pPr>
+            <a:r>
+              <a:rPr lang="en-US" sz="4000" b="1" dirty="0">
+                <a:solidFill>
+                  <a:schemeClr val="bg1"/>
+                </a:solidFill>
+              </a:rPr>
+              <a:t>Ska vi fylla din </a:t>
+            </a:r>
+            <a:pPr indent="0" marL="0">
+              <a:buNone/>
+            </a:pPr>
+            <a:r>
+              <a:rPr lang="en-US" sz="4000" b="1" dirty="0">
+                <a:solidFill>
+                  <a:schemeClr val="accent1"/>
+                </a:solidFill>
+              </a:rPr>
+              <a:t>kalender?</a:t>
+            </a:r>
+            <a:endParaRPr lang="en-US" sz="4000" dirty="0"/>
+          </a:p>
+        </p:txBody>
+      </p:sp>
+      <p:pic>
+        <p:nvPicPr>
+          <p:cNvPr id="6" name="Image 0" descr="preencoded.png">    </p:cNvPr>
+          <p:cNvPicPr>
+            <a:picLocks noChangeAspect="1"/>
+          </p:cNvPicPr>
+          <p:nvPr/>
+        </p:nvPicPr>
+        <p:blipFill>
+          <a:blip r:embed="rId1"/>
+          <a:stretch>
+            <a:fillRect/>
+          </a:stretch>
+        </p:blipFill>
+        <p:spPr>
+          <a:xfrm>
+            <a:off x="548640" y="2340864"/>
+            <a:ext cx="219456" cy="219456"/>
+          </a:xfrm>
+          <a:prstGeom prst="rect">
+            <a:avLst/>
+          </a:prstGeom>
+        </p:spPr>
+      </p:pic>
+      <p:sp>
+        <p:nvSpPr>
+          <p:cNvPr id="7" name="Text 4"/>
+          <p:cNvSpPr txBox="1"/>
+          <p:nvPr/>
+        </p:nvSpPr>
+        <p:spPr>
+          <a:xfrm>
+            <a:off x="896112" y="2286000"/>
+            <a:ext cx="4206240" cy="329184"/>
+          </a:xfrm>
+          <a:prstGeom prst="rect">
+            <a:avLst/>
+          </a:prstGeom>
+          <a:noFill/>
+          <a:ln/>
+        </p:spPr>
+        <p:txBody>
+          <a:bodyPr wrap="square" lIns="0" tIns="0" rIns="0" bIns="0" rtlCol="0" anchor="ctr"/>
+          <a:lstStyle/>
+          <a:p>
+            <a:pPr indent="0" marL="0">
+              <a:buNone/>
+            </a:pPr>
+            <a:r>
+              <a:rPr lang="en-US" sz="1500" dirty="0">
+                <a:solidFill>
+                  <a:schemeClr val="bg1"/>
+                </a:solidFill>
+              </a:rPr>
+              <a:t>Videoannonser som visar ert hantverk</a:t>
+            </a:r>
+            <a:endParaRPr lang="en-US" sz="1500" dirty="0"/>
+          </a:p>
+        </p:txBody>
+      </p:sp>
+      <p:pic>
+        <p:nvPicPr>
+          <p:cNvPr id="8" name="Image 1" descr="preencoded.png">    </p:cNvPr>
+          <p:cNvPicPr>
+            <a:picLocks noChangeAspect="1"/>
+          </p:cNvPicPr>
+          <p:nvPr/>
+        </p:nvPicPr>
+        <p:blipFill>
+          <a:blip r:embed="rId2"/>
+          <a:stretch>
+            <a:fillRect/>
+          </a:stretch>
+        </p:blipFill>
+        <p:spPr>
+          <a:xfrm>
+            <a:off x="548640" y="2752344"/>
+            <a:ext cx="219456" cy="219456"/>
+          </a:xfrm>
+          <a:prstGeom prst="rect">
+            <a:avLst/>
+          </a:prstGeom>
+        </p:spPr>
+      </p:pic>
+      <p:sp>
+        <p:nvSpPr>
+          <p:cNvPr id="9" name="Text 5"/>
+          <p:cNvSpPr txBox="1"/>
+          <p:nvPr/>
+        </p:nvSpPr>
+        <p:spPr>
+          <a:xfrm>
+            <a:off x="896112" y="2697480"/>
+            <a:ext cx="4206240" cy="329184"/>
+          </a:xfrm>
+          <a:prstGeom prst="rect">
+            <a:avLst/>
+          </a:prstGeom>
+          <a:noFill/>
+          <a:ln/>
+        </p:spPr>
+        <p:txBody>
+          <a:bodyPr wrap="square" lIns="0" tIns="0" rIns="0" bIns="0" rtlCol="0" anchor="ctr"/>
+          <a:lstStyle/>
+          <a:p>
+            <a:pPr indent="0" marL="0">
+              <a:buNone/>
+            </a:pPr>
+            <a:r>
+              <a:rPr lang="en-US" sz="1500" dirty="0">
+                <a:solidFill>
+                  <a:schemeClr val="bg1"/>
+                </a:solidFill>
+              </a:rPr>
+              <a:t>Vi kvalificerar varje lead</a:t>
+            </a:r>
+            <a:endParaRPr lang="en-US" sz="1500" dirty="0"/>
+          </a:p>
+        </p:txBody>
+      </p:sp>
+      <p:pic>
+        <p:nvPicPr>
+          <p:cNvPr id="10" name="Image 2" descr="preencoded.png">    </p:cNvPr>
+          <p:cNvPicPr>
+            <a:picLocks noChangeAspect="1"/>
+          </p:cNvPicPr>
+          <p:nvPr/>
+        </p:nvPicPr>
+        <p:blipFill>
+          <a:blip r:embed="rId3"/>
+          <a:stretch>
+            <a:fillRect/>
+          </a:stretch>
+        </p:blipFill>
+        <p:spPr>
+          <a:xfrm>
+            <a:off x="548640" y="3163824"/>
+            <a:ext cx="219456" cy="219456"/>
+          </a:xfrm>
+          <a:prstGeom prst="rect">
+            <a:avLst/>
+          </a:prstGeom>
+        </p:spPr>
+      </p:pic>
+      <p:sp>
+        <p:nvSpPr>
+          <p:cNvPr id="11" name="Text 6"/>
+          <p:cNvSpPr txBox="1"/>
+          <p:nvPr/>
+        </p:nvSpPr>
+        <p:spPr>
+          <a:xfrm>
+            <a:off x="896112" y="3108960"/>
+            <a:ext cx="4206240" cy="329184"/>
+          </a:xfrm>
+          <a:prstGeom prst="rect">
+            <a:avLst/>
+          </a:prstGeom>
+          <a:noFill/>
+          <a:ln/>
+        </p:spPr>
+        <p:txBody>
+          <a:bodyPr wrap="square" lIns="0" tIns="0" rIns="0" bIns="0" rtlCol="0" anchor="ctr"/>
+          <a:lstStyle/>
+          <a:p>
+            <a:pPr indent="0" marL="0">
+              <a:buNone/>
+            </a:pPr>
+            <a:r>
+              <a:rPr lang="en-US" sz="1500" dirty="0">
+                <a:solidFill>
+                  <a:schemeClr val="bg1"/>
+                </a:solidFill>
+              </a:rPr>
+              <a:t>Hembesöken bokas direkt i din kalender</a:t>
+            </a:r>
+            <a:endParaRPr lang="en-US" sz="1500" dirty="0"/>
+          </a:p>
+        </p:txBody>
+      </p:sp>
+      <p:sp>
+        <p:nvSpPr>
+          <p:cNvPr id="12" name="CTA button"/>
+          <p:cNvSpPr/>
+          <p:nvPr/>
+        </p:nvSpPr>
+        <p:spPr>
+          <a:xfrm>
+            <a:off x="548640" y="3657600"/>
+            <a:ext cx="2926080" cy="475488"/>
+          </a:xfrm>
+          <a:prstGeom prst="roundRect">
+            <a:avLst>
+              <a:gd name="adj" fmla="val 50000"/>
+            </a:avLst>
+          </a:prstGeom>
+          <a:solidFill>
+            <a:schemeClr val="accent1"/>
+          </a:solidFill>
+          <a:ln/>
+        </p:spPr>
+      </p:sp>
+      <p:sp>
+        <p:nvSpPr>
+          <p:cNvPr id="13" name="Text 8"/>
+          <p:cNvSpPr txBox="1"/>
+          <p:nvPr/>
+        </p:nvSpPr>
+        <p:spPr>
+          <a:xfrm>
+            <a:off x="548640" y="3657600"/>
+            <a:ext cx="2926080" cy="475488"/>
+          </a:xfrm>
+          <a:prstGeom prst="rect">
+            <a:avLst/>
+          </a:prstGeom>
+          <a:noFill/>
+          <a:ln/>
+        </p:spPr>
+        <p:txBody>
+          <a:bodyPr wrap="square" lIns="0" tIns="0" rIns="0" bIns="0" rtlCol="0" anchor="ctr"/>
+          <a:lstStyle/>
+          <a:p>
+            <a:pPr algn="ctr" indent="0" marL="0">
+              <a:buNone/>
+            </a:pPr>
+            <a:r>
+              <a:rPr lang="en-US" sz="1600" b="1" dirty="0">
                 <a:solidFill>
                   <a:schemeClr val="tx1"/>
                 </a:solidFill>
               </a:rPr>
-              <a:t>ZDANMOTION</a:t>
+              <a:t>Ja – vi kör igång idag</a:t>
+            </a:r>
+            <a:endParaRPr lang="en-US" sz="1600" dirty="0"/>
+          </a:p>
+        </p:txBody>
+      </p:sp>
+      <p:sp>
+        <p:nvSpPr>
+          <p:cNvPr id="14" name="Text 9"/>
+          <p:cNvSpPr txBox="1"/>
+          <p:nvPr/>
+        </p:nvSpPr>
+        <p:spPr>
+          <a:xfrm>
+            <a:off x="548640" y="4206240"/>
+            <a:ext cx="4572000" cy="274320"/>
+          </a:xfrm>
+          <a:prstGeom prst="rect">
+            <a:avLst/>
+          </a:prstGeom>
+          <a:noFill/>
+          <a:ln/>
+        </p:spPr>
+        <p:txBody>
+          <a:bodyPr wrap="square" lIns="0" tIns="0" rIns="0" bIns="0" rtlCol="0" anchor="ctr"/>
+          <a:lstStyle/>
+          <a:p>
+            <a:pPr indent="0" marL="0">
+              <a:buNone/>
+            </a:pPr>
+            <a:r>
+              <a:rPr lang="en-US" sz="1200" dirty="0">
+                <a:solidFill>
+                  <a:schemeClr val="accent4"/>
+                </a:solidFill>
+              </a:rPr>
+              <a:t>Signera digitalt och skicka bilder och filmer – sedan sätter vi igång.</a:t>
             </a:r>
             <a:endParaRPr lang="en-US" sz="1200" dirty="0"/>
           </a:p>
@@ -9314,14 +9312,14 @@
       </p:sp>
       <p:sp>
         <p:nvSpPr>
-          <p:cNvPr id="5" name="CTA title"/>
+          <p:cNvPr id="15" name="Text 10"/>
           <p:cNvSpPr txBox="1"/>
           <p:nvPr/>
         </p:nvSpPr>
         <p:spPr>
           <a:xfrm>
-            <a:off x="548640" y="960120"/>
-            <a:ext cx="8046720" cy="822960"/>
+            <a:off x="548640" y="4681728"/>
+            <a:ext cx="2743200" cy="228600"/>
           </a:xfrm>
           <a:prstGeom prst="rect">
             <a:avLst/>
@@ -9337,27 +9335,92 @@
               <a:buNone/>
             </a:pPr>
             <a:r>
-              <a:rPr lang="en-US" sz="4200" b="1" dirty="0">
+              <a:rPr lang="en-US" sz="1000" b="1" dirty="0">
+                <a:solidFill>
+                  <a:schemeClr val="accent3"/>
+                </a:solidFill>
+              </a:rPr>
+              <a:t>zdanmotion.se</a:t>
+            </a:r>
+            <a:endParaRPr lang="en-US" sz="1000" dirty="0"/>
+          </a:p>
+        </p:txBody>
+      </p:sp>
+      <p:sp>
+        <p:nvSpPr>
+          <p:cNvPr id="16" name="Month calendar"/>
+          <p:cNvSpPr/>
+          <p:nvPr/>
+        </p:nvSpPr>
+        <p:spPr>
+          <a:xfrm>
+            <a:off x="5577840" y="868680"/>
+            <a:ext cx="3017520" cy="3611880"/>
+          </a:xfrm>
+          <a:prstGeom prst="roundRect">
+            <a:avLst>
+              <a:gd name="adj" fmla="val 3636"/>
+            </a:avLst>
+          </a:prstGeom>
+          <a:solidFill>
+            <a:schemeClr val="bg2"/>
+          </a:solidFill>
+          <a:ln/>
+          <a:effectLst>
+            <a:outerShdw sx="100000" sy="100000" kx="0" ky="0" algn="bl" rotWithShape="0" blurRad="177800" dist="50800" dir="5400000">
+              <a:srgbClr val="000000">
+                <a:alpha val="35000"/>
+              </a:srgbClr>
+            </a:outerShdw>
+          </a:effectLst>
+        </p:spPr>
+      </p:sp>
+      <p:sp>
+        <p:nvSpPr>
+          <p:cNvPr id="17" name="Text 12"/>
+          <p:cNvSpPr txBox="1"/>
+          <p:nvPr/>
+        </p:nvSpPr>
+        <p:spPr>
+          <a:xfrm>
+            <a:off x="5806440" y="1051560"/>
+            <a:ext cx="2560320" cy="274320"/>
+          </a:xfrm>
+          <a:prstGeom prst="rect">
+            <a:avLst/>
+          </a:prstGeom>
+          <a:noFill/>
+          <a:ln/>
+        </p:spPr>
+        <p:txBody>
+          <a:bodyPr wrap="square" lIns="0" tIns="0" rIns="0" bIns="0" rtlCol="0" anchor="ctr"/>
+          <a:lstStyle/>
+          <a:p>
+            <a:pPr indent="0" marL="0">
+              <a:buNone/>
+            </a:pPr>
+            <a:r>
+              <a:rPr lang="en-US" sz="1500" b="1" dirty="0">
                 <a:solidFill>
                   <a:schemeClr val="tx1"/>
                 </a:solidFill>
               </a:rPr>
-              <a:t>Ska vi fylla er kalender?</a:t>
-            </a:r>
-            <a:endParaRPr lang="en-US" sz="4200" dirty="0"/>
-          </a:p>
-        </p:txBody>
-      </p:sp>
-      <p:sp>
-        <p:nvSpPr>
-          <p:cNvPr id="6" name="Text 4"/>
+              <a:t>Din kalender</a:t>
+            </a:r>
+            <a:endParaRPr lang="en-US" sz="1500" dirty="0"/>
+          </a:p>
+        </p:txBody>
+      </p:sp>
+      <p:sp>
+        <p:nvSpPr>
+          <p:cNvPr id="18" name="Text 13"/>
           <p:cNvSpPr txBox="1"/>
           <p:nvPr/>
         </p:nvSpPr>
         <p:spPr>
           <a:xfrm>
-            <a:off x="548640" y="1874520"/>
-            <a:ext cx="8046720" cy="320040"/>
+            <a:off x="5806440" y="1325880"/>
+            <a:ext cx="2560320" cy="228600"/>
           </a:xfrm>
           <a:prstGeom prst="rect">
             <a:avLst/>
@@ -9373,35 +9436,301 @@
               <a:buNone/>
             </a:pPr>
             <a:r>
-              <a:rPr lang="en-US" sz="1500" dirty="0">
-                <a:solidFill>
-                  <a:schemeClr val="tx1"/>
-                </a:solidFill>
-              </a:rPr>
-              <a:t>Från ja till första bokade hembesöket:</a:t>
-            </a:r>
-            <a:endParaRPr lang="en-US" sz="1500" dirty="0"/>
-          </a:p>
-        </p:txBody>
-      </p:sp>
-      <p:sp>
-        <p:nvSpPr>
-          <p:cNvPr id="7" name="Steps line"/>
-          <p:cNvSpPr/>
-          <p:nvPr/>
-        </p:nvSpPr>
-        <p:spPr>
-          <a:xfrm>
-            <a:off x="777240" y="2697480"/>
-            <a:ext cx="6035040" cy="0"/>
-          </a:xfrm>
-          <a:prstGeom prst="line">
-            <a:avLst/>
-          </a:prstGeom>
-          <a:noFill/>
-          <a:ln w="19050">
+              <a:rPr lang="en-US" sz="1000" b="1" dirty="0">
+                <a:solidFill>
+                  <a:schemeClr val="accent1"/>
+                </a:solidFill>
+              </a:rPr>
+              <a:t>12 hembesök bokade denna månad</a:t>
+            </a:r>
+            <a:endParaRPr lang="en-US" sz="1000" dirty="0"/>
+          </a:p>
+        </p:txBody>
+      </p:sp>
+      <p:sp>
+        <p:nvSpPr>
+          <p:cNvPr id="19" name="Text 14"/>
+          <p:cNvSpPr txBox="1"/>
+          <p:nvPr/>
+        </p:nvSpPr>
+        <p:spPr>
+          <a:xfrm>
+            <a:off x="5806440" y="1645920"/>
+            <a:ext cx="512064" cy="201168"/>
+          </a:xfrm>
+          <a:prstGeom prst="rect">
+            <a:avLst/>
+          </a:prstGeom>
+          <a:noFill/>
+          <a:ln/>
+        </p:spPr>
+        <p:txBody>
+          <a:bodyPr wrap="square" lIns="0" tIns="0" rIns="0" bIns="0" rtlCol="0" anchor="ctr"/>
+          <a:lstStyle/>
+          <a:p>
+            <a:pPr algn="ctr" indent="0" marL="0">
+              <a:buNone/>
+            </a:pPr>
+            <a:r>
+              <a:rPr lang="en-US" sz="900" b="1" dirty="0">
+                <a:solidFill>
+                  <a:schemeClr val="accent3"/>
+                </a:solidFill>
+              </a:rPr>
+              <a:t>M</a:t>
+            </a:r>
+            <a:endParaRPr lang="en-US" sz="900" dirty="0"/>
+          </a:p>
+        </p:txBody>
+      </p:sp>
+      <p:sp>
+        <p:nvSpPr>
+          <p:cNvPr id="20" name="Text 15"/>
+          <p:cNvSpPr txBox="1"/>
+          <p:nvPr/>
+        </p:nvSpPr>
+        <p:spPr>
+          <a:xfrm>
+            <a:off x="6318504" y="1645920"/>
+            <a:ext cx="512064" cy="201168"/>
+          </a:xfrm>
+          <a:prstGeom prst="rect">
+            <a:avLst/>
+          </a:prstGeom>
+          <a:noFill/>
+          <a:ln/>
+        </p:spPr>
+        <p:txBody>
+          <a:bodyPr wrap="square" lIns="0" tIns="0" rIns="0" bIns="0" rtlCol="0" anchor="ctr"/>
+          <a:lstStyle/>
+          <a:p>
+            <a:pPr algn="ctr" indent="0" marL="0">
+              <a:buNone/>
+            </a:pPr>
+            <a:r>
+              <a:rPr lang="en-US" sz="900" b="1" dirty="0">
+                <a:solidFill>
+                  <a:schemeClr val="accent3"/>
+                </a:solidFill>
+              </a:rPr>
+              <a:t>T</a:t>
+            </a:r>
+            <a:endParaRPr lang="en-US" sz="900" dirty="0"/>
+          </a:p>
+        </p:txBody>
+      </p:sp>
+      <p:sp>
+        <p:nvSpPr>
+          <p:cNvPr id="21" name="Text 16"/>
+          <p:cNvSpPr txBox="1"/>
+          <p:nvPr/>
+        </p:nvSpPr>
+        <p:spPr>
+          <a:xfrm>
+            <a:off x="6830568" y="1645920"/>
+            <a:ext cx="512064" cy="201168"/>
+          </a:xfrm>
+          <a:prstGeom prst="rect">
+            <a:avLst/>
+          </a:prstGeom>
+          <a:noFill/>
+          <a:ln/>
+        </p:spPr>
+        <p:txBody>
+          <a:bodyPr wrap="square" lIns="0" tIns="0" rIns="0" bIns="0" rtlCol="0" anchor="ctr"/>
+          <a:lstStyle/>
+          <a:p>
+            <a:pPr algn="ctr" indent="0" marL="0">
+              <a:buNone/>
+            </a:pPr>
+            <a:r>
+              <a:rPr lang="en-US" sz="900" b="1" dirty="0">
+                <a:solidFill>
+                  <a:schemeClr val="accent3"/>
+                </a:solidFill>
+              </a:rPr>
+              <a:t>O</a:t>
+            </a:r>
+            <a:endParaRPr lang="en-US" sz="900" dirty="0"/>
+          </a:p>
+        </p:txBody>
+      </p:sp>
+      <p:sp>
+        <p:nvSpPr>
+          <p:cNvPr id="22" name="Text 17"/>
+          <p:cNvSpPr txBox="1"/>
+          <p:nvPr/>
+        </p:nvSpPr>
+        <p:spPr>
+          <a:xfrm>
+            <a:off x="7342632" y="1645920"/>
+            <a:ext cx="512064" cy="201168"/>
+          </a:xfrm>
+          <a:prstGeom prst="rect">
+            <a:avLst/>
+          </a:prstGeom>
+          <a:noFill/>
+          <a:ln/>
+        </p:spPr>
+        <p:txBody>
+          <a:bodyPr wrap="square" lIns="0" tIns="0" rIns="0" bIns="0" rtlCol="0" anchor="ctr"/>
+          <a:lstStyle/>
+          <a:p>
+            <a:pPr algn="ctr" indent="0" marL="0">
+              <a:buNone/>
+            </a:pPr>
+            <a:r>
+              <a:rPr lang="en-US" sz="900" b="1" dirty="0">
+                <a:solidFill>
+                  <a:schemeClr val="accent3"/>
+                </a:solidFill>
+              </a:rPr>
+              <a:t>T</a:t>
+            </a:r>
+            <a:endParaRPr lang="en-US" sz="900" dirty="0"/>
+          </a:p>
+        </p:txBody>
+      </p:sp>
+      <p:sp>
+        <p:nvSpPr>
+          <p:cNvPr id="23" name="Text 18"/>
+          <p:cNvSpPr txBox="1"/>
+          <p:nvPr/>
+        </p:nvSpPr>
+        <p:spPr>
+          <a:xfrm>
+            <a:off x="7854696" y="1645920"/>
+            <a:ext cx="512064" cy="201168"/>
+          </a:xfrm>
+          <a:prstGeom prst="rect">
+            <a:avLst/>
+          </a:prstGeom>
+          <a:noFill/>
+          <a:ln/>
+        </p:spPr>
+        <p:txBody>
+          <a:bodyPr wrap="square" lIns="0" tIns="0" rIns="0" bIns="0" rtlCol="0" anchor="ctr"/>
+          <a:lstStyle/>
+          <a:p>
+            <a:pPr algn="ctr" indent="0" marL="0">
+              <a:buNone/>
+            </a:pPr>
+            <a:r>
+              <a:rPr lang="en-US" sz="900" b="1" dirty="0">
+                <a:solidFill>
+                  <a:schemeClr val="accent3"/>
+                </a:solidFill>
+              </a:rPr>
+              <a:t>F</a:t>
+            </a:r>
+            <a:endParaRPr lang="en-US" sz="900" dirty="0"/>
+          </a:p>
+        </p:txBody>
+      </p:sp>
+      <p:sp>
+        <p:nvSpPr>
+          <p:cNvPr id="24" name="Day 1"/>
+          <p:cNvSpPr/>
+          <p:nvPr/>
+        </p:nvSpPr>
+        <p:spPr>
+          <a:xfrm>
+            <a:off x="5833872" y="1874520"/>
+            <a:ext cx="457200" cy="566928"/>
+          </a:xfrm>
+          <a:prstGeom prst="roundRect">
+            <a:avLst>
+              <a:gd name="adj" fmla="val 12000"/>
+            </a:avLst>
+          </a:prstGeom>
+          <a:solidFill>
+            <a:schemeClr val="accent1"/>
+          </a:solidFill>
+          <a:ln/>
+        </p:spPr>
+      </p:sp>
+      <p:sp>
+        <p:nvSpPr>
+          <p:cNvPr id="25" name="Text 20"/>
+          <p:cNvSpPr txBox="1"/>
+          <p:nvPr/>
+        </p:nvSpPr>
+        <p:spPr>
+          <a:xfrm>
+            <a:off x="5879592" y="1901952"/>
+            <a:ext cx="274320" cy="164592"/>
+          </a:xfrm>
+          <a:prstGeom prst="rect">
+            <a:avLst/>
+          </a:prstGeom>
+          <a:noFill/>
+          <a:ln/>
+        </p:spPr>
+        <p:txBody>
+          <a:bodyPr wrap="square" lIns="0" tIns="0" rIns="0" bIns="0" rtlCol="0" anchor="ctr"/>
+          <a:lstStyle/>
+          <a:p>
+            <a:pPr indent="0" marL="0">
+              <a:buNone/>
+            </a:pPr>
+            <a:r>
+              <a:rPr lang="en-US" sz="800" b="1" dirty="0">
+                <a:solidFill>
+                  <a:schemeClr val="bg1"/>
+                </a:solidFill>
+              </a:rPr>
+              <a:t>3</a:t>
+            </a:r>
+            <a:endParaRPr lang="en-US" sz="800" dirty="0"/>
+          </a:p>
+        </p:txBody>
+      </p:sp>
+      <p:pic>
+        <p:nvPicPr>
+          <p:cNvPr id="26" name="Image 3" descr="preencoded.png">    </p:cNvPr>
+          <p:cNvPicPr>
+            <a:picLocks noChangeAspect="1"/>
+          </p:cNvPicPr>
+          <p:nvPr/>
+        </p:nvPicPr>
+        <p:blipFill>
+          <a:blip r:embed="rId4"/>
+          <a:stretch>
+            <a:fillRect/>
+          </a:stretch>
+        </p:blipFill>
+        <p:spPr>
+          <a:xfrm>
+            <a:off x="5961888" y="2130552"/>
+            <a:ext cx="201168" cy="201168"/>
+          </a:xfrm>
+          <a:prstGeom prst="rect">
+            <a:avLst/>
+          </a:prstGeom>
+        </p:spPr>
+      </p:pic>
+      <p:sp>
+        <p:nvSpPr>
+          <p:cNvPr id="27" name="Day 2"/>
+          <p:cNvSpPr/>
+          <p:nvPr/>
+        </p:nvSpPr>
+        <p:spPr>
+          <a:xfrm>
+            <a:off x="6345936" y="1874520"/>
+            <a:ext cx="457200" cy="566928"/>
+          </a:xfrm>
+          <a:prstGeom prst="roundRect">
+            <a:avLst>
+              <a:gd name="adj" fmla="val 12000"/>
+            </a:avLst>
+          </a:prstGeom>
+          <a:solidFill>
+            <a:schemeClr val="bg1"/>
+          </a:solidFill>
+          <a:ln w="9525">
             <a:solidFill>
-              <a:schemeClr val="tx1"/>
+              <a:schemeClr val="accent5"/>
             </a:solidFill>
             <a:prstDash val="solid"/>
           </a:ln>
@@ -9409,34 +9738,72 @@
       </p:sp>
       <p:sp>
         <p:nvSpPr>
-          <p:cNvPr id="8" name="Step 1"/>
-          <p:cNvSpPr/>
-          <p:nvPr/>
-        </p:nvSpPr>
-        <p:spPr>
-          <a:xfrm>
-            <a:off x="548640" y="2468880"/>
-            <a:ext cx="457200" cy="457200"/>
-          </a:xfrm>
-          <a:prstGeom prst="ellipse">
-            <a:avLst/>
+          <p:cNvPr id="28" name="Text 22"/>
+          <p:cNvSpPr txBox="1"/>
+          <p:nvPr/>
+        </p:nvSpPr>
+        <p:spPr>
+          <a:xfrm>
+            <a:off x="6391656" y="1901952"/>
+            <a:ext cx="274320" cy="164592"/>
+          </a:xfrm>
+          <a:prstGeom prst="rect">
+            <a:avLst/>
+          </a:prstGeom>
+          <a:noFill/>
+          <a:ln/>
+        </p:spPr>
+        <p:txBody>
+          <a:bodyPr wrap="square" lIns="0" tIns="0" rIns="0" bIns="0" rtlCol="0" anchor="ctr"/>
+          <a:lstStyle/>
+          <a:p>
+            <a:pPr indent="0" marL="0">
+              <a:buNone/>
+            </a:pPr>
+            <a:r>
+              <a:rPr lang="en-US" sz="800" b="1" dirty="0">
+                <a:solidFill>
+                  <a:schemeClr val="accent3"/>
+                </a:solidFill>
+              </a:rPr>
+              <a:t>4</a:t>
+            </a:r>
+            <a:endParaRPr lang="en-US" sz="800" dirty="0"/>
+          </a:p>
+        </p:txBody>
+      </p:sp>
+      <p:sp>
+        <p:nvSpPr>
+          <p:cNvPr id="29" name="Day 3"/>
+          <p:cNvSpPr/>
+          <p:nvPr/>
+        </p:nvSpPr>
+        <p:spPr>
+          <a:xfrm>
+            <a:off x="6858000" y="1874520"/>
+            <a:ext cx="457200" cy="566928"/>
+          </a:xfrm>
+          <a:prstGeom prst="roundRect">
+            <a:avLst>
+              <a:gd name="adj" fmla="val 12000"/>
+            </a:avLst>
           </a:prstGeom>
           <a:solidFill>
-            <a:schemeClr val="tx1"/>
+            <a:schemeClr val="accent1"/>
           </a:solidFill>
           <a:ln/>
         </p:spPr>
       </p:sp>
       <p:sp>
         <p:nvSpPr>
-          <p:cNvPr id="9" name="Text 7"/>
+          <p:cNvPr id="30" name="Text 24"/>
           <p:cNvSpPr txBox="1"/>
           <p:nvPr/>
         </p:nvSpPr>
         <p:spPr>
           <a:xfrm>
-            <a:off x="548640" y="2468880"/>
-            <a:ext cx="457200" cy="457200"/>
+            <a:off x="6903720" y="1901952"/>
+            <a:ext cx="274320" cy="164592"/>
           </a:xfrm>
           <a:prstGeom prst="rect">
             <a:avLst/>
@@ -9448,31 +9815,77 @@
           <a:bodyPr wrap="square" lIns="0" tIns="0" rIns="0" bIns="0" rtlCol="0" anchor="ctr"/>
           <a:lstStyle/>
           <a:p>
-            <a:pPr algn="ctr" indent="0" marL="0">
-              <a:buNone/>
-            </a:pPr>
-            <a:r>
-              <a:rPr lang="en-US" sz="1600" b="1" dirty="0">
-                <a:solidFill>
-                  <a:schemeClr val="accent1"/>
-                </a:solidFill>
-              </a:rPr>
-              <a:t>1</a:t>
-            </a:r>
-            <a:endParaRPr lang="en-US" sz="1600" dirty="0"/>
-          </a:p>
-        </p:txBody>
-      </p:sp>
-      <p:sp>
-        <p:nvSpPr>
-          <p:cNvPr id="10" name="Text 8"/>
+            <a:pPr indent="0" marL="0">
+              <a:buNone/>
+            </a:pPr>
+            <a:r>
+              <a:rPr lang="en-US" sz="800" b="1" dirty="0">
+                <a:solidFill>
+                  <a:schemeClr val="bg1"/>
+                </a:solidFill>
+              </a:rPr>
+              <a:t>5</a:t>
+            </a:r>
+            <a:endParaRPr lang="en-US" sz="800" dirty="0"/>
+          </a:p>
+        </p:txBody>
+      </p:sp>
+      <p:pic>
+        <p:nvPicPr>
+          <p:cNvPr id="31" name="Image 4" descr="preencoded.png">    </p:cNvPr>
+          <p:cNvPicPr>
+            <a:picLocks noChangeAspect="1"/>
+          </p:cNvPicPr>
+          <p:nvPr/>
+        </p:nvPicPr>
+        <p:blipFill>
+          <a:blip r:embed="rId5"/>
+          <a:stretch>
+            <a:fillRect/>
+          </a:stretch>
+        </p:blipFill>
+        <p:spPr>
+          <a:xfrm>
+            <a:off x="6986016" y="2130552"/>
+            <a:ext cx="201168" cy="201168"/>
+          </a:xfrm>
+          <a:prstGeom prst="rect">
+            <a:avLst/>
+          </a:prstGeom>
+        </p:spPr>
+      </p:pic>
+      <p:sp>
+        <p:nvSpPr>
+          <p:cNvPr id="32" name="Day 4"/>
+          <p:cNvSpPr/>
+          <p:nvPr/>
+        </p:nvSpPr>
+        <p:spPr>
+          <a:xfrm>
+            <a:off x="7370064" y="1874520"/>
+            <a:ext cx="457200" cy="566928"/>
+          </a:xfrm>
+          <a:prstGeom prst="roundRect">
+            <a:avLst>
+              <a:gd name="adj" fmla="val 12000"/>
+            </a:avLst>
+          </a:prstGeom>
+          <a:solidFill>
+            <a:schemeClr val="accent1"/>
+          </a:solidFill>
+          <a:ln/>
+        </p:spPr>
+      </p:sp>
+      <p:sp>
+        <p:nvSpPr>
+          <p:cNvPr id="33" name="Text 26"/>
           <p:cNvSpPr txBox="1"/>
           <p:nvPr/>
         </p:nvSpPr>
         <p:spPr>
           <a:xfrm>
-            <a:off x="548640" y="3063240"/>
-            <a:ext cx="1828800" cy="320040"/>
+            <a:off x="7415784" y="1901952"/>
+            <a:ext cx="274320" cy="164592"/>
           </a:xfrm>
           <a:prstGeom prst="rect">
             <a:avLst/>
@@ -9488,83 +9901,141 @@
               <a:buNone/>
             </a:pPr>
             <a:r>
-              <a:rPr lang="en-US" sz="1600" b="1" dirty="0">
-                <a:solidFill>
-                  <a:schemeClr val="tx1"/>
-                </a:solidFill>
-              </a:rPr>
-              <a:t>Signera avtalet</a:t>
-            </a:r>
-            <a:endParaRPr lang="en-US" sz="1600" dirty="0"/>
-          </a:p>
-        </p:txBody>
-      </p:sp>
-      <p:sp>
-        <p:nvSpPr>
-          <p:cNvPr id="11" name="Text 9"/>
+              <a:rPr lang="en-US" sz="800" b="1" dirty="0">
+                <a:solidFill>
+                  <a:schemeClr val="bg1"/>
+                </a:solidFill>
+              </a:rPr>
+              <a:t>6</a:t>
+            </a:r>
+            <a:endParaRPr lang="en-US" sz="800" dirty="0"/>
+          </a:p>
+        </p:txBody>
+      </p:sp>
+      <p:pic>
+        <p:nvPicPr>
+          <p:cNvPr id="34" name="Image 5" descr="preencoded.png">    </p:cNvPr>
+          <p:cNvPicPr>
+            <a:picLocks noChangeAspect="1"/>
+          </p:cNvPicPr>
+          <p:nvPr/>
+        </p:nvPicPr>
+        <p:blipFill>
+          <a:blip r:embed="rId6"/>
+          <a:stretch>
+            <a:fillRect/>
+          </a:stretch>
+        </p:blipFill>
+        <p:spPr>
+          <a:xfrm>
+            <a:off x="7498080" y="2130552"/>
+            <a:ext cx="201168" cy="201168"/>
+          </a:xfrm>
+          <a:prstGeom prst="rect">
+            <a:avLst/>
+          </a:prstGeom>
+        </p:spPr>
+      </p:pic>
+      <p:sp>
+        <p:nvSpPr>
+          <p:cNvPr id="35" name="Day 5"/>
+          <p:cNvSpPr/>
+          <p:nvPr/>
+        </p:nvSpPr>
+        <p:spPr>
+          <a:xfrm>
+            <a:off x="7882128" y="1874520"/>
+            <a:ext cx="457200" cy="566928"/>
+          </a:xfrm>
+          <a:prstGeom prst="roundRect">
+            <a:avLst>
+              <a:gd name="adj" fmla="val 12000"/>
+            </a:avLst>
+          </a:prstGeom>
+          <a:solidFill>
+            <a:schemeClr val="bg1"/>
+          </a:solidFill>
+          <a:ln w="9525">
+            <a:solidFill>
+              <a:schemeClr val="accent5"/>
+            </a:solidFill>
+            <a:prstDash val="solid"/>
+          </a:ln>
+        </p:spPr>
+      </p:sp>
+      <p:sp>
+        <p:nvSpPr>
+          <p:cNvPr id="36" name="Text 28"/>
           <p:cNvSpPr txBox="1"/>
           <p:nvPr/>
         </p:nvSpPr>
         <p:spPr>
           <a:xfrm>
-            <a:off x="548640" y="3401568"/>
-            <a:ext cx="1783080" cy="640080"/>
-          </a:xfrm>
-          <a:prstGeom prst="rect">
-            <a:avLst/>
-          </a:prstGeom>
-          <a:noFill/>
-          <a:ln/>
-        </p:spPr>
-        <p:txBody>
-          <a:bodyPr wrap="square" lIns="0" tIns="0" rIns="0" bIns="0" rtlCol="0" anchor="t"/>
+            <a:off x="7927848" y="1901952"/>
+            <a:ext cx="274320" cy="164592"/>
+          </a:xfrm>
+          <a:prstGeom prst="rect">
+            <a:avLst/>
+          </a:prstGeom>
+          <a:noFill/>
+          <a:ln/>
+        </p:spPr>
+        <p:txBody>
+          <a:bodyPr wrap="square" lIns="0" tIns="0" rIns="0" bIns="0" rtlCol="0" anchor="ctr"/>
           <a:lstStyle/>
           <a:p>
             <a:pPr indent="0" marL="0">
               <a:buNone/>
             </a:pPr>
             <a:r>
-              <a:rPr lang="en-US" sz="1400" dirty="0">
-                <a:solidFill>
-                  <a:schemeClr val="tx2"/>
-                </a:solidFill>
-              </a:rPr>
-              <a:t>Digitalt via länk – direkt under mötet.</a:t>
-            </a:r>
-            <a:endParaRPr lang="en-US" sz="1400" dirty="0"/>
-          </a:p>
-        </p:txBody>
-      </p:sp>
-      <p:sp>
-        <p:nvSpPr>
-          <p:cNvPr id="12" name="Step 2"/>
-          <p:cNvSpPr/>
-          <p:nvPr/>
-        </p:nvSpPr>
-        <p:spPr>
-          <a:xfrm>
-            <a:off x="2560320" y="2468880"/>
-            <a:ext cx="457200" cy="457200"/>
-          </a:xfrm>
-          <a:prstGeom prst="ellipse">
-            <a:avLst/>
+              <a:rPr lang="en-US" sz="800" b="1" dirty="0">
+                <a:solidFill>
+                  <a:schemeClr val="accent3"/>
+                </a:solidFill>
+              </a:rPr>
+              <a:t>7</a:t>
+            </a:r>
+            <a:endParaRPr lang="en-US" sz="800" dirty="0"/>
+          </a:p>
+        </p:txBody>
+      </p:sp>
+      <p:sp>
+        <p:nvSpPr>
+          <p:cNvPr id="37" name="Day 6"/>
+          <p:cNvSpPr/>
+          <p:nvPr/>
+        </p:nvSpPr>
+        <p:spPr>
+          <a:xfrm>
+            <a:off x="5833872" y="2496312"/>
+            <a:ext cx="457200" cy="566928"/>
+          </a:xfrm>
+          <a:prstGeom prst="roundRect">
+            <a:avLst>
+              <a:gd name="adj" fmla="val 12000"/>
+            </a:avLst>
           </a:prstGeom>
           <a:solidFill>
-            <a:schemeClr val="tx1"/>
+            <a:schemeClr val="bg1"/>
           </a:solidFill>
-          <a:ln/>
-        </p:spPr>
-      </p:sp>
-      <p:sp>
-        <p:nvSpPr>
-          <p:cNvPr id="13" name="Text 11"/>
+          <a:ln w="9525">
+            <a:solidFill>
+              <a:schemeClr val="accent5"/>
+            </a:solidFill>
+            <a:prstDash val="solid"/>
+          </a:ln>
+        </p:spPr>
+      </p:sp>
+      <p:sp>
+        <p:nvSpPr>
+          <p:cNvPr id="38" name="Text 30"/>
           <p:cNvSpPr txBox="1"/>
           <p:nvPr/>
         </p:nvSpPr>
         <p:spPr>
           <a:xfrm>
-            <a:off x="2560320" y="2468880"/>
-            <a:ext cx="457200" cy="457200"/>
+            <a:off x="5879592" y="2523744"/>
+            <a:ext cx="274320" cy="164592"/>
           </a:xfrm>
           <a:prstGeom prst="rect">
             <a:avLst/>
@@ -9576,31 +10047,53 @@
           <a:bodyPr wrap="square" lIns="0" tIns="0" rIns="0" bIns="0" rtlCol="0" anchor="ctr"/>
           <a:lstStyle/>
           <a:p>
-            <a:pPr algn="ctr" indent="0" marL="0">
-              <a:buNone/>
-            </a:pPr>
-            <a:r>
-              <a:rPr lang="en-US" sz="1600" b="1" dirty="0">
-                <a:solidFill>
-                  <a:schemeClr val="accent1"/>
-                </a:solidFill>
-              </a:rPr>
-              <a:t>2</a:t>
-            </a:r>
-            <a:endParaRPr lang="en-US" sz="1600" dirty="0"/>
-          </a:p>
-        </p:txBody>
-      </p:sp>
-      <p:sp>
-        <p:nvSpPr>
-          <p:cNvPr id="14" name="Text 12"/>
+            <a:pPr indent="0" marL="0">
+              <a:buNone/>
+            </a:pPr>
+            <a:r>
+              <a:rPr lang="en-US" sz="800" b="1" dirty="0">
+                <a:solidFill>
+                  <a:schemeClr val="accent3"/>
+                </a:solidFill>
+              </a:rPr>
+              <a:t>8</a:t>
+            </a:r>
+            <a:endParaRPr lang="en-US" sz="800" dirty="0"/>
+          </a:p>
+        </p:txBody>
+      </p:sp>
+      <p:sp>
+        <p:nvSpPr>
+          <p:cNvPr id="39" name="Day 7"/>
+          <p:cNvSpPr/>
+          <p:nvPr/>
+        </p:nvSpPr>
+        <p:spPr>
+          <a:xfrm>
+            <a:off x="6345936" y="2496312"/>
+            <a:ext cx="457200" cy="566928"/>
+          </a:xfrm>
+          <a:prstGeom prst="roundRect">
+            <a:avLst>
+              <a:gd name="adj" fmla="val 12000"/>
+            </a:avLst>
+          </a:prstGeom>
+          <a:solidFill>
+            <a:schemeClr val="accent1"/>
+          </a:solidFill>
+          <a:ln/>
+        </p:spPr>
+      </p:sp>
+      <p:sp>
+        <p:nvSpPr>
+          <p:cNvPr id="40" name="Text 32"/>
           <p:cNvSpPr txBox="1"/>
           <p:nvPr/>
         </p:nvSpPr>
         <p:spPr>
           <a:xfrm>
-            <a:off x="2560320" y="3063240"/>
-            <a:ext cx="1828800" cy="320040"/>
+            <a:off x="6391656" y="2523744"/>
+            <a:ext cx="274320" cy="164592"/>
           </a:xfrm>
           <a:prstGeom prst="rect">
             <a:avLst/>
@@ -9616,83 +10109,136 @@
               <a:buNone/>
             </a:pPr>
             <a:r>
-              <a:rPr lang="en-US" sz="1600" b="1" dirty="0">
-                <a:solidFill>
-                  <a:schemeClr val="tx1"/>
-                </a:solidFill>
-              </a:rPr>
-              <a:t>Skicka material</a:t>
-            </a:r>
-            <a:endParaRPr lang="en-US" sz="1600" dirty="0"/>
-          </a:p>
-        </p:txBody>
-      </p:sp>
-      <p:sp>
-        <p:nvSpPr>
-          <p:cNvPr id="15" name="Text 13"/>
+              <a:rPr lang="en-US" sz="800" b="1" dirty="0">
+                <a:solidFill>
+                  <a:schemeClr val="bg1"/>
+                </a:solidFill>
+              </a:rPr>
+              <a:t>9</a:t>
+            </a:r>
+            <a:endParaRPr lang="en-US" sz="800" dirty="0"/>
+          </a:p>
+        </p:txBody>
+      </p:sp>
+      <p:pic>
+        <p:nvPicPr>
+          <p:cNvPr id="41" name="Image 6" descr="preencoded.png">    </p:cNvPr>
+          <p:cNvPicPr>
+            <a:picLocks noChangeAspect="1"/>
+          </p:cNvPicPr>
+          <p:nvPr/>
+        </p:nvPicPr>
+        <p:blipFill>
+          <a:blip r:embed="rId7"/>
+          <a:stretch>
+            <a:fillRect/>
+          </a:stretch>
+        </p:blipFill>
+        <p:spPr>
+          <a:xfrm>
+            <a:off x="6473952" y="2752344"/>
+            <a:ext cx="201168" cy="201168"/>
+          </a:xfrm>
+          <a:prstGeom prst="rect">
+            <a:avLst/>
+          </a:prstGeom>
+        </p:spPr>
+      </p:pic>
+      <p:sp>
+        <p:nvSpPr>
+          <p:cNvPr id="42" name="Day 8"/>
+          <p:cNvSpPr/>
+          <p:nvPr/>
+        </p:nvSpPr>
+        <p:spPr>
+          <a:xfrm>
+            <a:off x="6858000" y="2496312"/>
+            <a:ext cx="457200" cy="566928"/>
+          </a:xfrm>
+          <a:prstGeom prst="roundRect">
+            <a:avLst>
+              <a:gd name="adj" fmla="val 12000"/>
+            </a:avLst>
+          </a:prstGeom>
+          <a:solidFill>
+            <a:schemeClr val="bg1"/>
+          </a:solidFill>
+          <a:ln w="9525">
+            <a:solidFill>
+              <a:schemeClr val="accent5"/>
+            </a:solidFill>
+            <a:prstDash val="solid"/>
+          </a:ln>
+        </p:spPr>
+      </p:sp>
+      <p:sp>
+        <p:nvSpPr>
+          <p:cNvPr id="43" name="Text 34"/>
           <p:cNvSpPr txBox="1"/>
           <p:nvPr/>
         </p:nvSpPr>
         <p:spPr>
           <a:xfrm>
-            <a:off x="2560320" y="3401568"/>
-            <a:ext cx="1783080" cy="640080"/>
-          </a:xfrm>
-          <a:prstGeom prst="rect">
-            <a:avLst/>
-          </a:prstGeom>
-          <a:noFill/>
-          <a:ln/>
-        </p:spPr>
-        <p:txBody>
-          <a:bodyPr wrap="square" lIns="0" tIns="0" rIns="0" bIns="0" rtlCol="0" anchor="t"/>
+            <a:off x="6903720" y="2523744"/>
+            <a:ext cx="274320" cy="164592"/>
+          </a:xfrm>
+          <a:prstGeom prst="rect">
+            <a:avLst/>
+          </a:prstGeom>
+          <a:noFill/>
+          <a:ln/>
+        </p:spPr>
+        <p:txBody>
+          <a:bodyPr wrap="square" lIns="0" tIns="0" rIns="0" bIns="0" rtlCol="0" anchor="ctr"/>
           <a:lstStyle/>
           <a:p>
             <a:pPr indent="0" marL="0">
               <a:buNone/>
             </a:pPr>
             <a:r>
-              <a:rPr lang="en-US" sz="1400" dirty="0">
-                <a:solidFill>
-                  <a:schemeClr val="tx2"/>
-                </a:solidFill>
-              </a:rPr>
-              <a:t>Bilder och filmer från era jobb i en Google Drive-mapp.</a:t>
-            </a:r>
-            <a:endParaRPr lang="en-US" sz="1400" dirty="0"/>
-          </a:p>
-        </p:txBody>
-      </p:sp>
-      <p:sp>
-        <p:nvSpPr>
-          <p:cNvPr id="16" name="Step 3"/>
-          <p:cNvSpPr/>
-          <p:nvPr/>
-        </p:nvSpPr>
-        <p:spPr>
-          <a:xfrm>
-            <a:off x="4572000" y="2468880"/>
-            <a:ext cx="457200" cy="457200"/>
-          </a:xfrm>
-          <a:prstGeom prst="ellipse">
-            <a:avLst/>
+              <a:rPr lang="en-US" sz="800" b="1" dirty="0">
+                <a:solidFill>
+                  <a:schemeClr val="accent3"/>
+                </a:solidFill>
+              </a:rPr>
+              <a:t>10</a:t>
+            </a:r>
+            <a:endParaRPr lang="en-US" sz="800" dirty="0"/>
+          </a:p>
+        </p:txBody>
+      </p:sp>
+      <p:sp>
+        <p:nvSpPr>
+          <p:cNvPr id="44" name="Day 9"/>
+          <p:cNvSpPr/>
+          <p:nvPr/>
+        </p:nvSpPr>
+        <p:spPr>
+          <a:xfrm>
+            <a:off x="7370064" y="2496312"/>
+            <a:ext cx="457200" cy="566928"/>
+          </a:xfrm>
+          <a:prstGeom prst="roundRect">
+            <a:avLst>
+              <a:gd name="adj" fmla="val 12000"/>
+            </a:avLst>
           </a:prstGeom>
           <a:solidFill>
-            <a:schemeClr val="tx1"/>
+            <a:schemeClr val="accent1"/>
           </a:solidFill>
           <a:ln/>
         </p:spPr>
       </p:sp>
       <p:sp>
         <p:nvSpPr>
-          <p:cNvPr id="17" name="Text 15"/>
+          <p:cNvPr id="45" name="Text 36"/>
           <p:cNvSpPr txBox="1"/>
           <p:nvPr/>
         </p:nvSpPr>
         <p:spPr>
           <a:xfrm>
-            <a:off x="4572000" y="2468880"/>
-            <a:ext cx="457200" cy="457200"/>
+            <a:off x="7415784" y="2523744"/>
+            <a:ext cx="274320" cy="164592"/>
           </a:xfrm>
           <a:prstGeom prst="rect">
             <a:avLst/>
@@ -9704,31 +10250,77 @@
           <a:bodyPr wrap="square" lIns="0" tIns="0" rIns="0" bIns="0" rtlCol="0" anchor="ctr"/>
           <a:lstStyle/>
           <a:p>
-            <a:pPr algn="ctr" indent="0" marL="0">
-              <a:buNone/>
-            </a:pPr>
-            <a:r>
-              <a:rPr lang="en-US" sz="1600" b="1" dirty="0">
-                <a:solidFill>
-                  <a:schemeClr val="accent1"/>
-                </a:solidFill>
-              </a:rPr>
-              <a:t>3</a:t>
-            </a:r>
-            <a:endParaRPr lang="en-US" sz="1600" dirty="0"/>
-          </a:p>
-        </p:txBody>
-      </p:sp>
-      <p:sp>
-        <p:nvSpPr>
-          <p:cNvPr id="18" name="Text 16"/>
+            <a:pPr indent="0" marL="0">
+              <a:buNone/>
+            </a:pPr>
+            <a:r>
+              <a:rPr lang="en-US" sz="800" b="1" dirty="0">
+                <a:solidFill>
+                  <a:schemeClr val="bg1"/>
+                </a:solidFill>
+              </a:rPr>
+              <a:t>11</a:t>
+            </a:r>
+            <a:endParaRPr lang="en-US" sz="800" dirty="0"/>
+          </a:p>
+        </p:txBody>
+      </p:sp>
+      <p:pic>
+        <p:nvPicPr>
+          <p:cNvPr id="46" name="Image 7" descr="preencoded.png">    </p:cNvPr>
+          <p:cNvPicPr>
+            <a:picLocks noChangeAspect="1"/>
+          </p:cNvPicPr>
+          <p:nvPr/>
+        </p:nvPicPr>
+        <p:blipFill>
+          <a:blip r:embed="rId8"/>
+          <a:stretch>
+            <a:fillRect/>
+          </a:stretch>
+        </p:blipFill>
+        <p:spPr>
+          <a:xfrm>
+            <a:off x="7498080" y="2752344"/>
+            <a:ext cx="201168" cy="201168"/>
+          </a:xfrm>
+          <a:prstGeom prst="rect">
+            <a:avLst/>
+          </a:prstGeom>
+        </p:spPr>
+      </p:pic>
+      <p:sp>
+        <p:nvSpPr>
+          <p:cNvPr id="47" name="Day 10"/>
+          <p:cNvSpPr/>
+          <p:nvPr/>
+        </p:nvSpPr>
+        <p:spPr>
+          <a:xfrm>
+            <a:off x="7882128" y="2496312"/>
+            <a:ext cx="457200" cy="566928"/>
+          </a:xfrm>
+          <a:prstGeom prst="roundRect">
+            <a:avLst>
+              <a:gd name="adj" fmla="val 12000"/>
+            </a:avLst>
+          </a:prstGeom>
+          <a:solidFill>
+            <a:schemeClr val="accent1"/>
+          </a:solidFill>
+          <a:ln/>
+        </p:spPr>
+      </p:sp>
+      <p:sp>
+        <p:nvSpPr>
+          <p:cNvPr id="48" name="Text 38"/>
           <p:cNvSpPr txBox="1"/>
           <p:nvPr/>
         </p:nvSpPr>
         <p:spPr>
           <a:xfrm>
-            <a:off x="4572000" y="3063240"/>
-            <a:ext cx="1828800" cy="320040"/>
+            <a:off x="7927848" y="2523744"/>
+            <a:ext cx="274320" cy="164592"/>
           </a:xfrm>
           <a:prstGeom prst="rect">
             <a:avLst/>
@@ -9744,83 +10336,136 @@
               <a:buNone/>
             </a:pPr>
             <a:r>
-              <a:rPr lang="en-US" sz="1600" b="1" dirty="0">
-                <a:solidFill>
-                  <a:schemeClr val="tx1"/>
-                </a:solidFill>
-              </a:rPr>
-              <a:t>Produktion</a:t>
-            </a:r>
-            <a:endParaRPr lang="en-US" sz="1600" dirty="0"/>
-          </a:p>
-        </p:txBody>
-      </p:sp>
-      <p:sp>
-        <p:nvSpPr>
-          <p:cNvPr id="19" name="Text 17"/>
+              <a:rPr lang="en-US" sz="800" b="1" dirty="0">
+                <a:solidFill>
+                  <a:schemeClr val="bg1"/>
+                </a:solidFill>
+              </a:rPr>
+              <a:t>12</a:t>
+            </a:r>
+            <a:endParaRPr lang="en-US" sz="800" dirty="0"/>
+          </a:p>
+        </p:txBody>
+      </p:sp>
+      <p:pic>
+        <p:nvPicPr>
+          <p:cNvPr id="49" name="Image 8" descr="preencoded.png">    </p:cNvPr>
+          <p:cNvPicPr>
+            <a:picLocks noChangeAspect="1"/>
+          </p:cNvPicPr>
+          <p:nvPr/>
+        </p:nvPicPr>
+        <p:blipFill>
+          <a:blip r:embed="rId9"/>
+          <a:stretch>
+            <a:fillRect/>
+          </a:stretch>
+        </p:blipFill>
+        <p:spPr>
+          <a:xfrm>
+            <a:off x="8010144" y="2752344"/>
+            <a:ext cx="201168" cy="201168"/>
+          </a:xfrm>
+          <a:prstGeom prst="rect">
+            <a:avLst/>
+          </a:prstGeom>
+        </p:spPr>
+      </p:pic>
+      <p:sp>
+        <p:nvSpPr>
+          <p:cNvPr id="50" name="Day 11"/>
+          <p:cNvSpPr/>
+          <p:nvPr/>
+        </p:nvSpPr>
+        <p:spPr>
+          <a:xfrm>
+            <a:off x="5833872" y="3118104"/>
+            <a:ext cx="457200" cy="566928"/>
+          </a:xfrm>
+          <a:prstGeom prst="roundRect">
+            <a:avLst>
+              <a:gd name="adj" fmla="val 12000"/>
+            </a:avLst>
+          </a:prstGeom>
+          <a:solidFill>
+            <a:schemeClr val="bg1"/>
+          </a:solidFill>
+          <a:ln w="9525">
+            <a:solidFill>
+              <a:schemeClr val="accent5"/>
+            </a:solidFill>
+            <a:prstDash val="solid"/>
+          </a:ln>
+        </p:spPr>
+      </p:sp>
+      <p:sp>
+        <p:nvSpPr>
+          <p:cNvPr id="51" name="Text 40"/>
           <p:cNvSpPr txBox="1"/>
           <p:nvPr/>
         </p:nvSpPr>
         <p:spPr>
           <a:xfrm>
-            <a:off x="4572000" y="3401568"/>
-            <a:ext cx="1783080" cy="640080"/>
-          </a:xfrm>
-          <a:prstGeom prst="rect">
-            <a:avLst/>
-          </a:prstGeom>
-          <a:noFill/>
-          <a:ln/>
-        </p:spPr>
-        <p:txBody>
-          <a:bodyPr wrap="square" lIns="0" tIns="0" rIns="0" bIns="0" rtlCol="0" anchor="t"/>
+            <a:off x="5879592" y="3145536"/>
+            <a:ext cx="274320" cy="164592"/>
+          </a:xfrm>
+          <a:prstGeom prst="rect">
+            <a:avLst/>
+          </a:prstGeom>
+          <a:noFill/>
+          <a:ln/>
+        </p:spPr>
+        <p:txBody>
+          <a:bodyPr wrap="square" lIns="0" tIns="0" rIns="0" bIns="0" rtlCol="0" anchor="ctr"/>
           <a:lstStyle/>
           <a:p>
             <a:pPr indent="0" marL="0">
               <a:buNone/>
             </a:pPr>
             <a:r>
-              <a:rPr lang="en-US" sz="1400" dirty="0">
-                <a:solidFill>
-                  <a:schemeClr val="tx2"/>
-                </a:solidFill>
-              </a:rPr>
-              <a:t>Vi gör annonser och formulär. Kampanjen går live.</a:t>
-            </a:r>
-            <a:endParaRPr lang="en-US" sz="1400" dirty="0"/>
-          </a:p>
-        </p:txBody>
-      </p:sp>
-      <p:sp>
-        <p:nvSpPr>
-          <p:cNvPr id="20" name="Step 4"/>
-          <p:cNvSpPr/>
-          <p:nvPr/>
-        </p:nvSpPr>
-        <p:spPr>
-          <a:xfrm>
-            <a:off x="6583680" y="2468880"/>
-            <a:ext cx="457200" cy="457200"/>
-          </a:xfrm>
-          <a:prstGeom prst="ellipse">
-            <a:avLst/>
+              <a:rPr lang="en-US" sz="800" b="1" dirty="0">
+                <a:solidFill>
+                  <a:schemeClr val="accent3"/>
+                </a:solidFill>
+              </a:rPr>
+              <a:t>13</a:t>
+            </a:r>
+            <a:endParaRPr lang="en-US" sz="800" dirty="0"/>
+          </a:p>
+        </p:txBody>
+      </p:sp>
+      <p:sp>
+        <p:nvSpPr>
+          <p:cNvPr id="52" name="Day 12"/>
+          <p:cNvSpPr/>
+          <p:nvPr/>
+        </p:nvSpPr>
+        <p:spPr>
+          <a:xfrm>
+            <a:off x="6345936" y="3118104"/>
+            <a:ext cx="457200" cy="566928"/>
+          </a:xfrm>
+          <a:prstGeom prst="roundRect">
+            <a:avLst>
+              <a:gd name="adj" fmla="val 12000"/>
+            </a:avLst>
           </a:prstGeom>
           <a:solidFill>
-            <a:schemeClr val="tx1"/>
+            <a:schemeClr val="accent1"/>
           </a:solidFill>
           <a:ln/>
         </p:spPr>
       </p:sp>
       <p:sp>
         <p:nvSpPr>
-          <p:cNvPr id="21" name="Text 19"/>
+          <p:cNvPr id="53" name="Text 42"/>
           <p:cNvSpPr txBox="1"/>
           <p:nvPr/>
         </p:nvSpPr>
         <p:spPr>
           <a:xfrm>
-            <a:off x="6583680" y="2468880"/>
-            <a:ext cx="457200" cy="457200"/>
+            <a:off x="6391656" y="3145536"/>
+            <a:ext cx="274320" cy="164592"/>
           </a:xfrm>
           <a:prstGeom prst="rect">
             <a:avLst/>
@@ -9832,31 +10477,77 @@
           <a:bodyPr wrap="square" lIns="0" tIns="0" rIns="0" bIns="0" rtlCol="0" anchor="ctr"/>
           <a:lstStyle/>
           <a:p>
-            <a:pPr algn="ctr" indent="0" marL="0">
-              <a:buNone/>
-            </a:pPr>
-            <a:r>
-              <a:rPr lang="en-US" sz="1600" b="1" dirty="0">
-                <a:solidFill>
-                  <a:schemeClr val="accent1"/>
-                </a:solidFill>
-              </a:rPr>
-              <a:t>4</a:t>
-            </a:r>
-            <a:endParaRPr lang="en-US" sz="1600" dirty="0"/>
-          </a:p>
-        </p:txBody>
-      </p:sp>
-      <p:sp>
-        <p:nvSpPr>
-          <p:cNvPr id="22" name="Text 20"/>
+            <a:pPr indent="0" marL="0">
+              <a:buNone/>
+            </a:pPr>
+            <a:r>
+              <a:rPr lang="en-US" sz="800" b="1" dirty="0">
+                <a:solidFill>
+                  <a:schemeClr val="bg1"/>
+                </a:solidFill>
+              </a:rPr>
+              <a:t>14</a:t>
+            </a:r>
+            <a:endParaRPr lang="en-US" sz="800" dirty="0"/>
+          </a:p>
+        </p:txBody>
+      </p:sp>
+      <p:pic>
+        <p:nvPicPr>
+          <p:cNvPr id="54" name="Image 9" descr="preencoded.png">    </p:cNvPr>
+          <p:cNvPicPr>
+            <a:picLocks noChangeAspect="1"/>
+          </p:cNvPicPr>
+          <p:nvPr/>
+        </p:nvPicPr>
+        <p:blipFill>
+          <a:blip r:embed="rId10"/>
+          <a:stretch>
+            <a:fillRect/>
+          </a:stretch>
+        </p:blipFill>
+        <p:spPr>
+          <a:xfrm>
+            <a:off x="6473952" y="3374136"/>
+            <a:ext cx="201168" cy="201168"/>
+          </a:xfrm>
+          <a:prstGeom prst="rect">
+            <a:avLst/>
+          </a:prstGeom>
+        </p:spPr>
+      </p:pic>
+      <p:sp>
+        <p:nvSpPr>
+          <p:cNvPr id="55" name="Day 13"/>
+          <p:cNvSpPr/>
+          <p:nvPr/>
+        </p:nvSpPr>
+        <p:spPr>
+          <a:xfrm>
+            <a:off x="6858000" y="3118104"/>
+            <a:ext cx="457200" cy="566928"/>
+          </a:xfrm>
+          <a:prstGeom prst="roundRect">
+            <a:avLst>
+              <a:gd name="adj" fmla="val 12000"/>
+            </a:avLst>
+          </a:prstGeom>
+          <a:solidFill>
+            <a:schemeClr val="accent1"/>
+          </a:solidFill>
+          <a:ln/>
+        </p:spPr>
+      </p:sp>
+      <p:sp>
+        <p:nvSpPr>
+          <p:cNvPr id="56" name="Text 44"/>
           <p:cNvSpPr txBox="1"/>
           <p:nvPr/>
         </p:nvSpPr>
         <p:spPr>
           <a:xfrm>
-            <a:off x="6583680" y="3063240"/>
-            <a:ext cx="1828800" cy="320040"/>
+            <a:off x="6903720" y="3145536"/>
+            <a:ext cx="274320" cy="164592"/>
           </a:xfrm>
           <a:prstGeom prst="rect">
             <a:avLst/>
@@ -9872,63 +10563,136 @@
               <a:buNone/>
             </a:pPr>
             <a:r>
-              <a:rPr lang="en-US" sz="1600" b="1" dirty="0">
-                <a:solidFill>
-                  <a:schemeClr val="tx1"/>
-                </a:solidFill>
-              </a:rPr>
-              <a:t>Hembesök</a:t>
-            </a:r>
-            <a:endParaRPr lang="en-US" sz="1600" dirty="0"/>
-          </a:p>
-        </p:txBody>
-      </p:sp>
-      <p:sp>
-        <p:nvSpPr>
-          <p:cNvPr id="23" name="Text 21"/>
+              <a:rPr lang="en-US" sz="800" b="1" dirty="0">
+                <a:solidFill>
+                  <a:schemeClr val="bg1"/>
+                </a:solidFill>
+              </a:rPr>
+              <a:t>15</a:t>
+            </a:r>
+            <a:endParaRPr lang="en-US" sz="800" dirty="0"/>
+          </a:p>
+        </p:txBody>
+      </p:sp>
+      <p:pic>
+        <p:nvPicPr>
+          <p:cNvPr id="57" name="Image 10" descr="preencoded.png">    </p:cNvPr>
+          <p:cNvPicPr>
+            <a:picLocks noChangeAspect="1"/>
+          </p:cNvPicPr>
+          <p:nvPr/>
+        </p:nvPicPr>
+        <p:blipFill>
+          <a:blip r:embed="rId11"/>
+          <a:stretch>
+            <a:fillRect/>
+          </a:stretch>
+        </p:blipFill>
+        <p:spPr>
+          <a:xfrm>
+            <a:off x="6986016" y="3374136"/>
+            <a:ext cx="201168" cy="201168"/>
+          </a:xfrm>
+          <a:prstGeom prst="rect">
+            <a:avLst/>
+          </a:prstGeom>
+        </p:spPr>
+      </p:pic>
+      <p:sp>
+        <p:nvSpPr>
+          <p:cNvPr id="58" name="Day 14"/>
+          <p:cNvSpPr/>
+          <p:nvPr/>
+        </p:nvSpPr>
+        <p:spPr>
+          <a:xfrm>
+            <a:off x="7370064" y="3118104"/>
+            <a:ext cx="457200" cy="566928"/>
+          </a:xfrm>
+          <a:prstGeom prst="roundRect">
+            <a:avLst>
+              <a:gd name="adj" fmla="val 12000"/>
+            </a:avLst>
+          </a:prstGeom>
+          <a:solidFill>
+            <a:schemeClr val="bg1"/>
+          </a:solidFill>
+          <a:ln w="9525">
+            <a:solidFill>
+              <a:schemeClr val="accent5"/>
+            </a:solidFill>
+            <a:prstDash val="solid"/>
+          </a:ln>
+        </p:spPr>
+      </p:sp>
+      <p:sp>
+        <p:nvSpPr>
+          <p:cNvPr id="59" name="Text 46"/>
           <p:cNvSpPr txBox="1"/>
           <p:nvPr/>
         </p:nvSpPr>
         <p:spPr>
           <a:xfrm>
-            <a:off x="6583680" y="3401568"/>
-            <a:ext cx="1783080" cy="640080"/>
-          </a:xfrm>
-          <a:prstGeom prst="rect">
-            <a:avLst/>
-          </a:prstGeom>
-          <a:noFill/>
-          <a:ln/>
-        </p:spPr>
-        <p:txBody>
-          <a:bodyPr wrap="square" lIns="0" tIns="0" rIns="0" bIns="0" rtlCol="0" anchor="t"/>
+            <a:off x="7415784" y="3145536"/>
+            <a:ext cx="274320" cy="164592"/>
+          </a:xfrm>
+          <a:prstGeom prst="rect">
+            <a:avLst/>
+          </a:prstGeom>
+          <a:noFill/>
+          <a:ln/>
+        </p:spPr>
+        <p:txBody>
+          <a:bodyPr wrap="square" lIns="0" tIns="0" rIns="0" bIns="0" rtlCol="0" anchor="ctr"/>
           <a:lstStyle/>
           <a:p>
             <a:pPr indent="0" marL="0">
               <a:buNone/>
             </a:pPr>
             <a:r>
-              <a:rPr lang="en-US" sz="1400" dirty="0">
-                <a:solidFill>
-                  <a:schemeClr val="tx2"/>
-                </a:solidFill>
-              </a:rPr>
-              <a:t>De första kunderna bokas in i er kalender.</a:t>
-            </a:r>
-            <a:endParaRPr lang="en-US" sz="1400" dirty="0"/>
-          </a:p>
-        </p:txBody>
-      </p:sp>
-      <p:sp>
-        <p:nvSpPr>
-          <p:cNvPr id="24" name="Text 22"/>
+              <a:rPr lang="en-US" sz="800" b="1" dirty="0">
+                <a:solidFill>
+                  <a:schemeClr val="accent3"/>
+                </a:solidFill>
+              </a:rPr>
+              <a:t>16</a:t>
+            </a:r>
+            <a:endParaRPr lang="en-US" sz="800" dirty="0"/>
+          </a:p>
+        </p:txBody>
+      </p:sp>
+      <p:sp>
+        <p:nvSpPr>
+          <p:cNvPr id="60" name="Day 15"/>
+          <p:cNvSpPr/>
+          <p:nvPr/>
+        </p:nvSpPr>
+        <p:spPr>
+          <a:xfrm>
+            <a:off x="7882128" y="3118104"/>
+            <a:ext cx="457200" cy="566928"/>
+          </a:xfrm>
+          <a:prstGeom prst="roundRect">
+            <a:avLst>
+              <a:gd name="adj" fmla="val 12000"/>
+            </a:avLst>
+          </a:prstGeom>
+          <a:solidFill>
+            <a:schemeClr val="accent1"/>
+          </a:solidFill>
+          <a:ln/>
+        </p:spPr>
+      </p:sp>
+      <p:sp>
+        <p:nvSpPr>
+          <p:cNvPr id="61" name="Text 48"/>
           <p:cNvSpPr txBox="1"/>
           <p:nvPr/>
         </p:nvSpPr>
         <p:spPr>
           <a:xfrm>
-            <a:off x="548640" y="4572000"/>
-            <a:ext cx="2743200" cy="274320"/>
+            <a:off x="7927848" y="3145536"/>
+            <a:ext cx="274320" cy="164592"/>
           </a:xfrm>
           <a:prstGeom prst="rect">
             <a:avLst/>
@@ -9944,17 +10708,413 @@
               <a:buNone/>
             </a:pPr>
             <a:r>
-              <a:rPr lang="en-US" sz="1200" b="1" dirty="0">
-                <a:solidFill>
-                  <a:schemeClr val="tx1"/>
-                </a:solidFill>
-              </a:rPr>
-              <a:t>zdanmotion.se</a:t>
-            </a:r>
-            <a:endParaRPr lang="en-US" sz="1200" dirty="0"/>
-          </a:p>
-        </p:txBody>
-      </p:sp>
+              <a:rPr lang="en-US" sz="800" b="1" dirty="0">
+                <a:solidFill>
+                  <a:schemeClr val="bg1"/>
+                </a:solidFill>
+              </a:rPr>
+              <a:t>17</a:t>
+            </a:r>
+            <a:endParaRPr lang="en-US" sz="800" dirty="0"/>
+          </a:p>
+        </p:txBody>
+      </p:sp>
+      <p:pic>
+        <p:nvPicPr>
+          <p:cNvPr id="62" name="Image 11" descr="preencoded.png">    </p:cNvPr>
+          <p:cNvPicPr>
+            <a:picLocks noChangeAspect="1"/>
+          </p:cNvPicPr>
+          <p:nvPr/>
+        </p:nvPicPr>
+        <p:blipFill>
+          <a:blip r:embed="rId12"/>
+          <a:stretch>
+            <a:fillRect/>
+          </a:stretch>
+        </p:blipFill>
+        <p:spPr>
+          <a:xfrm>
+            <a:off x="8010144" y="3374136"/>
+            <a:ext cx="201168" cy="201168"/>
+          </a:xfrm>
+          <a:prstGeom prst="rect">
+            <a:avLst/>
+          </a:prstGeom>
+        </p:spPr>
+      </p:pic>
+      <p:sp>
+        <p:nvSpPr>
+          <p:cNvPr id="63" name="Day 16"/>
+          <p:cNvSpPr/>
+          <p:nvPr/>
+        </p:nvSpPr>
+        <p:spPr>
+          <a:xfrm>
+            <a:off x="5833872" y="3739896"/>
+            <a:ext cx="457200" cy="566928"/>
+          </a:xfrm>
+          <a:prstGeom prst="roundRect">
+            <a:avLst>
+              <a:gd name="adj" fmla="val 12000"/>
+            </a:avLst>
+          </a:prstGeom>
+          <a:solidFill>
+            <a:schemeClr val="bg1"/>
+          </a:solidFill>
+          <a:ln w="9525">
+            <a:solidFill>
+              <a:schemeClr val="accent5"/>
+            </a:solidFill>
+            <a:prstDash val="solid"/>
+          </a:ln>
+        </p:spPr>
+      </p:sp>
+      <p:sp>
+        <p:nvSpPr>
+          <p:cNvPr id="64" name="Text 50"/>
+          <p:cNvSpPr txBox="1"/>
+          <p:nvPr/>
+        </p:nvSpPr>
+        <p:spPr>
+          <a:xfrm>
+            <a:off x="5879592" y="3767328"/>
+            <a:ext cx="274320" cy="164592"/>
+          </a:xfrm>
+          <a:prstGeom prst="rect">
+            <a:avLst/>
+          </a:prstGeom>
+          <a:noFill/>
+          <a:ln/>
+        </p:spPr>
+        <p:txBody>
+          <a:bodyPr wrap="square" lIns="0" tIns="0" rIns="0" bIns="0" rtlCol="0" anchor="ctr"/>
+          <a:lstStyle/>
+          <a:p>
+            <a:pPr indent="0" marL="0">
+              <a:buNone/>
+            </a:pPr>
+            <a:r>
+              <a:rPr lang="en-US" sz="800" b="1" dirty="0">
+                <a:solidFill>
+                  <a:schemeClr val="accent3"/>
+                </a:solidFill>
+              </a:rPr>
+              <a:t>18</a:t>
+            </a:r>
+            <a:endParaRPr lang="en-US" sz="800" dirty="0"/>
+          </a:p>
+        </p:txBody>
+      </p:sp>
+      <p:sp>
+        <p:nvSpPr>
+          <p:cNvPr id="65" name="Day 17"/>
+          <p:cNvSpPr/>
+          <p:nvPr/>
+        </p:nvSpPr>
+        <p:spPr>
+          <a:xfrm>
+            <a:off x="6345936" y="3739896"/>
+            <a:ext cx="457200" cy="566928"/>
+          </a:xfrm>
+          <a:prstGeom prst="roundRect">
+            <a:avLst>
+              <a:gd name="adj" fmla="val 12000"/>
+            </a:avLst>
+          </a:prstGeom>
+          <a:solidFill>
+            <a:schemeClr val="accent1"/>
+          </a:solidFill>
+          <a:ln/>
+        </p:spPr>
+      </p:sp>
+      <p:sp>
+        <p:nvSpPr>
+          <p:cNvPr id="66" name="Text 52"/>
+          <p:cNvSpPr txBox="1"/>
+          <p:nvPr/>
+        </p:nvSpPr>
+        <p:spPr>
+          <a:xfrm>
+            <a:off x="6391656" y="3767328"/>
+            <a:ext cx="274320" cy="164592"/>
+          </a:xfrm>
+          <a:prstGeom prst="rect">
+            <a:avLst/>
+          </a:prstGeom>
+          <a:noFill/>
+          <a:ln/>
+        </p:spPr>
+        <p:txBody>
+          <a:bodyPr wrap="square" lIns="0" tIns="0" rIns="0" bIns="0" rtlCol="0" anchor="ctr"/>
+          <a:lstStyle/>
+          <a:p>
+            <a:pPr indent="0" marL="0">
+              <a:buNone/>
+            </a:pPr>
+            <a:r>
+              <a:rPr lang="en-US" sz="800" b="1" dirty="0">
+                <a:solidFill>
+                  <a:schemeClr val="bg1"/>
+                </a:solidFill>
+              </a:rPr>
+              <a:t>19</a:t>
+            </a:r>
+            <a:endParaRPr lang="en-US" sz="800" dirty="0"/>
+          </a:p>
+        </p:txBody>
+      </p:sp>
+      <p:pic>
+        <p:nvPicPr>
+          <p:cNvPr id="67" name="Image 12" descr="preencoded.png">    </p:cNvPr>
+          <p:cNvPicPr>
+            <a:picLocks noChangeAspect="1"/>
+          </p:cNvPicPr>
+          <p:nvPr/>
+        </p:nvPicPr>
+        <p:blipFill>
+          <a:blip r:embed="rId13"/>
+          <a:stretch>
+            <a:fillRect/>
+          </a:stretch>
+        </p:blipFill>
+        <p:spPr>
+          <a:xfrm>
+            <a:off x="6473952" y="3995928"/>
+            <a:ext cx="201168" cy="201168"/>
+          </a:xfrm>
+          <a:prstGeom prst="rect">
+            <a:avLst/>
+          </a:prstGeom>
+        </p:spPr>
+      </p:pic>
+      <p:sp>
+        <p:nvSpPr>
+          <p:cNvPr id="68" name="Day 18"/>
+          <p:cNvSpPr/>
+          <p:nvPr/>
+        </p:nvSpPr>
+        <p:spPr>
+          <a:xfrm>
+            <a:off x="6858000" y="3739896"/>
+            <a:ext cx="457200" cy="566928"/>
+          </a:xfrm>
+          <a:prstGeom prst="roundRect">
+            <a:avLst>
+              <a:gd name="adj" fmla="val 12000"/>
+            </a:avLst>
+          </a:prstGeom>
+          <a:solidFill>
+            <a:schemeClr val="accent1"/>
+          </a:solidFill>
+          <a:ln/>
+        </p:spPr>
+      </p:sp>
+      <p:sp>
+        <p:nvSpPr>
+          <p:cNvPr id="69" name="Text 54"/>
+          <p:cNvSpPr txBox="1"/>
+          <p:nvPr/>
+        </p:nvSpPr>
+        <p:spPr>
+          <a:xfrm>
+            <a:off x="6903720" y="3767328"/>
+            <a:ext cx="274320" cy="164592"/>
+          </a:xfrm>
+          <a:prstGeom prst="rect">
+            <a:avLst/>
+          </a:prstGeom>
+          <a:noFill/>
+          <a:ln/>
+        </p:spPr>
+        <p:txBody>
+          <a:bodyPr wrap="square" lIns="0" tIns="0" rIns="0" bIns="0" rtlCol="0" anchor="ctr"/>
+          <a:lstStyle/>
+          <a:p>
+            <a:pPr indent="0" marL="0">
+              <a:buNone/>
+            </a:pPr>
+            <a:r>
+              <a:rPr lang="en-US" sz="800" b="1" dirty="0">
+                <a:solidFill>
+                  <a:schemeClr val="bg1"/>
+                </a:solidFill>
+              </a:rPr>
+              <a:t>20</a:t>
+            </a:r>
+            <a:endParaRPr lang="en-US" sz="800" dirty="0"/>
+          </a:p>
+        </p:txBody>
+      </p:sp>
+      <p:pic>
+        <p:nvPicPr>
+          <p:cNvPr id="70" name="Image 13" descr="preencoded.png">    </p:cNvPr>
+          <p:cNvPicPr>
+            <a:picLocks noChangeAspect="1"/>
+          </p:cNvPicPr>
+          <p:nvPr/>
+        </p:nvPicPr>
+        <p:blipFill>
+          <a:blip r:embed="rId14"/>
+          <a:stretch>
+            <a:fillRect/>
+          </a:stretch>
+        </p:blipFill>
+        <p:spPr>
+          <a:xfrm>
+            <a:off x="6986016" y="3995928"/>
+            <a:ext cx="201168" cy="201168"/>
+          </a:xfrm>
+          <a:prstGeom prst="rect">
+            <a:avLst/>
+          </a:prstGeom>
+        </p:spPr>
+      </p:pic>
+      <p:sp>
+        <p:nvSpPr>
+          <p:cNvPr id="71" name="Day 19"/>
+          <p:cNvSpPr/>
+          <p:nvPr/>
+        </p:nvSpPr>
+        <p:spPr>
+          <a:xfrm>
+            <a:off x="7370064" y="3739896"/>
+            <a:ext cx="457200" cy="566928"/>
+          </a:xfrm>
+          <a:prstGeom prst="roundRect">
+            <a:avLst>
+              <a:gd name="adj" fmla="val 12000"/>
+            </a:avLst>
+          </a:prstGeom>
+          <a:solidFill>
+            <a:schemeClr val="bg1"/>
+          </a:solidFill>
+          <a:ln w="9525">
+            <a:solidFill>
+              <a:schemeClr val="accent5"/>
+            </a:solidFill>
+            <a:prstDash val="solid"/>
+          </a:ln>
+        </p:spPr>
+      </p:sp>
+      <p:sp>
+        <p:nvSpPr>
+          <p:cNvPr id="72" name="Text 56"/>
+          <p:cNvSpPr txBox="1"/>
+          <p:nvPr/>
+        </p:nvSpPr>
+        <p:spPr>
+          <a:xfrm>
+            <a:off x="7415784" y="3767328"/>
+            <a:ext cx="274320" cy="164592"/>
+          </a:xfrm>
+          <a:prstGeom prst="rect">
+            <a:avLst/>
+          </a:prstGeom>
+          <a:noFill/>
+          <a:ln/>
+        </p:spPr>
+        <p:txBody>
+          <a:bodyPr wrap="square" lIns="0" tIns="0" rIns="0" bIns="0" rtlCol="0" anchor="ctr"/>
+          <a:lstStyle/>
+          <a:p>
+            <a:pPr indent="0" marL="0">
+              <a:buNone/>
+            </a:pPr>
+            <a:r>
+              <a:rPr lang="en-US" sz="800" b="1" dirty="0">
+                <a:solidFill>
+                  <a:schemeClr val="accent3"/>
+                </a:solidFill>
+              </a:rPr>
+              <a:t>21</a:t>
+            </a:r>
+            <a:endParaRPr lang="en-US" sz="800" dirty="0"/>
+          </a:p>
+        </p:txBody>
+      </p:sp>
+      <p:sp>
+        <p:nvSpPr>
+          <p:cNvPr id="73" name="Day 20"/>
+          <p:cNvSpPr/>
+          <p:nvPr/>
+        </p:nvSpPr>
+        <p:spPr>
+          <a:xfrm>
+            <a:off x="7882128" y="3739896"/>
+            <a:ext cx="457200" cy="566928"/>
+          </a:xfrm>
+          <a:prstGeom prst="roundRect">
+            <a:avLst>
+              <a:gd name="adj" fmla="val 12000"/>
+            </a:avLst>
+          </a:prstGeom>
+          <a:solidFill>
+            <a:schemeClr val="accent1"/>
+          </a:solidFill>
+          <a:ln/>
+        </p:spPr>
+      </p:sp>
+      <p:sp>
+        <p:nvSpPr>
+          <p:cNvPr id="74" name="Text 58"/>
+          <p:cNvSpPr txBox="1"/>
+          <p:nvPr/>
+        </p:nvSpPr>
+        <p:spPr>
+          <a:xfrm>
+            <a:off x="7927848" y="3767328"/>
+            <a:ext cx="274320" cy="164592"/>
+          </a:xfrm>
+          <a:prstGeom prst="rect">
+            <a:avLst/>
+          </a:prstGeom>
+          <a:noFill/>
+          <a:ln/>
+        </p:spPr>
+        <p:txBody>
+          <a:bodyPr wrap="square" lIns="0" tIns="0" rIns="0" bIns="0" rtlCol="0" anchor="ctr"/>
+          <a:lstStyle/>
+          <a:p>
+            <a:pPr indent="0" marL="0">
+              <a:buNone/>
+            </a:pPr>
+            <a:r>
+              <a:rPr lang="en-US" sz="800" b="1" dirty="0">
+                <a:solidFill>
+                  <a:schemeClr val="bg1"/>
+                </a:solidFill>
+              </a:rPr>
+              <a:t>22</a:t>
+            </a:r>
+            <a:endParaRPr lang="en-US" sz="800" dirty="0"/>
+          </a:p>
+        </p:txBody>
+      </p:sp>
+      <p:pic>
+        <p:nvPicPr>
+          <p:cNvPr id="75" name="Image 14" descr="preencoded.png">    </p:cNvPr>
+          <p:cNvPicPr>
+            <a:picLocks noChangeAspect="1"/>
+          </p:cNvPicPr>
+          <p:nvPr/>
+        </p:nvPicPr>
+        <p:blipFill>
+          <a:blip r:embed="rId15"/>
+          <a:stretch>
+            <a:fillRect/>
+          </a:stretch>
+        </p:blipFill>
+        <p:spPr>
+          <a:xfrm>
+            <a:off x="8010144" y="3995928"/>
+            <a:ext cx="201168" cy="201168"/>
+          </a:xfrm>
+          <a:prstGeom prst="rect">
+            <a:avLst/>
+          </a:prstGeom>
+        </p:spPr>
+      </p:pic>
     </p:spTree>
   </p:cSld>
   <p:clrMapOvr>

</xml_diff>

<commit_message>
Remove moving playhead from slide 3
Co-Authored-By: Claude Opus 5.5 <noreply@anthropic.com>
Claude-Session: https://claude.ai/code/session_01QVCR3cV59zPQJ7dR5FS4zs
</commit_message>
<xml_diff>
--- a/zdanmotion-bygg-presentation-v2.pptx
+++ b/zdanmotion-bygg-presentation-v2.pptx
@@ -113,29 +113,29 @@
   <p:extLst>
     <p:ext uri="{521415D9-36F7-43E2-AB2F-B90AF26B5E84}">
       <p14:sectionLst xmlns:p14="http://schemas.microsoft.com/office/powerpoint/2010/main">
-        <p14:section name="Intro" id="{8a542d01-cf61-6a3e-0e8a-ca0dd1bb1bd1}">
+        <p14:section name="Intro" id="{12afcdae-a247-153f-8871-4ecd5f4ad802}">
           <p14:sldIdLst>
             <p14:sldId id="256"/>
           </p14:sldIdLst>
         </p14:section>
-        <p14:section name="Agenda" id="{2f0cd821-9dd1-ce8d-39f3-0f3834c6bf2f}">
+        <p14:section name="Agenda" id="{8c000e75-0050-ff09-b877-974710fbf479}">
           <p14:sldIdLst>
             <p14:sldId id="257"/>
           </p14:sldIdLst>
         </p14:section>
-        <p14:section name="Lösningen" id="{3134b6b4-f296-244b-8e88-22128762c653}">
+        <p14:section name="Lösningen" id="{706f246b-635f-09aa-ad59-6b88d8366073}">
           <p14:sldIdLst>
             <p14:sldId id="258"/>
             <p14:sldId id="259"/>
             <p14:sldId id="260"/>
           </p14:sldIdLst>
         </p14:section>
-        <p14:section name="Pris" id="{96ed1a88-501c-5a06-bf6c-77f27d76a03b}">
+        <p14:section name="Pris" id="{9f7a61bc-52db-cbc9-e056-7fe37fa5ead5}">
           <p14:sldIdLst>
             <p14:sldId id="261"/>
           </p14:sldIdLst>
         </p14:section>
-        <p14:section name="Nästa steg" id="{5f0cfbf8-71ff-4666-acda-3104e4d54bea}">
+        <p14:section name="Nästa steg" id="{d56abd54-4a2d-3122-9b6b-6807bbb064f2}">
           <p14:sldIdLst>
             <p14:sldId id="262"/>
           </p14:sldIdLst>
@@ -5679,49 +5679,6 @@
             </a:solidFill>
             <a:prstDash val="solid"/>
           </a:ln>
-        </p:spPr>
-      </p:sp>
-      <p:sp>
-        <p:nvSpPr>
-          <p:cNvPr id="45" name="Playhead"/>
-          <p:cNvSpPr/>
-          <p:nvPr/>
-        </p:nvSpPr>
-        <p:spPr>
-          <a:xfrm>
-            <a:off x="4572000" y="1645920"/>
-            <a:ext cx="0" cy="1188720"/>
-          </a:xfrm>
-          <a:prstGeom prst="line">
-            <a:avLst/>
-          </a:prstGeom>
-          <a:noFill/>
-          <a:ln w="19050">
-            <a:solidFill>
-              <a:schemeClr val="bg1"/>
-            </a:solidFill>
-            <a:prstDash val="solid"/>
-          </a:ln>
-        </p:spPr>
-      </p:sp>
-      <p:sp>
-        <p:nvSpPr>
-          <p:cNvPr id="46" name="Playhead head"/>
-          <p:cNvSpPr/>
-          <p:nvPr/>
-        </p:nvSpPr>
-        <p:spPr>
-          <a:xfrm rot="10800000">
-            <a:off x="4480560" y="1609344"/>
-            <a:ext cx="182880" cy="128016"/>
-          </a:xfrm>
-          <a:prstGeom prst="triangle">
-            <a:avLst/>
-          </a:prstGeom>
-          <a:solidFill>
-            <a:schemeClr val="bg1"/>
-          </a:solidFill>
-          <a:ln/>
         </p:spPr>
       </p:sp>
       <p:sp>

</xml_diff>